<commit_message>
docs: expand interview deck and simplify project explanations
</commit_message>
<xml_diff>
--- a/docs/slides/TencentGR_Interview_Deck_CN.pptx
+++ b/docs/slides/TencentGR_Interview_Deck_CN.pptx
@@ -2,15 +2,15 @@
 <file path=ppt/presentation.xml><?xml version="1.0" encoding="utf-8"?>
 <p:presentation xmlns:p="http://schemas.openxmlformats.org/presentationml/2006/main">
   <p:sldMasterIdLst>
-    <p:sldMasterId xmlns:r="http://schemas.openxmlformats.org/officeDocument/2006/relationships" id="2147483648" r:id="R1f94a44857f84045"/>
+    <p:sldMasterId xmlns:r="http://schemas.openxmlformats.org/officeDocument/2006/relationships" id="2147483648" r:id="R03c38021fa954e85"/>
   </p:sldMasterIdLst>
   <p:notesMasterIdLst>
-    <p:notesMasterId xmlns:r="http://schemas.openxmlformats.org/officeDocument/2006/relationships" r:id="Rf2b3e0d08bd443b9"/>
+    <p:notesMasterId xmlns:r="http://schemas.openxmlformats.org/officeDocument/2006/relationships" r:id="Rbcd843f347424eed"/>
   </p:notesMasterIdLst>
   <p:sldIdLst>
-    <p:sldId xmlns:r="http://schemas.openxmlformats.org/officeDocument/2006/relationships" id="256" r:id="R5ce53b0d88294d49"/>
-    <p:sldId xmlns:r="http://schemas.openxmlformats.org/officeDocument/2006/relationships" id="257" r:id="Re3f4646a75924b31"/>
-    <p:sldId xmlns:r="http://schemas.openxmlformats.org/officeDocument/2006/relationships" id="258" r:id="R45c840f7002a475e"/>
+    <p:sldId xmlns:r="http://schemas.openxmlformats.org/officeDocument/2006/relationships" id="256" r:id="R36daebc85a854339"/>
+    <p:sldId xmlns:r="http://schemas.openxmlformats.org/officeDocument/2006/relationships" id="257" r:id="R5829f0c6de954495"/>
+    <p:sldId xmlns:r="http://schemas.openxmlformats.org/officeDocument/2006/relationships" id="258" r:id="R563b1676a8cc4fc3"/>
   </p:sldIdLst>
   <p:sldSz cx="12192000" cy="6858000"/>
   <p:notesSz cx="6858000" cy="9144000"/>
@@ -444,7 +444,42 @@
           <a:lstStyle xmlns:a="http://schemas.openxmlformats.org/drawingml/2006/main"/>
           <a:p xmlns:a="http://schemas.openxmlformats.org/drawingml/2006/main">
             <a:r>
-              <a:t>第 1 页讲稿（约 55 秒）：这个项目的起点是 2025 腾讯广告算法大赛的 TencentGR-1M Baseline。数据规模是 100 万用户、478 万 Item 索引，官方评测候选约 66 万。原始代码给出了模型入口，但路径、设备和评测过程耦合较强，候选与 Item ID 还可能静默错位。我的第一步是先冻结证据口径：使用固定 seed 做用户划分，对验证用户保留最后一次点击，Query 只使用 Target 之前的历史；排除没有点击或 Target 不在候选池的用户后，得到 78,921 行固定评测人口。候选编码和 Query 编码之后用分块精确内积取 Top-10，避免 ANN 误差混入消融。代码、配置、预测、指标和哈希一起交付。</a:t>
+              <a:t>第 1 页｜建议 2 分钟。</a:t>
+            </a:r>
+          </a:p>
+          <a:p xmlns:a="http://schemas.openxmlformats.org/drawingml/2006/main">
+            <a:r>
+              <a:t>这个项目想解决一个直接的问题：看一个人过去的行为，预测他下一次会点什么。数据约有 100 万用户和 478 万个对象索引，但这一轮评测只在官方给定的 66 万候选里选择，这两个数量不能混用。</a:t>
+            </a:r>
+          </a:p>
+          <a:p xmlns:a="http://schemas.openxmlformats.org/drawingml/2006/main">
+            <a:r>
+              <a:t>我先把验证用户的最后一次点击留作答案。模型只能看到这次点击之前的记录，不能把答案或后来的记录提前放进去。固定划分得到 100,184 名验证用户，排除 1,745 名没有有效点击的用户，以及 19,518 名目标不在候选池中的用户，最后评测 78,921 人。</a:t>
+            </a:r>
+          </a:p>
+          <a:p xmlns:a="http://schemas.openxmlformats.org/drawingml/2006/main">
+            <a:r>
+              <a:t>模型分两边处理：用户侧用 HSTU 读历史，得到表示兴趣的数字向量；对象侧把 ID 和稀疏属性变成另一组向量。两组归一化向量做内积，得到匹配分数。评测时每批处理 128 个用户，和全部 66 万候选算分，只留下前 10 个，因此不需要一次存下所有用户与所有候选的完整分数矩阵。</a:t>
+            </a:r>
+          </a:p>
+          <a:p xmlns:a="http://schemas.openxmlformats.org/drawingml/2006/main">
+            <a:r>
+              <a:t>HR@10 问的是答案有没有进入前 10，NDCG@10 还会看答案排得有多靠前。8×512 模型的 HR@10 是 0.120817，可以近似理解成每 100 个评测用户，约 12 个用户的真实下一条出现在前 10。综合分按 0.31 和 0.69 加权，不是点击率，也不是线上业务指标。</a:t>
+            </a:r>
+          </a:p>
+          <a:p xmlns:a="http://schemas.openxmlformats.org/drawingml/2006/main">
+            <a:r>
+              <a:t>我的工作重点是训练复现、受控对照、SID 故障排查和结果核验。上游方法来自腾讯 Baseline 和 OnePiece，不把它们当成个人原创。</a:t>
+            </a:r>
+          </a:p>
+          <a:p xmlns:a="http://schemas.openxmlformats.org/drawingml/2006/main">
+            <a:r>
+              <a:t>转场：把数据和评分规则固定下来之后，再看换模型和扩大模型有没有帮助。</a:t>
+            </a:r>
+          </a:p>
+          <a:p xmlns:a="http://schemas.openxmlformats.org/drawingml/2006/main">
+            <a:r>
+              <a:t>精确规模：1,001,845 用户；4,783,154 个 Item 索引；660,000 候选；78,921 个评测用户。</a:t>
             </a:r>
           </a:p>
           <a:p xmlns:a="http://schemas.openxmlformats.org/drawingml/2006/main">
@@ -454,7 +489,27 @@
           </a:p>
           <a:p xmlns:a="http://schemas.openxmlformats.org/drawingml/2006/main">
             <a:r>
-              <a:t>来源：README_CN.md；docs/ARCHITECTURE_AND_EXPERIMENTS_CN.md；metrics/four_way_comparison.json。</a:t>
+              <a:t>证据来源（仓库相对路径）：</a:t>
+            </a:r>
+          </a:p>
+          <a:p xmlns:a="http://schemas.openxmlformats.org/drawingml/2006/main">
+            <a:r>
+              <a:t>docs/ONEPIECE_REPRODUCTION_CN.md</a:t>
+            </a:r>
+          </a:p>
+          <a:p xmlns:a="http://schemas.openxmlformats.org/drawingml/2006/main">
+            <a:r>
+              <a:t>docs/ONEPIECE_RESULTS.md</a:t>
+            </a:r>
+          </a:p>
+          <a:p xmlns:a="http://schemas.openxmlformats.org/drawingml/2006/main">
+            <a:r>
+              <a:t>docs/ONEPIECE_SCALING_RESULTS.md</a:t>
+            </a:r>
+          </a:p>
+          <a:p xmlns:a="http://schemas.openxmlformats.org/drawingml/2006/main">
+            <a:r>
+              <a:t>docs/ARCHITECTURE_AND_EXPERIMENTS_CN.md</a:t>
             </a:r>
           </a:p>
         </p:txBody>
@@ -524,7 +579,32 @@
           <a:lstStyle xmlns:a="http://schemas.openxmlformats.org/drawingml/2006/main"/>
           <a:p xmlns:a="http://schemas.openxmlformats.org/drawingml/2006/main">
             <a:r>
-              <a:t>第 2 页讲稿（约 55 秒）：模型侧我没有直接堆功能，而是先回答两个可区分的问题。第一个问题是编码器差异：保持 4×128、特征、Batch、Epoch、优化器、seed 和评测人口不变，只切换 HSTU 与因果 Transformer。HSTU 综合分 0.06634，Transformer 0.06373，点估计提高 4.10%。第二个问题是当前资源范围内的容量扩展。HSTU 从 4×128 到 8×256，再到 8×512，综合分依次为 0.06634、0.07608 和 0.08335；8×512 相对 4×128 提高 25.63%。这里同时增加了深度和宽度，所以我只把它解释为整体 capacity scaling，不拆成单独的深度或宽度贡献。两组结论仍只有一个训练 seed，图上的区间只描述固定评测人口。</a:t>
+              <a:t>第 2 页｜建议 2 分钟。</a:t>
+            </a:r>
+          </a:p>
+          <a:p xmlns:a="http://schemas.openxmlformats.org/drawingml/2006/main">
+            <a:r>
+              <a:t>这页先解释三个名词。HSTU 是读历史的序列模块，可以理解为给不同历史记录分配权重，再用一个门控控制保留的信息。InfoNCE 是训练要求：把真实下一条的分数拉高，让它高于同一批里其他对象的分数。LogQ 处理抽样偏差：热门对象在训练中更容易出现，所以按训练频率做校正。它不等于简单压低热门推荐，也不能直接宣称解决了公平性问题。</a:t>
+            </a:r>
+          </a:p>
+          <a:p xmlns:a="http://schemas.openxmlformats.org/drawingml/2006/main">
+            <a:r>
+              <a:t>我做了两类实验。第一类只换处理历史的模块，使用 4 层、128 维，其他特征、训练批大小 32、训练轮数 6、优化器和评测规则保持一致。Transformer 综合分 0.0637291，HSTU 0.0663408，相对提高 4.10%。这是固定训练 seed 下的架构对照结果。逐用户配对差值的 95% 区间为 [0.0017145,0.0035089]，只反映当前固定模型在这些用户上的差异，不反映多次训练的波动。</a:t>
+            </a:r>
+          </a:p>
+          <a:p xmlns:a="http://schemas.openxmlformats.org/drawingml/2006/main">
+            <a:r>
+              <a:t>第二类扩大 HSTU，分数从 4×128 的 0.0663408，到 8×256 的 0.0760805，再到 8×512 的 0.0833458。最大配置比最小配置提高 25.63%。这里同时加深和加宽，只能说扩大整体容量有效，不能说是哪一项单独贡献了提升。</a:t>
+            </a:r>
+          </a:p>
+          <a:p xmlns:a="http://schemas.openxmlformats.org/drawingml/2006/main">
+            <a:r>
+              <a:t>资源表也要一起看。HSTU 从 4×128 到 8×512，记录中的训练时间从 78.6 分钟增加到 180.8 分钟，显存峰值从 9.23 GiB 增加到 26.16 GiB。它说明效果和资源消耗一起增加；这些是对应实验运行记录，不是跨硬件的速度基准，也没有测成线上响应时间。</a:t>
+            </a:r>
+          </a:p>
+          <a:p xmlns:a="http://schemas.openxmlformats.org/drawingml/2006/main">
+            <a:r>
+              <a:t>转场：选定更强的 8×512 对照组以后，我继续检查增加语义 ID 辅助任务是否有收益。</a:t>
             </a:r>
           </a:p>
           <a:p xmlns:a="http://schemas.openxmlformats.org/drawingml/2006/main">
@@ -534,7 +614,32 @@
           </a:p>
           <a:p xmlns:a="http://schemas.openxmlformats.org/drawingml/2006/main">
             <a:r>
-              <a:t>来源：metrics/onepiece_architecture_comparison.json；metrics/onepiece_scaling_comparison.json；docs/ONEPIECE_RESULTS.md；docs/ONEPIECE_SCALING_RESULTS.md。</a:t>
+              <a:t>证据来源（仓库相对路径）：</a:t>
+            </a:r>
+          </a:p>
+          <a:p xmlns:a="http://schemas.openxmlformats.org/drawingml/2006/main">
+            <a:r>
+              <a:t>metrics/onepiece_architecture_comparison.json</a:t>
+            </a:r>
+          </a:p>
+          <a:p xmlns:a="http://schemas.openxmlformats.org/drawingml/2006/main">
+            <a:r>
+              <a:t>metrics/onepiece_scaling_comparison.json</a:t>
+            </a:r>
+          </a:p>
+          <a:p xmlns:a="http://schemas.openxmlformats.org/drawingml/2006/main">
+            <a:r>
+              <a:t>docs/ONEPIECE_RESULTS.md</a:t>
+            </a:r>
+          </a:p>
+          <a:p xmlns:a="http://schemas.openxmlformats.org/drawingml/2006/main">
+            <a:r>
+              <a:t>docs/ONEPIECE_SCALING_RESULTS.md</a:t>
+            </a:r>
+          </a:p>
+          <a:p xmlns:a="http://schemas.openxmlformats.org/drawingml/2006/main">
+            <a:r>
+              <a:t>docs/ONEPIECE_INTERVIEW_CN.md</a:t>
             </a:r>
           </a:p>
         </p:txBody>
@@ -604,7 +709,42 @@
           <a:lstStyle xmlns:a="http://schemas.openxmlformats.org/drawingml/2006/main"/>
           <a:p xmlns:a="http://schemas.openxmlformats.org/drawingml/2006/main">
             <a:r>
-              <a:t>第 3 页讲稿（约 70 秒）：第一轮在 8×512 HSTU 上加入两级 SID 辅助目标后，综合分从 0.08335 降到 0.07846，下降 5.87%。我没有把它写成 SID 无效，而是检查训练曲线和映射，发现 478 万 Item 中有 225 万发生 pair 碰撞，两个 SID 交叉熵还以等权方式直接加入主目标。修复时，我先用容量平衡重分配把 pair 碰撞降到 0，再给辅助损失增加首个 Epoch 线性 warm-up，并比较 0.02 和 0.05 两档权重。0.02 的综合分恢复到 0.08346，与无 SID 的差值只有 +0.14%，配对区间跨 0，所以最终结论是修复到持平。0.05 的 Beam 生成召回更好，但全候选排序略低，说明两个目标之间存在权衡。为了避免把评测处理误写成模型提升，我还用四个既有 checkpoint 补齐候选过滤和历史过滤的对齐重评。同一控制 checkpoint 变化 +2.61%，这是协议效应；掩码和 SID 的模型对照区间都跨 0。</a:t>
+              <a:t>第 3 页｜建议 2–3 分钟。</a:t>
+            </a:r>
+          </a:p>
+          <a:p xmlns:a="http://schemas.openxmlformats.org/drawingml/2006/main">
+            <a:r>
+              <a:t>SID 可以先理解成对象的一组短编号。这里从已经训练好的对象向量出发，用两级残差聚类，每级 4,096 个编码，把每个对象变成两个数字，再让模型额外学习预测这两个数字。主任务仍然是推荐下一条。</a:t>
+            </a:r>
+          </a:p>
+          <a:p xmlns:a="http://schemas.openxmlformats.org/drawingml/2006/main">
+            <a:r>
+              <a:t>第一轮出现了两个排查线索：4,783,154 个对象只有 2,533,113 个不同编号组合，相减得到 2,250,041 个重复占用；它不是两两冲突配对数。与此同时，两个辅助损失被等权加入，总损失从第 3 轮约 24.91 反弹到 42–44。排序综合分从无 SID 的 0.0833458 降到 0.0784571，相对下降 5.87%。这些现象提示编号和训练目标需要排查，但不能单独证明每一项造成了多少下降。</a:t>
+            </a:r>
+          </a:p>
+          <a:p xmlns:a="http://schemas.openxmlformats.org/drawingml/2006/main">
+            <a:r>
+              <a:t>我重新分配重复编号，把每个对象对应到不同的编号组合；再把辅助损失权重设为 0.02 或 0.05，并在第一个训练轮次从 0 线性升到目标权重，避免一开始就用完整强度加入辅助任务。两档新权重之间才是固定其余条件的对照；旧版和新版同时改变了多项。</a:t>
+            </a:r>
+          </a:p>
+          <a:p xmlns:a="http://schemas.openxmlformats.org/drawingml/2006/main">
+            <a:r>
+              <a:t>结果是 0.02 版综合分 0.0834596，约为图上的 0.08346，相对无 SID 高 0.14%；0.05 版为 0.0827533，相对低 0.71%。0.02 的逐用户配对 95% 差值区间是 [-0.0007888,0.0010164]，包含 0，所以准确说法是明显退化被修复、得分接近原水平，尚未证明额外收益。区间含 0 也不等于已经证明两者严格等价。</a:t>
+            </a:r>
+          </a:p>
+          <a:p xmlns:a="http://schemas.openxmlformats.org/drawingml/2006/main">
+            <a:r>
+              <a:t>我还用同一个已保存模型更换评测过滤规则，分数从 0.0833458 变成 0.0855212，高了 2.61%。没有重新训练模型，所以这部分来自候选池和历史过滤的变化，不能计入模型优化收益。</a:t>
+            </a:r>
+          </a:p>
+          <a:p xmlns:a="http://schemas.openxmlformats.org/drawingml/2006/main">
+            <a:r>
+              <a:t>这个项目让我积累的核心经验是：先把实验条件和输出核对清楚，再解释数字。下一步优先做多个训练 seed，并分别检验编号、权重和预热的独立影响。</a:t>
+            </a:r>
+          </a:p>
+          <a:p xmlns:a="http://schemas.openxmlformats.org/drawingml/2006/main">
+            <a:r>
+              <a:t>实现边界：零碰撞映射使用全局 residual 近似，存在跨 L1 重分配；不声称严格复现上游层级 SID，映射生成脚本当前不在公开仓库。</a:t>
             </a:r>
           </a:p>
           <a:p xmlns:a="http://schemas.openxmlformats.org/drawingml/2006/main">
@@ -614,7 +754,27 @@
           </a:p>
           <a:p xmlns:a="http://schemas.openxmlformats.org/drawingml/2006/main">
             <a:r>
-              <a:t>来源：metrics/onepiece_alignment_comparison.json；metrics/onepiece_followup_comparison.json；docs/ONEPIECE_SID_RESULTS.md；docs/ONEPIECE_ALIGNMENT_RESULTS.md。</a:t>
+              <a:t>证据来源（仓库相对路径）：</a:t>
+            </a:r>
+          </a:p>
+          <a:p xmlns:a="http://schemas.openxmlformats.org/drawingml/2006/main">
+            <a:r>
+              <a:t>metrics/onepiece_alignment_comparison.json</a:t>
+            </a:r>
+          </a:p>
+          <a:p xmlns:a="http://schemas.openxmlformats.org/drawingml/2006/main">
+            <a:r>
+              <a:t>metrics/onepiece_followup_comparison.json</a:t>
+            </a:r>
+          </a:p>
+          <a:p xmlns:a="http://schemas.openxmlformats.org/drawingml/2006/main">
+            <a:r>
+              <a:t>docs/ONEPIECE_SID_RESULTS.md</a:t>
+            </a:r>
+          </a:p>
+          <a:p xmlns:a="http://schemas.openxmlformats.org/drawingml/2006/main">
+            <a:r>
+              <a:t>docs/ONEPIECE_ALIGNMENT_RESULTS.md</a:t>
             </a:r>
           </a:p>
         </p:txBody>
@@ -682,7 +842,7 @@
   </p:cSld>
   <p:clrMap bg1="lt1" tx1="dk1" bg2="lt2" tx2="dk2" accent1="accent1" accent2="accent2" accent3="accent3" accent4="accent4" accent5="accent5" accent6="accent6" hlink="hlink" folHlink="folHlink"/>
   <p:sldLayoutIdLst>
-    <p:sldLayoutId xmlns:r="http://schemas.openxmlformats.org/officeDocument/2006/relationships" id="2147483649" r:id="R8696e1cf569c4a57"/>
+    <p:sldLayoutId xmlns:r="http://schemas.openxmlformats.org/officeDocument/2006/relationships" id="2147483649" r:id="R24021969debf46de"/>
   </p:sldLayoutIdLst>
   <p:txStyles>
     <p:titleStyle>
@@ -1313,7 +1473,7 @@
             <a:lstStyle xmlns:a="http://schemas.openxmlformats.org/drawingml/2006/main"/>
             <a:p xmlns:a="http://schemas.openxmlformats.org/drawingml/2006/main">
               <a:pPr>
-                <a:defRPr sz="1200" b="1">
+                <a:defRPr sz="1425" b="1">
                   <a:solidFill>
                     <a:srgbClr val="17212B"/>
                   </a:solidFill>
@@ -1360,7 +1520,7 @@
           <a:lstStyle xmlns:a="http://schemas.openxmlformats.org/drawingml/2006/main"/>
           <a:p xmlns:a="http://schemas.openxmlformats.org/drawingml/2006/main">
             <a:pPr>
-              <a:defRPr sz="1200" b="1">
+              <a:defRPr sz="1425" b="1">
                 <a:solidFill>
                   <a:srgbClr val="17212B"/>
                 </a:solidFill>
@@ -1408,7 +1568,7 @@
           <a:lstStyle xmlns:a="http://schemas.openxmlformats.org/drawingml/2006/main"/>
           <a:p xmlns:a="http://schemas.openxmlformats.org/drawingml/2006/main">
             <a:pPr>
-              <a:defRPr sz="1050">
+              <a:defRPr sz="1275">
                 <a:solidFill>
                   <a:srgbClr val="5C6670"/>
                 </a:solidFill>
@@ -1421,7 +1581,7 @@
         </c:txPr>
         <c:crossAx val="48650112"/>
         <c:crossBetween val="between"/>
-        <c:majorUnit val="0.02"/>
+        <c:majorUnit val="0.03"/>
       </c:valAx>
       <c:spPr>
         <a:solidFill xmlns:a="http://schemas.openxmlformats.org/drawingml/2006/main">
@@ -1555,7 +1715,7 @@
             <a:lstStyle xmlns:a="http://schemas.openxmlformats.org/drawingml/2006/main"/>
             <a:p xmlns:a="http://schemas.openxmlformats.org/drawingml/2006/main">
               <a:pPr>
-                <a:defRPr sz="1125" b="1">
+                <a:defRPr sz="1500" b="1">
                   <a:solidFill>
                     <a:srgbClr val="17212B"/>
                   </a:solidFill>
@@ -1602,7 +1762,7 @@
           <a:lstStyle xmlns:a="http://schemas.openxmlformats.org/drawingml/2006/main"/>
           <a:p xmlns:a="http://schemas.openxmlformats.org/drawingml/2006/main">
             <a:pPr>
-              <a:defRPr sz="1125" b="1">
+              <a:defRPr sz="1575" b="1">
                 <a:solidFill>
                   <a:srgbClr val="17212B"/>
                 </a:solidFill>
@@ -1650,7 +1810,7 @@
           <a:lstStyle xmlns:a="http://schemas.openxmlformats.org/drawingml/2006/main"/>
           <a:p xmlns:a="http://schemas.openxmlformats.org/drawingml/2006/main">
             <a:pPr>
-              <a:defRPr sz="975">
+              <a:defRPr sz="1275">
                 <a:solidFill>
                   <a:srgbClr val="5C6670"/>
                 </a:solidFill>
@@ -1711,10 +1871,10 @@
       </p:grpSpPr>
       <p:sp>
         <p:nvSpPr>
-          <p:cNvPr id="22" name="">
+          <p:cNvPr id="26" name="">
             <a:extLst xmlns:a="http://schemas.openxmlformats.org/drawingml/2006/main">
               <a:ext uri="{FF2B5EF4-FFF2-40B4-BE49-F238E27FC236}">
-                <a16:creationId xmlns:a16="http://schemas.microsoft.com/office/drawing/2014/main" id="{DE39803B-0287-42AE-90A0-756ADDFF7D17}"/>
+                <a16:creationId xmlns:a16="http://schemas.microsoft.com/office/drawing/2014/main" id="{944D1829-2DED-4094-B52A-D8085A7F9B1C}"/>
               </a:ext>
             </a:extLst>
           </p:cNvPr>
@@ -1725,8 +1885,8 @@
         </p:nvSpPr>
         <p:spPr>
           <a:xfrm xmlns:a="http://schemas.openxmlformats.org/drawingml/2006/main">
-            <a:off x="11353800" y="438150"/>
-            <a:ext cx="400050" cy="266700"/>
+            <a:off x="514350" y="304800"/>
+            <a:ext cx="10572750" cy="590550"/>
           </a:xfrm>
           <a:prstGeom xmlns:a="http://schemas.openxmlformats.org/drawingml/2006/main" prst="rect">
             <a:avLst/>
@@ -1738,30 +1898,30 @@
         </p:spPr>
         <p:txBody>
           <a:bodyPr xmlns:a="http://schemas.openxmlformats.org/drawingml/2006/main" anchor="ctr">
-            <a:normAutofit fontScale="95833"/>
+            <a:noAutofit/>
           </a:bodyPr>
           <a:lstStyle xmlns:a="http://schemas.openxmlformats.org/drawingml/2006/main"/>
           <a:p xmlns:a="http://schemas.openxmlformats.org/drawingml/2006/main">
-            <a:pPr algn="r">
-              <a:defRPr sz="1200" b="0">
-                <a:solidFill>
-                  <a:srgbClr val="5C6670"/>
-                </a:solidFill>
-                <a:latin typeface="Microsoft YaHei"/>
-                <a:ea typeface="Microsoft YaHei"/>
-                <a:cs typeface="Microsoft YaHei"/>
-              </a:defRPr>
-            </a:pPr>
-            <a:r>
-              <a:rPr sz="1200" b="0">
-                <a:solidFill>
-                  <a:srgbClr val="5C6670"/>
-                </a:solidFill>
-                <a:latin typeface="Microsoft YaHei"/>
-                <a:ea typeface="Microsoft YaHei"/>
-                <a:cs typeface="Microsoft YaHei"/>
-              </a:rPr>
-              <a:t>01</a:t>
+            <a:pPr algn="l">
+              <a:defRPr sz="3150" b="1">
+                <a:solidFill>
+                  <a:srgbClr val="17212B"/>
+                </a:solidFill>
+                <a:latin typeface="Microsoft YaHei"/>
+                <a:ea typeface="Microsoft YaHei"/>
+                <a:cs typeface="Microsoft YaHei"/>
+              </a:defRPr>
+            </a:pPr>
+            <a:r>
+              <a:rPr sz="3150" b="1">
+                <a:solidFill>
+                  <a:srgbClr val="17212B"/>
+                </a:solidFill>
+                <a:latin typeface="Microsoft YaHei"/>
+                <a:ea typeface="Microsoft YaHei"/>
+                <a:cs typeface="Microsoft YaHei"/>
+              </a:rPr>
+              <a:t>TencentGR-1M：用过去的行为推荐下一条</a:t>
             </a:r>
           </a:p>
         </p:txBody>
@@ -1771,7 +1931,7 @@
           <p:cNvPr id="2" name="">
             <a:extLst xmlns:a="http://schemas.openxmlformats.org/drawingml/2006/main">
               <a:ext uri="{FF2B5EF4-FFF2-40B4-BE49-F238E27FC236}">
-                <a16:creationId xmlns:a16="http://schemas.microsoft.com/office/drawing/2014/main" id="{84E720BB-72B8-40B5-9613-059DB43274DE}"/>
+                <a16:creationId xmlns:a16="http://schemas.microsoft.com/office/drawing/2014/main" id="{2B19C5A1-D3C2-4549-9634-5AA2410763C0}"/>
               </a:ext>
             </a:extLst>
           </p:cNvPr>
@@ -1782,8 +1942,8 @@
         </p:nvSpPr>
         <p:spPr>
           <a:xfrm xmlns:a="http://schemas.openxmlformats.org/drawingml/2006/main">
-            <a:off x="609600" y="400050"/>
-            <a:ext cx="9810750" cy="590550"/>
+            <a:off x="542925" y="952500"/>
+            <a:ext cx="11106150" cy="381000"/>
           </a:xfrm>
           <a:prstGeom xmlns:a="http://schemas.openxmlformats.org/drawingml/2006/main" prst="rect">
             <a:avLst/>
@@ -1795,30 +1955,30 @@
         </p:spPr>
         <p:txBody>
           <a:bodyPr xmlns:a="http://schemas.openxmlformats.org/drawingml/2006/main" anchor="ctr">
-            <a:normAutofit fontScale="90972"/>
+            <a:noAutofit/>
           </a:bodyPr>
           <a:lstStyle xmlns:a="http://schemas.openxmlformats.org/drawingml/2006/main"/>
           <a:p xmlns:a="http://schemas.openxmlformats.org/drawingml/2006/main">
             <a:pPr algn="l">
-              <a:defRPr sz="3600" b="1">
-                <a:solidFill>
-                  <a:srgbClr val="17212B"/>
-                </a:solidFill>
-                <a:latin typeface="Microsoft YaHei"/>
-                <a:ea typeface="Microsoft YaHei"/>
-                <a:cs typeface="Microsoft YaHei"/>
-              </a:defRPr>
-            </a:pPr>
-            <a:r>
-              <a:rPr sz="3600" b="1">
-                <a:solidFill>
-                  <a:srgbClr val="17212B"/>
-                </a:solidFill>
-                <a:latin typeface="Microsoft YaHei"/>
-                <a:ea typeface="Microsoft YaHei"/>
-                <a:cs typeface="Microsoft YaHei"/>
-              </a:rPr>
-              <a:t>TencentGR-1M 生成式推荐复现</a:t>
+              <a:defRPr sz="1650" b="0">
+                <a:solidFill>
+                  <a:srgbClr val="5C6670"/>
+                </a:solidFill>
+                <a:latin typeface="Microsoft YaHei"/>
+                <a:ea typeface="Microsoft YaHei"/>
+                <a:cs typeface="Microsoft YaHei"/>
+              </a:defRPr>
+            </a:pPr>
+            <a:r>
+              <a:rPr sz="1650" b="0">
+                <a:solidFill>
+                  <a:srgbClr val="5C6670"/>
+                </a:solidFill>
+                <a:latin typeface="Microsoft YaHei"/>
+                <a:ea typeface="Microsoft YaHei"/>
+                <a:cs typeface="Microsoft YaHei"/>
+              </a:rPr>
+              <a:t>任务与评测｜输入用户历史，给候选对象打分，输出最可能被点击的前 10 个。</a:t>
             </a:r>
           </a:p>
         </p:txBody>
@@ -1828,7 +1988,7 @@
           <p:cNvPr id="3" name="">
             <a:extLst xmlns:a="http://schemas.openxmlformats.org/drawingml/2006/main">
               <a:ext uri="{FF2B5EF4-FFF2-40B4-BE49-F238E27FC236}">
-                <a16:creationId xmlns:a16="http://schemas.microsoft.com/office/drawing/2014/main" id="{AE176B54-32EA-44BC-B03E-1B31FF4B9891}"/>
+                <a16:creationId xmlns:a16="http://schemas.microsoft.com/office/drawing/2014/main" id="{BE65B688-DB15-455E-AC23-90A4D027822B}"/>
               </a:ext>
             </a:extLst>
           </p:cNvPr>
@@ -1839,8 +1999,8 @@
         </p:nvSpPr>
         <p:spPr>
           <a:xfrm xmlns:a="http://schemas.openxmlformats.org/drawingml/2006/main">
-            <a:off x="628650" y="1028700"/>
-            <a:ext cx="9810750" cy="361950"/>
+            <a:off x="11334750" y="409575"/>
+            <a:ext cx="361950" cy="266700"/>
           </a:xfrm>
           <a:prstGeom xmlns:a="http://schemas.openxmlformats.org/drawingml/2006/main" prst="rect">
             <a:avLst/>
@@ -1852,30 +2012,30 @@
         </p:spPr>
         <p:txBody>
           <a:bodyPr xmlns:a="http://schemas.openxmlformats.org/drawingml/2006/main" anchor="ctr">
-            <a:normAutofit fontScale="98611"/>
+            <a:noAutofit/>
           </a:bodyPr>
           <a:lstStyle xmlns:a="http://schemas.openxmlformats.org/drawingml/2006/main"/>
           <a:p xmlns:a="http://schemas.openxmlformats.org/drawingml/2006/main">
-            <a:pPr algn="l">
-              <a:defRPr sz="1800" b="0">
-                <a:solidFill>
-                  <a:srgbClr val="008A83"/>
-                </a:solidFill>
-                <a:latin typeface="Microsoft YaHei"/>
-                <a:ea typeface="Microsoft YaHei"/>
-                <a:cs typeface="Microsoft YaHei"/>
-              </a:defRPr>
-            </a:pPr>
-            <a:r>
-              <a:rPr sz="1800" b="0">
-                <a:solidFill>
-                  <a:srgbClr val="008A83"/>
-                </a:solidFill>
-                <a:latin typeface="Microsoft YaHei"/>
-                <a:ea typeface="Microsoft YaHei"/>
-                <a:cs typeface="Microsoft YaHei"/>
-              </a:rPr>
-              <a:t>把比赛 Baseline 整理为可审计、可复算、可发布的实验系统</a:t>
+            <a:pPr algn="r">
+              <a:defRPr sz="1200" b="0">
+                <a:solidFill>
+                  <a:srgbClr val="5C6670"/>
+                </a:solidFill>
+                <a:latin typeface="Microsoft YaHei"/>
+                <a:ea typeface="Microsoft YaHei"/>
+                <a:cs typeface="Microsoft YaHei"/>
+              </a:defRPr>
+            </a:pPr>
+            <a:r>
+              <a:rPr sz="1200" b="0">
+                <a:solidFill>
+                  <a:srgbClr val="5C6670"/>
+                </a:solidFill>
+                <a:latin typeface="Microsoft YaHei"/>
+                <a:ea typeface="Microsoft YaHei"/>
+                <a:cs typeface="Microsoft YaHei"/>
+              </a:rPr>
+              <a:t>01</a:t>
             </a:r>
           </a:p>
         </p:txBody>
@@ -1885,7 +2045,7 @@
           <p:cNvPr id="4" name="">
             <a:extLst xmlns:a="http://schemas.openxmlformats.org/drawingml/2006/main">
               <a:ext uri="{FF2B5EF4-FFF2-40B4-BE49-F238E27FC236}">
-                <a16:creationId xmlns:a16="http://schemas.microsoft.com/office/drawing/2014/main" id="{84E9852B-9D47-4EC9-969B-ED1D8EB60C2D}"/>
+                <a16:creationId xmlns:a16="http://schemas.microsoft.com/office/drawing/2014/main" id="{70BC07E9-11E1-41FC-8D00-BE7EF64C07F5}"/>
               </a:ext>
             </a:extLst>
           </p:cNvPr>
@@ -1896,8 +2056,8 @@
         </p:nvSpPr>
         <p:spPr>
           <a:xfrm xmlns:a="http://schemas.openxmlformats.org/drawingml/2006/main">
-            <a:off x="628650" y="1733550"/>
-            <a:ext cx="2333625" cy="552450"/>
+            <a:off x="571500" y="1495425"/>
+            <a:ext cx="2524125" cy="457200"/>
           </a:xfrm>
           <a:prstGeom xmlns:a="http://schemas.openxmlformats.org/drawingml/2006/main" prst="rect">
             <a:avLst/>
@@ -1909,22 +2069,22 @@
         </p:spPr>
         <p:txBody>
           <a:bodyPr xmlns:a="http://schemas.openxmlformats.org/drawingml/2006/main" anchor="ctr">
-            <a:normAutofit fontScale="84028"/>
+            <a:noAutofit/>
           </a:bodyPr>
           <a:lstStyle xmlns:a="http://schemas.openxmlformats.org/drawingml/2006/main"/>
           <a:p xmlns:a="http://schemas.openxmlformats.org/drawingml/2006/main">
             <a:pPr algn="l">
-              <a:defRPr sz="3600" b="1">
-                <a:solidFill>
-                  <a:srgbClr val="17212B"/>
-                </a:solidFill>
-                <a:latin typeface="Microsoft YaHei"/>
-                <a:ea typeface="Microsoft YaHei"/>
-                <a:cs typeface="Microsoft YaHei"/>
-              </a:defRPr>
-            </a:pPr>
-            <a:r>
-              <a:rPr sz="3600" b="1">
+              <a:defRPr sz="2850" b="1">
+                <a:solidFill>
+                  <a:srgbClr val="17212B"/>
+                </a:solidFill>
+                <a:latin typeface="Microsoft YaHei"/>
+                <a:ea typeface="Microsoft YaHei"/>
+                <a:cs typeface="Microsoft YaHei"/>
+              </a:defRPr>
+            </a:pPr>
+            <a:r>
+              <a:rPr sz="2850" b="1">
                 <a:solidFill>
                   <a:srgbClr val="17212B"/>
                 </a:solidFill>
@@ -1942,7 +2102,7 @@
           <p:cNvPr id="5" name="">
             <a:extLst xmlns:a="http://schemas.openxmlformats.org/drawingml/2006/main">
               <a:ext uri="{FF2B5EF4-FFF2-40B4-BE49-F238E27FC236}">
-                <a16:creationId xmlns:a16="http://schemas.microsoft.com/office/drawing/2014/main" id="{844DAEAB-D700-4854-A6E3-78E7256FDBD6}"/>
+                <a16:creationId xmlns:a16="http://schemas.microsoft.com/office/drawing/2014/main" id="{7A653CD0-A148-4626-ADA1-1558BE9912AA}"/>
               </a:ext>
             </a:extLst>
           </p:cNvPr>
@@ -1953,8 +2113,8 @@
         </p:nvSpPr>
         <p:spPr>
           <a:xfrm xmlns:a="http://schemas.openxmlformats.org/drawingml/2006/main">
-            <a:off x="628650" y="2276475"/>
-            <a:ext cx="2333625" cy="285750"/>
+            <a:off x="571500" y="1971675"/>
+            <a:ext cx="2524125" cy="304800"/>
           </a:xfrm>
           <a:prstGeom xmlns:a="http://schemas.openxmlformats.org/drawingml/2006/main" prst="rect">
             <a:avLst/>
@@ -1966,12 +2126,12 @@
         </p:spPr>
         <p:txBody>
           <a:bodyPr xmlns:a="http://schemas.openxmlformats.org/drawingml/2006/main" anchor="ctr">
-            <a:normAutofit fontScale="89474"/>
+            <a:noAutofit/>
           </a:bodyPr>
           <a:lstStyle xmlns:a="http://schemas.openxmlformats.org/drawingml/2006/main"/>
           <a:p xmlns:a="http://schemas.openxmlformats.org/drawingml/2006/main">
             <a:pPr algn="l">
-              <a:defRPr sz="1425" b="0">
+              <a:defRPr sz="1650" b="0">
                 <a:solidFill>
                   <a:srgbClr val="5C6670"/>
                 </a:solidFill>
@@ -1981,7 +2141,7 @@
               </a:defRPr>
             </a:pPr>
             <a:r>
-              <a:rPr sz="1425" b="0">
+              <a:rPr sz="1650" b="0">
                 <a:solidFill>
                   <a:srgbClr val="5C6670"/>
                 </a:solidFill>
@@ -1999,7 +2159,7 @@
           <p:cNvPr id="6" name="">
             <a:extLst xmlns:a="http://schemas.openxmlformats.org/drawingml/2006/main">
               <a:ext uri="{FF2B5EF4-FFF2-40B4-BE49-F238E27FC236}">
-                <a16:creationId xmlns:a16="http://schemas.microsoft.com/office/drawing/2014/main" id="{1BD62981-3DC3-4C50-BF65-68B83596D3F9}"/>
+                <a16:creationId xmlns:a16="http://schemas.microsoft.com/office/drawing/2014/main" id="{EBAB2910-146E-4E2B-8C33-678FD9915832}"/>
               </a:ext>
             </a:extLst>
           </p:cNvPr>
@@ -2010,8 +2170,8 @@
         </p:nvSpPr>
         <p:spPr>
           <a:xfrm xmlns:a="http://schemas.openxmlformats.org/drawingml/2006/main">
-            <a:off x="3333750" y="1733550"/>
-            <a:ext cx="2333625" cy="552450"/>
+            <a:off x="3238500" y="1495425"/>
+            <a:ext cx="2524125" cy="457200"/>
           </a:xfrm>
           <a:prstGeom xmlns:a="http://schemas.openxmlformats.org/drawingml/2006/main" prst="rect">
             <a:avLst/>
@@ -2023,22 +2183,22 @@
         </p:spPr>
         <p:txBody>
           <a:bodyPr xmlns:a="http://schemas.openxmlformats.org/drawingml/2006/main" anchor="ctr">
-            <a:normAutofit fontScale="84028"/>
+            <a:noAutofit/>
           </a:bodyPr>
           <a:lstStyle xmlns:a="http://schemas.openxmlformats.org/drawingml/2006/main"/>
           <a:p xmlns:a="http://schemas.openxmlformats.org/drawingml/2006/main">
             <a:pPr algn="l">
-              <a:defRPr sz="3600" b="1">
-                <a:solidFill>
-                  <a:srgbClr val="17212B"/>
-                </a:solidFill>
-                <a:latin typeface="Microsoft YaHei"/>
-                <a:ea typeface="Microsoft YaHei"/>
-                <a:cs typeface="Microsoft YaHei"/>
-              </a:defRPr>
-            </a:pPr>
-            <a:r>
-              <a:rPr sz="3600" b="1">
+              <a:defRPr sz="2850" b="1">
+                <a:solidFill>
+                  <a:srgbClr val="17212B"/>
+                </a:solidFill>
+                <a:latin typeface="Microsoft YaHei"/>
+                <a:ea typeface="Microsoft YaHei"/>
+                <a:cs typeface="Microsoft YaHei"/>
+              </a:defRPr>
+            </a:pPr>
+            <a:r>
+              <a:rPr sz="2850" b="1">
                 <a:solidFill>
                   <a:srgbClr val="17212B"/>
                 </a:solidFill>
@@ -2056,7 +2216,7 @@
           <p:cNvPr id="7" name="">
             <a:extLst xmlns:a="http://schemas.openxmlformats.org/drawingml/2006/main">
               <a:ext uri="{FF2B5EF4-FFF2-40B4-BE49-F238E27FC236}">
-                <a16:creationId xmlns:a16="http://schemas.microsoft.com/office/drawing/2014/main" id="{DA2072D4-E052-47E8-9F4E-A990BE1D91DD}"/>
+                <a16:creationId xmlns:a16="http://schemas.microsoft.com/office/drawing/2014/main" id="{511ADBE1-FF4E-48C0-BD57-346D4F070F33}"/>
               </a:ext>
             </a:extLst>
           </p:cNvPr>
@@ -2067,8 +2227,8 @@
         </p:nvSpPr>
         <p:spPr>
           <a:xfrm xmlns:a="http://schemas.openxmlformats.org/drawingml/2006/main">
-            <a:off x="3333750" y="2276475"/>
-            <a:ext cx="2333625" cy="285750"/>
+            <a:off x="3238500" y="1971675"/>
+            <a:ext cx="2524125" cy="304800"/>
           </a:xfrm>
           <a:prstGeom xmlns:a="http://schemas.openxmlformats.org/drawingml/2006/main" prst="rect">
             <a:avLst/>
@@ -2080,12 +2240,12 @@
         </p:spPr>
         <p:txBody>
           <a:bodyPr xmlns:a="http://schemas.openxmlformats.org/drawingml/2006/main" anchor="ctr">
-            <a:normAutofit fontScale="89474"/>
+            <a:noAutofit/>
           </a:bodyPr>
           <a:lstStyle xmlns:a="http://schemas.openxmlformats.org/drawingml/2006/main"/>
           <a:p xmlns:a="http://schemas.openxmlformats.org/drawingml/2006/main">
             <a:pPr algn="l">
-              <a:defRPr sz="1425" b="0">
+              <a:defRPr sz="1650" b="0">
                 <a:solidFill>
                   <a:srgbClr val="5C6670"/>
                 </a:solidFill>
@@ -2095,7 +2255,7 @@
               </a:defRPr>
             </a:pPr>
             <a:r>
-              <a:rPr sz="1425" b="0">
+              <a:rPr sz="1650" b="0">
                 <a:solidFill>
                   <a:srgbClr val="5C6670"/>
                 </a:solidFill>
@@ -2103,7 +2263,7 @@
                 <a:ea typeface="Microsoft YaHei"/>
                 <a:cs typeface="Microsoft YaHei"/>
               </a:rPr>
-              <a:t>Item 索引</a:t>
+              <a:t>对象索引（Item）</a:t>
             </a:r>
           </a:p>
         </p:txBody>
@@ -2113,7 +2273,7 @@
           <p:cNvPr id="8" name="">
             <a:extLst xmlns:a="http://schemas.openxmlformats.org/drawingml/2006/main">
               <a:ext uri="{FF2B5EF4-FFF2-40B4-BE49-F238E27FC236}">
-                <a16:creationId xmlns:a16="http://schemas.microsoft.com/office/drawing/2014/main" id="{A4A201B7-B6C0-48EF-9FC9-4C39C9AFE7C8}"/>
+                <a16:creationId xmlns:a16="http://schemas.microsoft.com/office/drawing/2014/main" id="{420630B8-EC3B-43D7-84B8-CA6B0D3E0E73}"/>
               </a:ext>
             </a:extLst>
           </p:cNvPr>
@@ -2124,8 +2284,8 @@
         </p:nvSpPr>
         <p:spPr>
           <a:xfrm xmlns:a="http://schemas.openxmlformats.org/drawingml/2006/main">
-            <a:off x="6153150" y="1733550"/>
-            <a:ext cx="2333625" cy="552450"/>
+            <a:off x="6115050" y="1495425"/>
+            <a:ext cx="2524125" cy="457200"/>
           </a:xfrm>
           <a:prstGeom xmlns:a="http://schemas.openxmlformats.org/drawingml/2006/main" prst="rect">
             <a:avLst/>
@@ -2137,22 +2297,22 @@
         </p:spPr>
         <p:txBody>
           <a:bodyPr xmlns:a="http://schemas.openxmlformats.org/drawingml/2006/main" anchor="ctr">
-            <a:normAutofit fontScale="84028"/>
+            <a:noAutofit/>
           </a:bodyPr>
           <a:lstStyle xmlns:a="http://schemas.openxmlformats.org/drawingml/2006/main"/>
           <a:p xmlns:a="http://schemas.openxmlformats.org/drawingml/2006/main">
             <a:pPr algn="l">
-              <a:defRPr sz="3600" b="1">
-                <a:solidFill>
-                  <a:srgbClr val="17212B"/>
-                </a:solidFill>
-                <a:latin typeface="Microsoft YaHei"/>
-                <a:ea typeface="Microsoft YaHei"/>
-                <a:cs typeface="Microsoft YaHei"/>
-              </a:defRPr>
-            </a:pPr>
-            <a:r>
-              <a:rPr sz="3600" b="1">
+              <a:defRPr sz="2850" b="1">
+                <a:solidFill>
+                  <a:srgbClr val="17212B"/>
+                </a:solidFill>
+                <a:latin typeface="Microsoft YaHei"/>
+                <a:ea typeface="Microsoft YaHei"/>
+                <a:cs typeface="Microsoft YaHei"/>
+              </a:defRPr>
+            </a:pPr>
+            <a:r>
+              <a:rPr sz="2850" b="1">
                 <a:solidFill>
                   <a:srgbClr val="17212B"/>
                 </a:solidFill>
@@ -2170,7 +2330,7 @@
           <p:cNvPr id="9" name="">
             <a:extLst xmlns:a="http://schemas.openxmlformats.org/drawingml/2006/main">
               <a:ext uri="{FF2B5EF4-FFF2-40B4-BE49-F238E27FC236}">
-                <a16:creationId xmlns:a16="http://schemas.microsoft.com/office/drawing/2014/main" id="{6A9CC822-4AF4-4B55-9809-2ADD6F24487F}"/>
+                <a16:creationId xmlns:a16="http://schemas.microsoft.com/office/drawing/2014/main" id="{EF48AC79-3F12-4115-B95A-913FD293B288}"/>
               </a:ext>
             </a:extLst>
           </p:cNvPr>
@@ -2181,8 +2341,8 @@
         </p:nvSpPr>
         <p:spPr>
           <a:xfrm xmlns:a="http://schemas.openxmlformats.org/drawingml/2006/main">
-            <a:off x="6153150" y="2276475"/>
-            <a:ext cx="2333625" cy="285750"/>
+            <a:off x="6115050" y="1971675"/>
+            <a:ext cx="2524125" cy="304800"/>
           </a:xfrm>
           <a:prstGeom xmlns:a="http://schemas.openxmlformats.org/drawingml/2006/main" prst="rect">
             <a:avLst/>
@@ -2194,12 +2354,12 @@
         </p:spPr>
         <p:txBody>
           <a:bodyPr xmlns:a="http://schemas.openxmlformats.org/drawingml/2006/main" anchor="ctr">
-            <a:normAutofit fontScale="89474"/>
+            <a:noAutofit/>
           </a:bodyPr>
           <a:lstStyle xmlns:a="http://schemas.openxmlformats.org/drawingml/2006/main"/>
           <a:p xmlns:a="http://schemas.openxmlformats.org/drawingml/2006/main">
             <a:pPr algn="l">
-              <a:defRPr sz="1425" b="0">
+              <a:defRPr sz="1650" b="0">
                 <a:solidFill>
                   <a:srgbClr val="5C6670"/>
                 </a:solidFill>
@@ -2209,7 +2369,7 @@
               </a:defRPr>
             </a:pPr>
             <a:r>
-              <a:rPr sz="1425" b="0">
+              <a:rPr sz="1650" b="0">
                 <a:solidFill>
                   <a:srgbClr val="5C6670"/>
                 </a:solidFill>
@@ -2217,7 +2377,7 @@
                 <a:ea typeface="Microsoft YaHei"/>
                 <a:cs typeface="Microsoft YaHei"/>
               </a:rPr>
-              <a:t>官方候选</a:t>
+              <a:t>本轮评测候选</a:t>
             </a:r>
           </a:p>
         </p:txBody>
@@ -2227,7 +2387,7 @@
           <p:cNvPr id="10" name="">
             <a:extLst xmlns:a="http://schemas.openxmlformats.org/drawingml/2006/main">
               <a:ext uri="{FF2B5EF4-FFF2-40B4-BE49-F238E27FC236}">
-                <a16:creationId xmlns:a16="http://schemas.microsoft.com/office/drawing/2014/main" id="{35B375A1-9F83-4467-8FAD-18CC0A0D4A37}"/>
+                <a16:creationId xmlns:a16="http://schemas.microsoft.com/office/drawing/2014/main" id="{51E00511-0323-4999-9CD5-EAA250A84290}"/>
               </a:ext>
             </a:extLst>
           </p:cNvPr>
@@ -2238,8 +2398,8 @@
         </p:nvSpPr>
         <p:spPr>
           <a:xfrm xmlns:a="http://schemas.openxmlformats.org/drawingml/2006/main">
-            <a:off x="9124950" y="1733550"/>
-            <a:ext cx="2333625" cy="552450"/>
+            <a:off x="9048750" y="1495425"/>
+            <a:ext cx="2524125" cy="457200"/>
           </a:xfrm>
           <a:prstGeom xmlns:a="http://schemas.openxmlformats.org/drawingml/2006/main" prst="rect">
             <a:avLst/>
@@ -2251,12 +2411,12 @@
         </p:spPr>
         <p:txBody>
           <a:bodyPr xmlns:a="http://schemas.openxmlformats.org/drawingml/2006/main" anchor="ctr">
-            <a:normAutofit fontScale="84028"/>
+            <a:noAutofit/>
           </a:bodyPr>
           <a:lstStyle xmlns:a="http://schemas.openxmlformats.org/drawingml/2006/main"/>
           <a:p xmlns:a="http://schemas.openxmlformats.org/drawingml/2006/main">
             <a:pPr algn="l">
-              <a:defRPr sz="3600" b="1">
+              <a:defRPr sz="2850" b="1">
                 <a:solidFill>
                   <a:srgbClr val="E7743A"/>
                 </a:solidFill>
@@ -2266,7 +2426,7 @@
               </a:defRPr>
             </a:pPr>
             <a:r>
-              <a:rPr sz="3600" b="1">
+              <a:rPr sz="2850" b="1">
                 <a:solidFill>
                   <a:srgbClr val="E7743A"/>
                 </a:solidFill>
@@ -2284,7 +2444,7 @@
           <p:cNvPr id="11" name="">
             <a:extLst xmlns:a="http://schemas.openxmlformats.org/drawingml/2006/main">
               <a:ext uri="{FF2B5EF4-FFF2-40B4-BE49-F238E27FC236}">
-                <a16:creationId xmlns:a16="http://schemas.microsoft.com/office/drawing/2014/main" id="{17FB2FFE-648B-431A-A61A-29C870A9AA00}"/>
+                <a16:creationId xmlns:a16="http://schemas.microsoft.com/office/drawing/2014/main" id="{BA6DD996-E863-47C0-B7AA-CF2FABE13665}"/>
               </a:ext>
             </a:extLst>
           </p:cNvPr>
@@ -2295,8 +2455,8 @@
         </p:nvSpPr>
         <p:spPr>
           <a:xfrm xmlns:a="http://schemas.openxmlformats.org/drawingml/2006/main">
-            <a:off x="9124950" y="2276475"/>
-            <a:ext cx="2333625" cy="285750"/>
+            <a:off x="9048750" y="1971675"/>
+            <a:ext cx="2524125" cy="304800"/>
           </a:xfrm>
           <a:prstGeom xmlns:a="http://schemas.openxmlformats.org/drawingml/2006/main" prst="rect">
             <a:avLst/>
@@ -2308,12 +2468,12 @@
         </p:spPr>
         <p:txBody>
           <a:bodyPr xmlns:a="http://schemas.openxmlformats.org/drawingml/2006/main" anchor="ctr">
-            <a:normAutofit fontScale="89474"/>
+            <a:noAutofit/>
           </a:bodyPr>
           <a:lstStyle xmlns:a="http://schemas.openxmlformats.org/drawingml/2006/main"/>
           <a:p xmlns:a="http://schemas.openxmlformats.org/drawingml/2006/main">
             <a:pPr algn="l">
-              <a:defRPr sz="1425" b="0">
+              <a:defRPr sz="1650" b="0">
                 <a:solidFill>
                   <a:srgbClr val="5C6670"/>
                 </a:solidFill>
@@ -2323,7 +2483,7 @@
               </a:defRPr>
             </a:pPr>
             <a:r>
-              <a:rPr sz="1425" b="0">
+              <a:rPr sz="1650" b="0">
                 <a:solidFill>
                   <a:srgbClr val="5C6670"/>
                 </a:solidFill>
@@ -2341,7 +2501,7 @@
           <p:cNvPr id="12" name="">
             <a:extLst xmlns:a="http://schemas.openxmlformats.org/drawingml/2006/main">
               <a:ext uri="{FF2B5EF4-FFF2-40B4-BE49-F238E27FC236}">
-                <a16:creationId xmlns:a16="http://schemas.microsoft.com/office/drawing/2014/main" id="{7B187808-DC9B-49C5-AA12-E2DD1E21150A}"/>
+                <a16:creationId xmlns:a16="http://schemas.microsoft.com/office/drawing/2014/main" id="{878CE571-054D-459C-B622-7A733D31E93D}"/>
               </a:ext>
             </a:extLst>
           </p:cNvPr>
@@ -2352,8 +2512,8 @@
         </p:nvSpPr>
         <p:spPr>
           <a:xfrm xmlns:a="http://schemas.openxmlformats.org/drawingml/2006/main">
-            <a:off x="628650" y="3200400"/>
-            <a:ext cx="2000250" cy="304800"/>
+            <a:off x="571500" y="2533650"/>
+            <a:ext cx="5543550" cy="342900"/>
           </a:xfrm>
           <a:prstGeom xmlns:a="http://schemas.openxmlformats.org/drawingml/2006/main" prst="rect">
             <a:avLst/>
@@ -2365,12 +2525,12 @@
         </p:spPr>
         <p:txBody>
           <a:bodyPr xmlns:a="http://schemas.openxmlformats.org/drawingml/2006/main" anchor="ctr">
-            <a:normAutofit fontScale="100000"/>
+            <a:noAutofit/>
           </a:bodyPr>
           <a:lstStyle xmlns:a="http://schemas.openxmlformats.org/drawingml/2006/main"/>
           <a:p xmlns:a="http://schemas.openxmlformats.org/drawingml/2006/main">
             <a:pPr algn="l">
-              <a:defRPr sz="1350" b="1">
+              <a:defRPr sz="1950" b="1">
                 <a:solidFill>
                   <a:srgbClr val="008A83"/>
                 </a:solidFill>
@@ -2380,7 +2540,7 @@
               </a:defRPr>
             </a:pPr>
             <a:r>
-              <a:rPr sz="1350" b="1">
+              <a:rPr sz="1950" b="1">
                 <a:solidFill>
                   <a:srgbClr val="008A83"/>
                 </a:solidFill>
@@ -2388,7 +2548,7 @@
                 <a:ea typeface="Microsoft YaHei"/>
                 <a:cs typeface="Microsoft YaHei"/>
               </a:rPr>
-              <a:t>固定协议</a:t>
+              <a:t>从历史行为得到推荐结果</a:t>
             </a:r>
           </a:p>
         </p:txBody>
@@ -2398,7 +2558,7 @@
           <p:cNvPr id="13" name="">
             <a:extLst xmlns:a="http://schemas.openxmlformats.org/drawingml/2006/main">
               <a:ext uri="{FF2B5EF4-FFF2-40B4-BE49-F238E27FC236}">
-                <a16:creationId xmlns:a16="http://schemas.microsoft.com/office/drawing/2014/main" id="{EE67ABB1-72E6-4132-96AD-9F4F41C60184}"/>
+                <a16:creationId xmlns:a16="http://schemas.microsoft.com/office/drawing/2014/main" id="{A799E326-0FCD-4C3D-98BE-CE0951D0455F}"/>
               </a:ext>
             </a:extLst>
           </p:cNvPr>
@@ -2409,8 +2569,8 @@
         </p:nvSpPr>
         <p:spPr>
           <a:xfrm xmlns:a="http://schemas.openxmlformats.org/drawingml/2006/main">
-            <a:off x="628650" y="3600450"/>
-            <a:ext cx="5048250" cy="400050"/>
+            <a:off x="571500" y="2962275"/>
+            <a:ext cx="5619750" cy="609600"/>
           </a:xfrm>
           <a:prstGeom xmlns:a="http://schemas.openxmlformats.org/drawingml/2006/main" prst="rect">
             <a:avLst/>
@@ -2422,30 +2582,53 @@
         </p:spPr>
         <p:txBody>
           <a:bodyPr xmlns:a="http://schemas.openxmlformats.org/drawingml/2006/main" anchor="ctr">
-            <a:normAutofit fontScale="100000"/>
+            <a:noAutofit/>
           </a:bodyPr>
           <a:lstStyle xmlns:a="http://schemas.openxmlformats.org/drawingml/2006/main"/>
           <a:p xmlns:a="http://schemas.openxmlformats.org/drawingml/2006/main">
             <a:pPr algn="l">
-              <a:defRPr sz="1875" b="1">
-                <a:solidFill>
-                  <a:srgbClr val="17212B"/>
-                </a:solidFill>
-                <a:latin typeface="Microsoft YaHei"/>
-                <a:ea typeface="Microsoft YaHei"/>
-                <a:cs typeface="Microsoft YaHei"/>
-              </a:defRPr>
-            </a:pPr>
-            <a:r>
-              <a:rPr sz="1875" b="1">
-                <a:solidFill>
-                  <a:srgbClr val="17212B"/>
-                </a:solidFill>
-                <a:latin typeface="Microsoft YaHei"/>
-                <a:ea typeface="Microsoft YaHei"/>
-                <a:cs typeface="Microsoft YaHei"/>
-              </a:rPr>
-              <a:t>01  最后点击留出与 ID 对齐</a:t>
+              <a:defRPr sz="1725" b="0">
+                <a:solidFill>
+                  <a:srgbClr val="17212B"/>
+                </a:solidFill>
+                <a:latin typeface="Microsoft YaHei"/>
+                <a:ea typeface="Microsoft YaHei"/>
+                <a:cs typeface="Microsoft YaHei"/>
+              </a:defRPr>
+            </a:pPr>
+            <a:r>
+              <a:rPr sz="1725" b="0">
+                <a:solidFill>
+                  <a:srgbClr val="17212B"/>
+                </a:solidFill>
+                <a:latin typeface="Microsoft YaHei"/>
+                <a:ea typeface="Microsoft YaHei"/>
+                <a:cs typeface="Microsoft YaHei"/>
+              </a:rPr>
+              <a:t>① 留出答案：最后一次点击作为目标，</a:t>
+            </a:r>
+          </a:p>
+          <a:p xmlns:a="http://schemas.openxmlformats.org/drawingml/2006/main">
+            <a:pPr algn="l">
+              <a:defRPr sz="1725" b="0">
+                <a:solidFill>
+                  <a:srgbClr val="17212B"/>
+                </a:solidFill>
+                <a:latin typeface="Microsoft YaHei"/>
+                <a:ea typeface="Microsoft YaHei"/>
+                <a:cs typeface="Microsoft YaHei"/>
+              </a:defRPr>
+            </a:pPr>
+            <a:r>
+              <a:rPr sz="1725" b="0">
+                <a:solidFill>
+                  <a:srgbClr val="17212B"/>
+                </a:solidFill>
+                <a:latin typeface="Microsoft YaHei"/>
+                <a:ea typeface="Microsoft YaHei"/>
+                <a:cs typeface="Microsoft YaHei"/>
+              </a:rPr>
+              <a:t>    只把它之前的记录给模型。</a:t>
             </a:r>
           </a:p>
         </p:txBody>
@@ -2455,7 +2638,7 @@
           <p:cNvPr id="14" name="">
             <a:extLst xmlns:a="http://schemas.openxmlformats.org/drawingml/2006/main">
               <a:ext uri="{FF2B5EF4-FFF2-40B4-BE49-F238E27FC236}">
-                <a16:creationId xmlns:a16="http://schemas.microsoft.com/office/drawing/2014/main" id="{F08D2D97-D2AB-4479-9288-127BA6C50C3E}"/>
+                <a16:creationId xmlns:a16="http://schemas.microsoft.com/office/drawing/2014/main" id="{F48D9CDA-85D3-4CCF-8938-6E40A312CF03}"/>
               </a:ext>
             </a:extLst>
           </p:cNvPr>
@@ -2466,8 +2649,8 @@
         </p:nvSpPr>
         <p:spPr>
           <a:xfrm xmlns:a="http://schemas.openxmlformats.org/drawingml/2006/main">
-            <a:off x="628650" y="4133850"/>
-            <a:ext cx="5048250" cy="400050"/>
+            <a:off x="571500" y="3648075"/>
+            <a:ext cx="5619750" cy="609600"/>
           </a:xfrm>
           <a:prstGeom xmlns:a="http://schemas.openxmlformats.org/drawingml/2006/main" prst="rect">
             <a:avLst/>
@@ -2479,30 +2662,53 @@
         </p:spPr>
         <p:txBody>
           <a:bodyPr xmlns:a="http://schemas.openxmlformats.org/drawingml/2006/main" anchor="ctr">
-            <a:normAutofit fontScale="100000"/>
+            <a:noAutofit/>
           </a:bodyPr>
           <a:lstStyle xmlns:a="http://schemas.openxmlformats.org/drawingml/2006/main"/>
           <a:p xmlns:a="http://schemas.openxmlformats.org/drawingml/2006/main">
             <a:pPr algn="l">
-              <a:defRPr sz="1875" b="0">
-                <a:solidFill>
-                  <a:srgbClr val="17212B"/>
-                </a:solidFill>
-                <a:latin typeface="Microsoft YaHei"/>
-                <a:ea typeface="Microsoft YaHei"/>
-                <a:cs typeface="Microsoft YaHei"/>
-              </a:defRPr>
-            </a:pPr>
-            <a:r>
-              <a:rPr sz="1875" b="0">
-                <a:solidFill>
-                  <a:srgbClr val="17212B"/>
-                </a:solidFill>
-                <a:latin typeface="Microsoft YaHei"/>
-                <a:ea typeface="Microsoft YaHei"/>
-                <a:cs typeface="Microsoft YaHei"/>
-              </a:rPr>
-              <a:t>02  HSTU / InfoNCE 受控训练</a:t>
+              <a:defRPr sz="1725" b="0">
+                <a:solidFill>
+                  <a:srgbClr val="17212B"/>
+                </a:solidFill>
+                <a:latin typeface="Microsoft YaHei"/>
+                <a:ea typeface="Microsoft YaHei"/>
+                <a:cs typeface="Microsoft YaHei"/>
+              </a:defRPr>
+            </a:pPr>
+            <a:r>
+              <a:rPr sz="1725" b="0">
+                <a:solidFill>
+                  <a:srgbClr val="17212B"/>
+                </a:solidFill>
+                <a:latin typeface="Microsoft YaHei"/>
+                <a:ea typeface="Microsoft YaHei"/>
+                <a:cs typeface="Microsoft YaHei"/>
+              </a:rPr>
+              <a:t>② 用户侧：用 HSTU 汇总历史兴趣；</a:t>
+            </a:r>
+          </a:p>
+          <a:p xmlns:a="http://schemas.openxmlformats.org/drawingml/2006/main">
+            <a:pPr algn="l">
+              <a:defRPr sz="1725" b="0">
+                <a:solidFill>
+                  <a:srgbClr val="17212B"/>
+                </a:solidFill>
+                <a:latin typeface="Microsoft YaHei"/>
+                <a:ea typeface="Microsoft YaHei"/>
+                <a:cs typeface="Microsoft YaHei"/>
+              </a:defRPr>
+            </a:pPr>
+            <a:r>
+              <a:rPr sz="1725" b="0">
+                <a:solidFill>
+                  <a:srgbClr val="17212B"/>
+                </a:solidFill>
+                <a:latin typeface="Microsoft YaHei"/>
+                <a:ea typeface="Microsoft YaHei"/>
+                <a:cs typeface="Microsoft YaHei"/>
+              </a:rPr>
+              <a:t>    对象侧：把 ID 和属性变成数字向量。</a:t>
             </a:r>
           </a:p>
         </p:txBody>
@@ -2512,7 +2718,7 @@
           <p:cNvPr id="15" name="">
             <a:extLst xmlns:a="http://schemas.openxmlformats.org/drawingml/2006/main">
               <a:ext uri="{FF2B5EF4-FFF2-40B4-BE49-F238E27FC236}">
-                <a16:creationId xmlns:a16="http://schemas.microsoft.com/office/drawing/2014/main" id="{91CC126A-AF3D-4380-8D6B-83C78035F0FC}"/>
+                <a16:creationId xmlns:a16="http://schemas.microsoft.com/office/drawing/2014/main" id="{0EBD32A9-D50A-456E-9C08-4A781E014F58}"/>
               </a:ext>
             </a:extLst>
           </p:cNvPr>
@@ -2523,8 +2729,8 @@
         </p:nvSpPr>
         <p:spPr>
           <a:xfrm xmlns:a="http://schemas.openxmlformats.org/drawingml/2006/main">
-            <a:off x="628650" y="4667250"/>
-            <a:ext cx="5048250" cy="400050"/>
+            <a:off x="571500" y="4333875"/>
+            <a:ext cx="5619750" cy="609600"/>
           </a:xfrm>
           <a:prstGeom xmlns:a="http://schemas.openxmlformats.org/drawingml/2006/main" prst="rect">
             <a:avLst/>
@@ -2536,30 +2742,53 @@
         </p:spPr>
         <p:txBody>
           <a:bodyPr xmlns:a="http://schemas.openxmlformats.org/drawingml/2006/main" anchor="ctr">
-            <a:normAutofit fontScale="100000"/>
+            <a:noAutofit/>
           </a:bodyPr>
           <a:lstStyle xmlns:a="http://schemas.openxmlformats.org/drawingml/2006/main"/>
           <a:p xmlns:a="http://schemas.openxmlformats.org/drawingml/2006/main">
             <a:pPr algn="l">
-              <a:defRPr sz="1875" b="0">
-                <a:solidFill>
-                  <a:srgbClr val="17212B"/>
-                </a:solidFill>
-                <a:latin typeface="Microsoft YaHei"/>
-                <a:ea typeface="Microsoft YaHei"/>
-                <a:cs typeface="Microsoft YaHei"/>
-              </a:defRPr>
-            </a:pPr>
-            <a:r>
-              <a:rPr sz="1875" b="0">
-                <a:solidFill>
-                  <a:srgbClr val="17212B"/>
-                </a:solidFill>
-                <a:latin typeface="Microsoft YaHei"/>
-                <a:ea typeface="Microsoft YaHei"/>
-                <a:cs typeface="Microsoft YaHei"/>
-              </a:rPr>
-              <a:t>03  分块精确内积 Top-10</a:t>
+              <a:defRPr sz="1725" b="0">
+                <a:solidFill>
+                  <a:srgbClr val="17212B"/>
+                </a:solidFill>
+                <a:latin typeface="Microsoft YaHei"/>
+                <a:ea typeface="Microsoft YaHei"/>
+                <a:cs typeface="Microsoft YaHei"/>
+              </a:defRPr>
+            </a:pPr>
+            <a:r>
+              <a:rPr sz="1725" b="0">
+                <a:solidFill>
+                  <a:srgbClr val="17212B"/>
+                </a:solidFill>
+                <a:latin typeface="Microsoft YaHei"/>
+                <a:ea typeface="Microsoft YaHei"/>
+                <a:cs typeface="Microsoft YaHei"/>
+              </a:rPr>
+              <a:t>③ 计算匹配分数：每批处理 128 个用户，</a:t>
+            </a:r>
+          </a:p>
+          <a:p xmlns:a="http://schemas.openxmlformats.org/drawingml/2006/main">
+            <a:pPr algn="l">
+              <a:defRPr sz="1725" b="0">
+                <a:solidFill>
+                  <a:srgbClr val="17212B"/>
+                </a:solidFill>
+                <a:latin typeface="Microsoft YaHei"/>
+                <a:ea typeface="Microsoft YaHei"/>
+                <a:cs typeface="Microsoft YaHei"/>
+              </a:defRPr>
+            </a:pPr>
+            <a:r>
+              <a:rPr sz="1725" b="0">
+                <a:solidFill>
+                  <a:srgbClr val="17212B"/>
+                </a:solidFill>
+                <a:latin typeface="Microsoft YaHei"/>
+                <a:ea typeface="Microsoft YaHei"/>
+                <a:cs typeface="Microsoft YaHei"/>
+              </a:rPr>
+              <a:t>    遍历 66 万候选，留下得分最高的 10 个。</a:t>
             </a:r>
           </a:p>
         </p:txBody>
@@ -2569,7 +2798,7 @@
           <p:cNvPr id="16" name="">
             <a:extLst xmlns:a="http://schemas.openxmlformats.org/drawingml/2006/main">
               <a:ext uri="{FF2B5EF4-FFF2-40B4-BE49-F238E27FC236}">
-                <a16:creationId xmlns:a16="http://schemas.microsoft.com/office/drawing/2014/main" id="{0718E7EE-82AF-40E6-8DD3-B4BD8CCE0896}"/>
+                <a16:creationId xmlns:a16="http://schemas.microsoft.com/office/drawing/2014/main" id="{98AD180B-55BB-4B8E-81CD-9AC1C63F6414}"/>
               </a:ext>
             </a:extLst>
           </p:cNvPr>
@@ -2580,8 +2809,8 @@
         </p:nvSpPr>
         <p:spPr>
           <a:xfrm xmlns:a="http://schemas.openxmlformats.org/drawingml/2006/main">
-            <a:off x="628650" y="5200650"/>
-            <a:ext cx="5048250" cy="400050"/>
+            <a:off x="571500" y="5019675"/>
+            <a:ext cx="5619750" cy="609600"/>
           </a:xfrm>
           <a:prstGeom xmlns:a="http://schemas.openxmlformats.org/drawingml/2006/main" prst="rect">
             <a:avLst/>
@@ -2593,30 +2822,53 @@
         </p:spPr>
         <p:txBody>
           <a:bodyPr xmlns:a="http://schemas.openxmlformats.org/drawingml/2006/main" anchor="ctr">
-            <a:normAutofit fontScale="100000"/>
+            <a:noAutofit/>
           </a:bodyPr>
           <a:lstStyle xmlns:a="http://schemas.openxmlformats.org/drawingml/2006/main"/>
           <a:p xmlns:a="http://schemas.openxmlformats.org/drawingml/2006/main">
             <a:pPr algn="l">
-              <a:defRPr sz="1875" b="0">
-                <a:solidFill>
-                  <a:srgbClr val="17212B"/>
-                </a:solidFill>
-                <a:latin typeface="Microsoft YaHei"/>
-                <a:ea typeface="Microsoft YaHei"/>
-                <a:cs typeface="Microsoft YaHei"/>
-              </a:defRPr>
-            </a:pPr>
-            <a:r>
-              <a:rPr sz="1875" b="0">
-                <a:solidFill>
-                  <a:srgbClr val="17212B"/>
-                </a:solidFill>
-                <a:latin typeface="Microsoft YaHei"/>
-                <a:ea typeface="Microsoft YaHei"/>
-                <a:cs typeface="Microsoft YaHei"/>
-              </a:rPr>
-              <a:t>04  逐行统计与 SHA-256 回读</a:t>
+              <a:defRPr sz="1725" b="0">
+                <a:solidFill>
+                  <a:srgbClr val="17212B"/>
+                </a:solidFill>
+                <a:latin typeface="Microsoft YaHei"/>
+                <a:ea typeface="Microsoft YaHei"/>
+                <a:cs typeface="Microsoft YaHei"/>
+              </a:defRPr>
+            </a:pPr>
+            <a:r>
+              <a:rPr sz="1725" b="0">
+                <a:solidFill>
+                  <a:srgbClr val="17212B"/>
+                </a:solidFill>
+                <a:latin typeface="Microsoft YaHei"/>
+                <a:ea typeface="Microsoft YaHei"/>
+                <a:cs typeface="Microsoft YaHei"/>
+              </a:rPr>
+              <a:t>④ 保存结果：用户、目标、预测逐行对应，</a:t>
+            </a:r>
+          </a:p>
+          <a:p xmlns:a="http://schemas.openxmlformats.org/drawingml/2006/main">
+            <a:pPr algn="l">
+              <a:defRPr sz="1725" b="0">
+                <a:solidFill>
+                  <a:srgbClr val="17212B"/>
+                </a:solidFill>
+                <a:latin typeface="Microsoft YaHei"/>
+                <a:ea typeface="Microsoft YaHei"/>
+                <a:cs typeface="Microsoft YaHei"/>
+              </a:defRPr>
+            </a:pPr>
+            <a:r>
+              <a:rPr sz="1725" b="0">
+                <a:solidFill>
+                  <a:srgbClr val="17212B"/>
+                </a:solidFill>
+                <a:latin typeface="Microsoft YaHei"/>
+                <a:ea typeface="Microsoft YaHei"/>
+                <a:cs typeface="Microsoft YaHei"/>
+              </a:rPr>
+              <a:t>    同时留存配置和文件校验值。</a:t>
             </a:r>
           </a:p>
         </p:txBody>
@@ -2626,7 +2878,7 @@
           <p:cNvPr id="17" name="">
             <a:extLst xmlns:a="http://schemas.openxmlformats.org/drawingml/2006/main">
               <a:ext uri="{FF2B5EF4-FFF2-40B4-BE49-F238E27FC236}">
-                <a16:creationId xmlns:a16="http://schemas.microsoft.com/office/drawing/2014/main" id="{DC252C25-B2C5-44BE-BC95-26B892C11578}"/>
+                <a16:creationId xmlns:a16="http://schemas.microsoft.com/office/drawing/2014/main" id="{D8F38F61-1EEE-4BAD-90C7-9F25268E4CE3}"/>
               </a:ext>
             </a:extLst>
           </p:cNvPr>
@@ -2637,8 +2889,8 @@
         </p:nvSpPr>
         <p:spPr>
           <a:xfrm xmlns:a="http://schemas.openxmlformats.org/drawingml/2006/main">
-            <a:off x="6743700" y="3200400"/>
-            <a:ext cx="1714500" cy="304800"/>
+            <a:off x="6572250" y="2533650"/>
+            <a:ext cx="5095875" cy="342900"/>
           </a:xfrm>
           <a:prstGeom xmlns:a="http://schemas.openxmlformats.org/drawingml/2006/main" prst="rect">
             <a:avLst/>
@@ -2650,30 +2902,30 @@
         </p:spPr>
         <p:txBody>
           <a:bodyPr xmlns:a="http://schemas.openxmlformats.org/drawingml/2006/main" anchor="ctr">
-            <a:normAutofit fontScale="100000"/>
+            <a:noAutofit/>
           </a:bodyPr>
           <a:lstStyle xmlns:a="http://schemas.openxmlformats.org/drawingml/2006/main"/>
           <a:p xmlns:a="http://schemas.openxmlformats.org/drawingml/2006/main">
             <a:pPr algn="l">
-              <a:defRPr sz="1350" b="1">
-                <a:solidFill>
-                  <a:srgbClr val="E7743A"/>
-                </a:solidFill>
-                <a:latin typeface="Microsoft YaHei"/>
-                <a:ea typeface="Microsoft YaHei"/>
-                <a:cs typeface="Microsoft YaHei"/>
-              </a:defRPr>
-            </a:pPr>
-            <a:r>
-              <a:rPr sz="1350" b="1">
-                <a:solidFill>
-                  <a:srgbClr val="E7743A"/>
-                </a:solidFill>
-                <a:latin typeface="Microsoft YaHei"/>
-                <a:ea typeface="Microsoft YaHei"/>
-                <a:cs typeface="Microsoft YaHei"/>
-              </a:rPr>
-              <a:t>证据链</a:t>
+              <a:defRPr sz="1950" b="1">
+                <a:solidFill>
+                  <a:srgbClr val="008A83"/>
+                </a:solidFill>
+                <a:latin typeface="Microsoft YaHei"/>
+                <a:ea typeface="Microsoft YaHei"/>
+                <a:cs typeface="Microsoft YaHei"/>
+              </a:defRPr>
+            </a:pPr>
+            <a:r>
+              <a:rPr sz="1950" b="1">
+                <a:solidFill>
+                  <a:srgbClr val="008A83"/>
+                </a:solidFill>
+                <a:latin typeface="Microsoft YaHei"/>
+                <a:ea typeface="Microsoft YaHei"/>
+                <a:cs typeface="Microsoft YaHei"/>
+              </a:rPr>
+              <a:t>怎样判断推荐得好不好？</a:t>
             </a:r>
           </a:p>
         </p:txBody>
@@ -2683,7 +2935,7 @@
           <p:cNvPr id="18" name="">
             <a:extLst xmlns:a="http://schemas.openxmlformats.org/drawingml/2006/main">
               <a:ext uri="{FF2B5EF4-FFF2-40B4-BE49-F238E27FC236}">
-                <a16:creationId xmlns:a16="http://schemas.microsoft.com/office/drawing/2014/main" id="{4344C891-283E-45C6-9FF0-B56A870FA2C5}"/>
+                <a16:creationId xmlns:a16="http://schemas.microsoft.com/office/drawing/2014/main" id="{40B8C9C1-A070-4832-A665-805B86AEDD46}"/>
               </a:ext>
             </a:extLst>
           </p:cNvPr>
@@ -2694,8 +2946,8 @@
         </p:nvSpPr>
         <p:spPr>
           <a:xfrm xmlns:a="http://schemas.openxmlformats.org/drawingml/2006/main">
-            <a:off x="6743700" y="3581400"/>
-            <a:ext cx="4476750" cy="819150"/>
+            <a:off x="6572250" y="2981325"/>
+            <a:ext cx="5095875" cy="314325"/>
           </a:xfrm>
           <a:prstGeom xmlns:a="http://schemas.openxmlformats.org/drawingml/2006/main" prst="rect">
             <a:avLst/>
@@ -2707,30 +2959,30 @@
         </p:spPr>
         <p:txBody>
           <a:bodyPr xmlns:a="http://schemas.openxmlformats.org/drawingml/2006/main" anchor="ctr">
-            <a:normAutofit fontScale="100000"/>
+            <a:noAutofit/>
           </a:bodyPr>
           <a:lstStyle xmlns:a="http://schemas.openxmlformats.org/drawingml/2006/main"/>
           <a:p xmlns:a="http://schemas.openxmlformats.org/drawingml/2006/main">
             <a:pPr algn="l">
-              <a:defRPr sz="2325" b="1">
-                <a:solidFill>
-                  <a:srgbClr val="17212B"/>
-                </a:solidFill>
-                <a:latin typeface="Microsoft YaHei"/>
-                <a:ea typeface="Microsoft YaHei"/>
-                <a:cs typeface="Microsoft YaHei"/>
-              </a:defRPr>
-            </a:pPr>
-            <a:r>
-              <a:rPr sz="2325" b="1">
-                <a:solidFill>
-                  <a:srgbClr val="17212B"/>
-                </a:solidFill>
-                <a:latin typeface="Microsoft YaHei"/>
-                <a:ea typeface="Microsoft YaHei"/>
-                <a:cs typeface="Microsoft YaHei"/>
-              </a:rPr>
-              <a:t>代码、配置、预测、指标和哈希一一绑定</a:t>
+              <a:defRPr sz="1800" b="1">
+                <a:solidFill>
+                  <a:srgbClr val="17212B"/>
+                </a:solidFill>
+                <a:latin typeface="Microsoft YaHei"/>
+                <a:ea typeface="Microsoft YaHei"/>
+                <a:cs typeface="Microsoft YaHei"/>
+              </a:defRPr>
+            </a:pPr>
+            <a:r>
+              <a:rPr sz="1800" b="1">
+                <a:solidFill>
+                  <a:srgbClr val="17212B"/>
+                </a:solidFill>
+                <a:latin typeface="Microsoft YaHei"/>
+                <a:ea typeface="Microsoft YaHei"/>
+                <a:cs typeface="Microsoft YaHei"/>
+              </a:rPr>
+              <a:t>HR@10：有没有推荐到</a:t>
             </a:r>
           </a:p>
         </p:txBody>
@@ -2740,7 +2992,7 @@
           <p:cNvPr id="19" name="">
             <a:extLst xmlns:a="http://schemas.openxmlformats.org/drawingml/2006/main">
               <a:ext uri="{FF2B5EF4-FFF2-40B4-BE49-F238E27FC236}">
-                <a16:creationId xmlns:a16="http://schemas.microsoft.com/office/drawing/2014/main" id="{279E1496-7A00-437A-B43F-27653A9FE59C}"/>
+                <a16:creationId xmlns:a16="http://schemas.microsoft.com/office/drawing/2014/main" id="{D9E7FBF9-9CAA-4B1A-8FE7-F489E927BAA7}"/>
               </a:ext>
             </a:extLst>
           </p:cNvPr>
@@ -2751,8 +3003,8 @@
         </p:nvSpPr>
         <p:spPr>
           <a:xfrm xmlns:a="http://schemas.openxmlformats.org/drawingml/2006/main">
-            <a:off x="6743700" y="4552950"/>
-            <a:ext cx="4476750" cy="742950"/>
+            <a:off x="6572250" y="3343275"/>
+            <a:ext cx="5095875" cy="590550"/>
           </a:xfrm>
           <a:prstGeom xmlns:a="http://schemas.openxmlformats.org/drawingml/2006/main" prst="rect">
             <a:avLst/>
@@ -2764,30 +3016,53 @@
         </p:spPr>
         <p:txBody>
           <a:bodyPr xmlns:a="http://schemas.openxmlformats.org/drawingml/2006/main" anchor="ctr">
-            <a:normAutofit fontScale="100000"/>
+            <a:noAutofit/>
           </a:bodyPr>
           <a:lstStyle xmlns:a="http://schemas.openxmlformats.org/drawingml/2006/main"/>
           <a:p xmlns:a="http://schemas.openxmlformats.org/drawingml/2006/main">
             <a:pPr algn="l">
-              <a:defRPr sz="1650" b="0">
-                <a:solidFill>
-                  <a:srgbClr val="5C6670"/>
-                </a:solidFill>
-                <a:latin typeface="Microsoft YaHei"/>
-                <a:ea typeface="Microsoft YaHei"/>
-                <a:cs typeface="Microsoft YaHei"/>
-              </a:defRPr>
-            </a:pPr>
-            <a:r>
-              <a:rPr sz="1650" b="0">
-                <a:solidFill>
-                  <a:srgbClr val="5C6670"/>
-                </a:solidFill>
-                <a:latin typeface="Microsoft YaHei"/>
-                <a:ea typeface="Microsoft YaHei"/>
-                <a:cs typeface="Microsoft YaHei"/>
-              </a:rPr>
-              <a:t>每个结论都能回到机器可读产物；公开仓库与大权重按许可分层发布。</a:t>
+              <a:defRPr sz="1725" b="0">
+                <a:solidFill>
+                  <a:srgbClr val="17212B"/>
+                </a:solidFill>
+                <a:latin typeface="Microsoft YaHei"/>
+                <a:ea typeface="Microsoft YaHei"/>
+                <a:cs typeface="Microsoft YaHei"/>
+              </a:defRPr>
+            </a:pPr>
+            <a:r>
+              <a:rPr sz="1725" b="0">
+                <a:solidFill>
+                  <a:srgbClr val="17212B"/>
+                </a:solidFill>
+                <a:latin typeface="Microsoft YaHei"/>
+                <a:ea typeface="Microsoft YaHei"/>
+                <a:cs typeface="Microsoft YaHei"/>
+              </a:rPr>
+              <a:t>真实目标进入前 10 的用户比例。</a:t>
+            </a:r>
+          </a:p>
+          <a:p xmlns:a="http://schemas.openxmlformats.org/drawingml/2006/main">
+            <a:pPr algn="l">
+              <a:defRPr sz="1725" b="0">
+                <a:solidFill>
+                  <a:srgbClr val="17212B"/>
+                </a:solidFill>
+                <a:latin typeface="Microsoft YaHei"/>
+                <a:ea typeface="Microsoft YaHei"/>
+                <a:cs typeface="Microsoft YaHei"/>
+              </a:defRPr>
+            </a:pPr>
+            <a:r>
+              <a:rPr sz="1725" b="0">
+                <a:solidFill>
+                  <a:srgbClr val="17212B"/>
+                </a:solidFill>
+                <a:latin typeface="Microsoft YaHei"/>
+                <a:ea typeface="Microsoft YaHei"/>
+                <a:cs typeface="Microsoft YaHei"/>
+              </a:rPr>
+              <a:t>8×512 模型约为 12.08%。</a:t>
             </a:r>
           </a:p>
         </p:txBody>
@@ -2797,7 +3072,7 @@
           <p:cNvPr id="20" name="">
             <a:extLst xmlns:a="http://schemas.openxmlformats.org/drawingml/2006/main">
               <a:ext uri="{FF2B5EF4-FFF2-40B4-BE49-F238E27FC236}">
-                <a16:creationId xmlns:a16="http://schemas.microsoft.com/office/drawing/2014/main" id="{ABFCB58B-837C-4CE1-B6F7-5B3C6B3D9BB4}"/>
+                <a16:creationId xmlns:a16="http://schemas.microsoft.com/office/drawing/2014/main" id="{ADB4057D-491B-44A0-B4D0-E549020D2294}"/>
               </a:ext>
             </a:extLst>
           </p:cNvPr>
@@ -2808,8 +3083,8 @@
         </p:nvSpPr>
         <p:spPr>
           <a:xfrm xmlns:a="http://schemas.openxmlformats.org/drawingml/2006/main">
-            <a:off x="6743700" y="5572125"/>
-            <a:ext cx="4476750" cy="342900"/>
+            <a:off x="6572250" y="4114800"/>
+            <a:ext cx="5095875" cy="314325"/>
           </a:xfrm>
           <a:prstGeom xmlns:a="http://schemas.openxmlformats.org/drawingml/2006/main" prst="rect">
             <a:avLst/>
@@ -2821,30 +3096,30 @@
         </p:spPr>
         <p:txBody>
           <a:bodyPr xmlns:a="http://schemas.openxmlformats.org/drawingml/2006/main" anchor="ctr">
-            <a:normAutofit fontScale="100000"/>
+            <a:noAutofit/>
           </a:bodyPr>
           <a:lstStyle xmlns:a="http://schemas.openxmlformats.org/drawingml/2006/main"/>
           <a:p xmlns:a="http://schemas.openxmlformats.org/drawingml/2006/main">
             <a:pPr algn="l">
-              <a:defRPr sz="1500" b="1">
-                <a:solidFill>
-                  <a:srgbClr val="C84D42"/>
-                </a:solidFill>
-                <a:latin typeface="Microsoft YaHei"/>
-                <a:ea typeface="Microsoft YaHei"/>
-                <a:cs typeface="Microsoft YaHei"/>
-              </a:defRPr>
-            </a:pPr>
-            <a:r>
-              <a:rPr sz="1500" b="1">
-                <a:solidFill>
-                  <a:srgbClr val="C84D42"/>
-                </a:solidFill>
-                <a:latin typeface="Microsoft YaHei"/>
-                <a:ea typeface="Microsoft YaHei"/>
-                <a:cs typeface="Microsoft YaHei"/>
-              </a:rPr>
-              <a:t>公开离线复现，不对应官方榜单</a:t>
+              <a:defRPr sz="1800" b="1">
+                <a:solidFill>
+                  <a:srgbClr val="17212B"/>
+                </a:solidFill>
+                <a:latin typeface="Microsoft YaHei"/>
+                <a:ea typeface="Microsoft YaHei"/>
+                <a:cs typeface="Microsoft YaHei"/>
+              </a:defRPr>
+            </a:pPr>
+            <a:r>
+              <a:rPr sz="1800" b="1">
+                <a:solidFill>
+                  <a:srgbClr val="17212B"/>
+                </a:solidFill>
+                <a:latin typeface="Microsoft YaHei"/>
+                <a:ea typeface="Microsoft YaHei"/>
+                <a:cs typeface="Microsoft YaHei"/>
+              </a:rPr>
+              <a:t>NDCG@10：推荐得够不够靠前</a:t>
             </a:r>
           </a:p>
         </p:txBody>
@@ -2854,7 +3129,7 @@
           <p:cNvPr id="21" name="">
             <a:extLst xmlns:a="http://schemas.openxmlformats.org/drawingml/2006/main">
               <a:ext uri="{FF2B5EF4-FFF2-40B4-BE49-F238E27FC236}">
-                <a16:creationId xmlns:a16="http://schemas.microsoft.com/office/drawing/2014/main" id="{A1C797F8-889B-4AC6-B112-C3DC1F9D416C}"/>
+                <a16:creationId xmlns:a16="http://schemas.microsoft.com/office/drawing/2014/main" id="{965FAEBF-0669-4569-9FF9-88DC3F168958}"/>
               </a:ext>
             </a:extLst>
           </p:cNvPr>
@@ -2865,8 +3140,8 @@
         </p:nvSpPr>
         <p:spPr>
           <a:xfrm xmlns:a="http://schemas.openxmlformats.org/drawingml/2006/main">
-            <a:off x="628650" y="6419850"/>
-            <a:ext cx="10001250" cy="209550"/>
+            <a:off x="6572250" y="4486275"/>
+            <a:ext cx="5095875" cy="314325"/>
           </a:xfrm>
           <a:prstGeom xmlns:a="http://schemas.openxmlformats.org/drawingml/2006/main" prst="rect">
             <a:avLst/>
@@ -2878,12 +3153,126 @@
         </p:spPr>
         <p:txBody>
           <a:bodyPr xmlns:a="http://schemas.openxmlformats.org/drawingml/2006/main" anchor="ctr">
-            <a:normAutofit fontScale="73809"/>
+            <a:noAutofit/>
           </a:bodyPr>
           <a:lstStyle xmlns:a="http://schemas.openxmlformats.org/drawingml/2006/main"/>
           <a:p xmlns:a="http://schemas.openxmlformats.org/drawingml/2006/main">
             <a:pPr algn="l">
-              <a:defRPr sz="1050" b="0">
+              <a:defRPr sz="1725" b="0">
+                <a:solidFill>
+                  <a:srgbClr val="17212B"/>
+                </a:solidFill>
+                <a:latin typeface="Microsoft YaHei"/>
+                <a:ea typeface="Microsoft YaHei"/>
+                <a:cs typeface="Microsoft YaHei"/>
+              </a:defRPr>
+            </a:pPr>
+            <a:r>
+              <a:rPr sz="1725" b="0">
+                <a:solidFill>
+                  <a:srgbClr val="17212B"/>
+                </a:solidFill>
+                <a:latin typeface="Microsoft YaHei"/>
+                <a:ea typeface="Microsoft YaHei"/>
+                <a:cs typeface="Microsoft YaHei"/>
+              </a:rPr>
+              <a:t>目标排得越靠前，得分越高。</a:t>
+            </a:r>
+          </a:p>
+        </p:txBody>
+      </p:sp>
+      <p:sp>
+        <p:nvSpPr>
+          <p:cNvPr id="22" name="">
+            <a:extLst xmlns:a="http://schemas.openxmlformats.org/drawingml/2006/main">
+              <a:ext uri="{FF2B5EF4-FFF2-40B4-BE49-F238E27FC236}">
+                <a16:creationId xmlns:a16="http://schemas.microsoft.com/office/drawing/2014/main" id="{90B9171F-AAB1-476A-914C-B24B382008C6}"/>
+              </a:ext>
+            </a:extLst>
+          </p:cNvPr>
+          <p:cNvSpPr>
+            <a:spLocks xmlns:a="http://schemas.openxmlformats.org/drawingml/2006/main" noGrp="1"/>
+          </p:cNvSpPr>
+          <p:nvPr/>
+        </p:nvSpPr>
+        <p:spPr>
+          <a:xfrm xmlns:a="http://schemas.openxmlformats.org/drawingml/2006/main">
+            <a:off x="6572250" y="4953000"/>
+            <a:ext cx="5095875" cy="381000"/>
+          </a:xfrm>
+          <a:prstGeom xmlns:a="http://schemas.openxmlformats.org/drawingml/2006/main" prst="rect">
+            <a:avLst/>
+          </a:prstGeom>
+          <a:noFill xmlns:a="http://schemas.openxmlformats.org/drawingml/2006/main"/>
+          <a:ln xmlns:a="http://schemas.openxmlformats.org/drawingml/2006/main" w="0">
+            <a:noFill/>
+          </a:ln>
+        </p:spPr>
+        <p:txBody>
+          <a:bodyPr xmlns:a="http://schemas.openxmlformats.org/drawingml/2006/main" anchor="ctr">
+            <a:noAutofit/>
+          </a:bodyPr>
+          <a:lstStyle xmlns:a="http://schemas.openxmlformats.org/drawingml/2006/main"/>
+          <a:p xmlns:a="http://schemas.openxmlformats.org/drawingml/2006/main">
+            <a:pPr algn="l">
+              <a:defRPr sz="1650" b="1">
+                <a:solidFill>
+                  <a:srgbClr val="008A83"/>
+                </a:solidFill>
+                <a:latin typeface="Microsoft YaHei"/>
+                <a:ea typeface="Microsoft YaHei"/>
+                <a:cs typeface="Microsoft YaHei"/>
+              </a:defRPr>
+            </a:pPr>
+            <a:r>
+              <a:rPr sz="1650" b="1">
+                <a:solidFill>
+                  <a:srgbClr val="008A83"/>
+                </a:solidFill>
+                <a:latin typeface="Microsoft YaHei"/>
+                <a:ea typeface="Microsoft YaHei"/>
+                <a:cs typeface="Microsoft YaHei"/>
+              </a:rPr>
+              <a:t>综合分 = 0.31 × HR + 0.69 × NDCG</a:t>
+            </a:r>
+          </a:p>
+        </p:txBody>
+      </p:sp>
+      <p:sp>
+        <p:nvSpPr>
+          <p:cNvPr id="23" name="">
+            <a:extLst xmlns:a="http://schemas.openxmlformats.org/drawingml/2006/main">
+              <a:ext uri="{FF2B5EF4-FFF2-40B4-BE49-F238E27FC236}">
+                <a16:creationId xmlns:a16="http://schemas.microsoft.com/office/drawing/2014/main" id="{74BD3460-72B4-4025-AE3D-35AB3FE08F36}"/>
+              </a:ext>
+            </a:extLst>
+          </p:cNvPr>
+          <p:cNvSpPr>
+            <a:spLocks xmlns:a="http://schemas.openxmlformats.org/drawingml/2006/main" noGrp="1"/>
+          </p:cNvSpPr>
+          <p:nvPr/>
+        </p:nvSpPr>
+        <p:spPr>
+          <a:xfrm xmlns:a="http://schemas.openxmlformats.org/drawingml/2006/main">
+            <a:off x="6572250" y="5381625"/>
+            <a:ext cx="5095875" cy="323850"/>
+          </a:xfrm>
+          <a:prstGeom xmlns:a="http://schemas.openxmlformats.org/drawingml/2006/main" prst="rect">
+            <a:avLst/>
+          </a:prstGeom>
+          <a:noFill xmlns:a="http://schemas.openxmlformats.org/drawingml/2006/main"/>
+          <a:ln xmlns:a="http://schemas.openxmlformats.org/drawingml/2006/main" w="0">
+            <a:noFill/>
+          </a:ln>
+        </p:spPr>
+        <p:txBody>
+          <a:bodyPr xmlns:a="http://schemas.openxmlformats.org/drawingml/2006/main" anchor="ctr">
+            <a:noAutofit/>
+          </a:bodyPr>
+          <a:lstStyle xmlns:a="http://schemas.openxmlformats.org/drawingml/2006/main"/>
+          <a:p xmlns:a="http://schemas.openxmlformats.org/drawingml/2006/main">
+            <a:pPr algn="l">
+              <a:defRPr sz="1650" b="0">
                 <a:solidFill>
                   <a:srgbClr val="5C6670"/>
                 </a:solidFill>
@@ -2893,7 +3282,7 @@
               </a:defRPr>
             </a:pPr>
             <a:r>
-              <a:rPr sz="1050" b="0">
+              <a:rPr sz="1650" b="0">
                 <a:solidFill>
                   <a:srgbClr val="5C6670"/>
                 </a:solidFill>
@@ -2901,7 +3290,121 @@
                 <a:ea typeface="Microsoft YaHei"/>
                 <a:cs typeface="Microsoft YaHei"/>
               </a:rPr>
-              <a:t>项目来源：TencentGR-1M 官方 Baseline 与固定提交的公开 OnePiece 方法</a:t>
+              <a:t>各模型使用相同用户、候选和过滤规则。</a:t>
+            </a:r>
+          </a:p>
+        </p:txBody>
+      </p:sp>
+      <p:sp>
+        <p:nvSpPr>
+          <p:cNvPr id="24" name="">
+            <a:extLst xmlns:a="http://schemas.openxmlformats.org/drawingml/2006/main">
+              <a:ext uri="{FF2B5EF4-FFF2-40B4-BE49-F238E27FC236}">
+                <a16:creationId xmlns:a16="http://schemas.microsoft.com/office/drawing/2014/main" id="{F18D2A75-173B-4A6A-A5E4-2D47841EB121}"/>
+              </a:ext>
+            </a:extLst>
+          </p:cNvPr>
+          <p:cNvSpPr>
+            <a:spLocks xmlns:a="http://schemas.openxmlformats.org/drawingml/2006/main" noGrp="1"/>
+          </p:cNvSpPr>
+          <p:nvPr/>
+        </p:nvSpPr>
+        <p:spPr>
+          <a:xfrm xmlns:a="http://schemas.openxmlformats.org/drawingml/2006/main">
+            <a:off x="571500" y="5953125"/>
+            <a:ext cx="11010900" cy="381000"/>
+          </a:xfrm>
+          <a:prstGeom xmlns:a="http://schemas.openxmlformats.org/drawingml/2006/main" prst="rect">
+            <a:avLst/>
+          </a:prstGeom>
+          <a:noFill xmlns:a="http://schemas.openxmlformats.org/drawingml/2006/main"/>
+          <a:ln xmlns:a="http://schemas.openxmlformats.org/drawingml/2006/main" w="0">
+            <a:noFill/>
+          </a:ln>
+        </p:spPr>
+        <p:txBody>
+          <a:bodyPr xmlns:a="http://schemas.openxmlformats.org/drawingml/2006/main" anchor="ctr">
+            <a:noAutofit/>
+          </a:bodyPr>
+          <a:lstStyle xmlns:a="http://schemas.openxmlformats.org/drawingml/2006/main"/>
+          <a:p xmlns:a="http://schemas.openxmlformats.org/drawingml/2006/main">
+            <a:pPr algn="l">
+              <a:defRPr sz="1800" b="1">
+                <a:solidFill>
+                  <a:srgbClr val="008A83"/>
+                </a:solidFill>
+                <a:latin typeface="Microsoft YaHei"/>
+                <a:ea typeface="Microsoft YaHei"/>
+                <a:cs typeface="Microsoft YaHei"/>
+              </a:defRPr>
+            </a:pPr>
+            <a:r>
+              <a:rPr sz="1800" b="1">
+                <a:solidFill>
+                  <a:srgbClr val="008A83"/>
+                </a:solidFill>
+                <a:latin typeface="Microsoft YaHei"/>
+                <a:ea typeface="Microsoft YaHei"/>
+                <a:cs typeface="Microsoft YaHei"/>
+              </a:rPr>
+              <a:t>我的工作：复现训练、设计对照、修复 SID、核对评测与交付。</a:t>
+            </a:r>
+          </a:p>
+        </p:txBody>
+      </p:sp>
+      <p:sp>
+        <p:nvSpPr>
+          <p:cNvPr id="25" name="">
+            <a:extLst xmlns:a="http://schemas.openxmlformats.org/drawingml/2006/main">
+              <a:ext uri="{FF2B5EF4-FFF2-40B4-BE49-F238E27FC236}">
+                <a16:creationId xmlns:a16="http://schemas.microsoft.com/office/drawing/2014/main" id="{9DD6FCCC-BD2B-4B8A-BB5A-FDD758A0E995}"/>
+              </a:ext>
+            </a:extLst>
+          </p:cNvPr>
+          <p:cNvSpPr>
+            <a:spLocks xmlns:a="http://schemas.openxmlformats.org/drawingml/2006/main" noGrp="1"/>
+          </p:cNvSpPr>
+          <p:nvPr/>
+        </p:nvSpPr>
+        <p:spPr>
+          <a:xfrm xmlns:a="http://schemas.openxmlformats.org/drawingml/2006/main">
+            <a:off x="571500" y="6486525"/>
+            <a:ext cx="11049000" cy="228600"/>
+          </a:xfrm>
+          <a:prstGeom xmlns:a="http://schemas.openxmlformats.org/drawingml/2006/main" prst="rect">
+            <a:avLst/>
+          </a:prstGeom>
+          <a:noFill xmlns:a="http://schemas.openxmlformats.org/drawingml/2006/main"/>
+          <a:ln xmlns:a="http://schemas.openxmlformats.org/drawingml/2006/main" w="0">
+            <a:noFill/>
+          </a:ln>
+        </p:spPr>
+        <p:txBody>
+          <a:bodyPr xmlns:a="http://schemas.openxmlformats.org/drawingml/2006/main" anchor="ctr">
+            <a:noAutofit/>
+          </a:bodyPr>
+          <a:lstStyle xmlns:a="http://schemas.openxmlformats.org/drawingml/2006/main"/>
+          <a:p xmlns:a="http://schemas.openxmlformats.org/drawingml/2006/main">
+            <a:pPr algn="l">
+              <a:defRPr sz="1125" b="0">
+                <a:solidFill>
+                  <a:srgbClr val="5C6670"/>
+                </a:solidFill>
+                <a:latin typeface="Microsoft YaHei"/>
+                <a:ea typeface="Microsoft YaHei"/>
+                <a:cs typeface="Microsoft YaHei"/>
+              </a:defRPr>
+            </a:pPr>
+            <a:r>
+              <a:rPr sz="1125" b="0">
+                <a:solidFill>
+                  <a:srgbClr val="5C6670"/>
+                </a:solidFill>
+                <a:latin typeface="Microsoft YaHei"/>
+                <a:ea typeface="Microsoft YaHei"/>
+                <a:cs typeface="Microsoft YaHei"/>
+              </a:rPr>
+              <a:t>基于腾讯官方 Baseline 与公开 OnePiece 方法的离线复现；不是官方榜单成绩。精确数量与来源见备注。</a:t>
             </a:r>
           </a:p>
         </p:txBody>
@@ -2935,12 +3438,28 @@
       <p:grpSpPr>
         <a:xfrm xmlns:a="http://schemas.openxmlformats.org/drawingml/2006/main"/>
       </p:grpSpPr>
-      <p:sp>
-        <p:nvSpPr>
-          <p:cNvPr id="11" name="">
+      <p:graphicFrame>
+        <p:nvGraphicFramePr>
+          <p:cNvPr id="28" name="Chart"/>
+          <p:cNvGraphicFramePr/>
+          <p:nvPr/>
+        </p:nvGraphicFramePr>
+        <p:xfrm>
+          <a:off xmlns:a="http://schemas.openxmlformats.org/drawingml/2006/main" x="5534025" y="1943100"/>
+          <a:ext xmlns:a="http://schemas.openxmlformats.org/drawingml/2006/main" cx="6191250" cy="2219325"/>
+        </p:xfrm>
+        <a:graphic xmlns:a="http://schemas.openxmlformats.org/drawingml/2006/main">
+          <a:graphicData uri="http://schemas.openxmlformats.org/drawingml/2006/chart">
+            <c:chart xmlns:r="http://schemas.openxmlformats.org/officeDocument/2006/relationships" xmlns:c="http://schemas.openxmlformats.org/drawingml/2006/chart" r:id="R5b6a33707d1a4ad4"/>
+          </a:graphicData>
+        </a:graphic>
+      </p:graphicFrame>
+      <p:sp>
+        <p:nvSpPr>
+          <p:cNvPr id="13" name="">
             <a:extLst xmlns:a="http://schemas.openxmlformats.org/drawingml/2006/main">
               <a:ext uri="{FF2B5EF4-FFF2-40B4-BE49-F238E27FC236}">
-                <a16:creationId xmlns:a16="http://schemas.microsoft.com/office/drawing/2014/main" id="{64EA368F-8270-4ADB-A7F0-7D9B7CF4CDE1}"/>
+                <a16:creationId xmlns:a16="http://schemas.microsoft.com/office/drawing/2014/main" id="{55CF46A0-94DE-48C8-BD87-03EBC1143C33}"/>
               </a:ext>
             </a:extLst>
           </p:cNvPr>
@@ -2951,8 +3470,8 @@
         </p:nvSpPr>
         <p:spPr>
           <a:xfrm xmlns:a="http://schemas.openxmlformats.org/drawingml/2006/main">
-            <a:off x="11353800" y="438150"/>
-            <a:ext cx="400050" cy="266700"/>
+            <a:off x="514350" y="304800"/>
+            <a:ext cx="10572750" cy="590550"/>
           </a:xfrm>
           <a:prstGeom xmlns:a="http://schemas.openxmlformats.org/drawingml/2006/main" prst="rect">
             <a:avLst/>
@@ -2964,40 +3483,40 @@
         </p:spPr>
         <p:txBody>
           <a:bodyPr xmlns:a="http://schemas.openxmlformats.org/drawingml/2006/main" anchor="ctr">
-            <a:normAutofit fontScale="95833"/>
+            <a:noAutofit/>
           </a:bodyPr>
           <a:lstStyle xmlns:a="http://schemas.openxmlformats.org/drawingml/2006/main"/>
           <a:p xmlns:a="http://schemas.openxmlformats.org/drawingml/2006/main">
-            <a:pPr algn="r">
-              <a:defRPr sz="1200" b="0">
-                <a:solidFill>
-                  <a:srgbClr val="5C6670"/>
-                </a:solidFill>
-                <a:latin typeface="Microsoft YaHei"/>
-                <a:ea typeface="Microsoft YaHei"/>
-                <a:cs typeface="Microsoft YaHei"/>
-              </a:defRPr>
-            </a:pPr>
-            <a:r>
-              <a:rPr sz="1200" b="0">
-                <a:solidFill>
-                  <a:srgbClr val="5C6670"/>
-                </a:solidFill>
-                <a:latin typeface="Microsoft YaHei"/>
-                <a:ea typeface="Microsoft YaHei"/>
-                <a:cs typeface="Microsoft YaHei"/>
-              </a:rPr>
-              <a:t>02</a:t>
-            </a:r>
-          </a:p>
-        </p:txBody>
-      </p:sp>
-      <p:sp>
-        <p:nvSpPr>
-          <p:cNvPr id="2" name="">
+            <a:pPr algn="l">
+              <a:defRPr sz="3150" b="1">
+                <a:solidFill>
+                  <a:srgbClr val="17212B"/>
+                </a:solidFill>
+                <a:latin typeface="Microsoft YaHei"/>
+                <a:ea typeface="Microsoft YaHei"/>
+                <a:cs typeface="Microsoft YaHei"/>
+              </a:defRPr>
+            </a:pPr>
+            <a:r>
+              <a:rPr sz="3150" b="1">
+                <a:solidFill>
+                  <a:srgbClr val="17212B"/>
+                </a:solidFill>
+                <a:latin typeface="Microsoft YaHei"/>
+                <a:ea typeface="Microsoft YaHei"/>
+                <a:cs typeface="Microsoft YaHei"/>
+              </a:rPr>
+              <a:t>模型方法与结果：结构对照 + 容量扩展</a:t>
+            </a:r>
+          </a:p>
+        </p:txBody>
+      </p:sp>
+      <p:sp>
+        <p:nvSpPr>
+          <p:cNvPr id="14" name="">
             <a:extLst xmlns:a="http://schemas.openxmlformats.org/drawingml/2006/main">
               <a:ext uri="{FF2B5EF4-FFF2-40B4-BE49-F238E27FC236}">
-                <a16:creationId xmlns:a16="http://schemas.microsoft.com/office/drawing/2014/main" id="{E73EE25A-43DD-49C5-9107-4A890719D066}"/>
+                <a16:creationId xmlns:a16="http://schemas.microsoft.com/office/drawing/2014/main" id="{1AF9E7E6-5669-4C23-8E91-6E9530D2773D}"/>
               </a:ext>
             </a:extLst>
           </p:cNvPr>
@@ -3008,8 +3527,8 @@
         </p:nvSpPr>
         <p:spPr>
           <a:xfrm xmlns:a="http://schemas.openxmlformats.org/drawingml/2006/main">
-            <a:off x="609600" y="400050"/>
-            <a:ext cx="9906000" cy="590550"/>
+            <a:off x="542925" y="952500"/>
+            <a:ext cx="11106150" cy="381000"/>
           </a:xfrm>
           <a:prstGeom xmlns:a="http://schemas.openxmlformats.org/drawingml/2006/main" prst="rect">
             <a:avLst/>
@@ -3021,40 +3540,40 @@
         </p:spPr>
         <p:txBody>
           <a:bodyPr xmlns:a="http://schemas.openxmlformats.org/drawingml/2006/main" anchor="ctr">
-            <a:normAutofit fontScale="97037"/>
+            <a:noAutofit/>
           </a:bodyPr>
           <a:lstStyle xmlns:a="http://schemas.openxmlformats.org/drawingml/2006/main"/>
           <a:p xmlns:a="http://schemas.openxmlformats.org/drawingml/2006/main">
             <a:pPr algn="l">
-              <a:defRPr sz="3375" b="1">
-                <a:solidFill>
-                  <a:srgbClr val="17212B"/>
-                </a:solidFill>
-                <a:latin typeface="Microsoft YaHei"/>
-                <a:ea typeface="Microsoft YaHei"/>
-                <a:cs typeface="Microsoft YaHei"/>
-              </a:defRPr>
-            </a:pPr>
-            <a:r>
-              <a:rPr sz="3375" b="1">
-                <a:solidFill>
-                  <a:srgbClr val="17212B"/>
-                </a:solidFill>
-                <a:latin typeface="Microsoft YaHei"/>
-                <a:ea typeface="Microsoft YaHei"/>
-                <a:cs typeface="Microsoft YaHei"/>
-              </a:rPr>
-              <a:t>同协议对照分开回答架构与容量问题</a:t>
-            </a:r>
-          </a:p>
-        </p:txBody>
-      </p:sp>
-      <p:sp>
-        <p:nvSpPr>
-          <p:cNvPr id="3" name="">
+              <a:defRPr sz="1650" b="0">
+                <a:solidFill>
+                  <a:srgbClr val="5C6670"/>
+                </a:solidFill>
+                <a:latin typeface="Microsoft YaHei"/>
+                <a:ea typeface="Microsoft YaHei"/>
+                <a:cs typeface="Microsoft YaHei"/>
+              </a:defRPr>
+            </a:pPr>
+            <a:r>
+              <a:rPr sz="1650" b="0">
+                <a:solidFill>
+                  <a:srgbClr val="5C6670"/>
+                </a:solidFill>
+                <a:latin typeface="Microsoft YaHei"/>
+                <a:ea typeface="Microsoft YaHei"/>
+                <a:cs typeface="Microsoft YaHei"/>
+              </a:rPr>
+              <a:t>4×128 表示 4 层、向量维度 128；模型对照固定数据、训练设置和评测规则。</a:t>
+            </a:r>
+          </a:p>
+        </p:txBody>
+      </p:sp>
+      <p:sp>
+        <p:nvSpPr>
+          <p:cNvPr id="15" name="">
             <a:extLst xmlns:a="http://schemas.openxmlformats.org/drawingml/2006/main">
               <a:ext uri="{FF2B5EF4-FFF2-40B4-BE49-F238E27FC236}">
-                <a16:creationId xmlns:a16="http://schemas.microsoft.com/office/drawing/2014/main" id="{437BF9AC-850C-4523-88B9-28E62FA51883}"/>
+                <a16:creationId xmlns:a16="http://schemas.microsoft.com/office/drawing/2014/main" id="{2BB50AF8-A8FB-4AFE-B61D-CCD628FADAC4}"/>
               </a:ext>
             </a:extLst>
           </p:cNvPr>
@@ -3065,8 +3584,8 @@
         </p:nvSpPr>
         <p:spPr>
           <a:xfrm xmlns:a="http://schemas.openxmlformats.org/drawingml/2006/main">
-            <a:off x="628650" y="1028700"/>
-            <a:ext cx="9906000" cy="323850"/>
+            <a:off x="11334750" y="409575"/>
+            <a:ext cx="361950" cy="266700"/>
           </a:xfrm>
           <a:prstGeom xmlns:a="http://schemas.openxmlformats.org/drawingml/2006/main" prst="rect">
             <a:avLst/>
@@ -3078,12 +3597,12 @@
         </p:spPr>
         <p:txBody>
           <a:bodyPr xmlns:a="http://schemas.openxmlformats.org/drawingml/2006/main" anchor="ctr">
-            <a:normAutofit fontScale="92424"/>
+            <a:noAutofit/>
           </a:bodyPr>
           <a:lstStyle xmlns:a="http://schemas.openxmlformats.org/drawingml/2006/main"/>
           <a:p xmlns:a="http://schemas.openxmlformats.org/drawingml/2006/main">
-            <a:pPr algn="l">
-              <a:defRPr sz="1650" b="0">
+            <a:pPr algn="r">
+              <a:defRPr sz="1200" b="0">
                 <a:solidFill>
                   <a:srgbClr val="5C6670"/>
                 </a:solidFill>
@@ -3093,7 +3612,7 @@
               </a:defRPr>
             </a:pPr>
             <a:r>
-              <a:rPr sz="1650" b="0">
+              <a:rPr sz="1200" b="0">
                 <a:solidFill>
                   <a:srgbClr val="5C6670"/>
                 </a:solidFill>
@@ -3101,17 +3620,17 @@
                 <a:ea typeface="Microsoft YaHei"/>
                 <a:cs typeface="Microsoft YaHei"/>
               </a:rPr>
-              <a:t>固定 seed 综合分，78,921 个用户与 66 万候选逐行对齐</a:t>
-            </a:r>
-          </a:p>
-        </p:txBody>
-      </p:sp>
-      <p:sp>
-        <p:nvSpPr>
-          <p:cNvPr id="4" name="">
+              <a:t>02</a:t>
+            </a:r>
+          </a:p>
+        </p:txBody>
+      </p:sp>
+      <p:sp>
+        <p:nvSpPr>
+          <p:cNvPr id="16" name="">
             <a:extLst xmlns:a="http://schemas.openxmlformats.org/drawingml/2006/main">
               <a:ext uri="{FF2B5EF4-FFF2-40B4-BE49-F238E27FC236}">
-                <a16:creationId xmlns:a16="http://schemas.microsoft.com/office/drawing/2014/main" id="{F98BFB8A-3F15-4746-B9D3-8E6076DD1BE5}"/>
+                <a16:creationId xmlns:a16="http://schemas.microsoft.com/office/drawing/2014/main" id="{57178218-FE45-4CF9-828A-FBA9624C2132}"/>
               </a:ext>
             </a:extLst>
           </p:cNvPr>
@@ -3122,8 +3641,8 @@
         </p:nvSpPr>
         <p:spPr>
           <a:xfrm xmlns:a="http://schemas.openxmlformats.org/drawingml/2006/main">
-            <a:off x="704850" y="1504950"/>
-            <a:ext cx="2381250" cy="228600"/>
+            <a:off x="571500" y="1504950"/>
+            <a:ext cx="4857750" cy="342900"/>
           </a:xfrm>
           <a:prstGeom xmlns:a="http://schemas.openxmlformats.org/drawingml/2006/main" prst="rect">
             <a:avLst/>
@@ -3135,56 +3654,40 @@
         </p:spPr>
         <p:txBody>
           <a:bodyPr xmlns:a="http://schemas.openxmlformats.org/drawingml/2006/main" anchor="ctr">
-            <a:normAutofit fontScale="70588"/>
+            <a:noAutofit/>
           </a:bodyPr>
           <a:lstStyle xmlns:a="http://schemas.openxmlformats.org/drawingml/2006/main"/>
           <a:p xmlns:a="http://schemas.openxmlformats.org/drawingml/2006/main">
             <a:pPr algn="l">
-              <a:defRPr sz="1275" b="0">
-                <a:solidFill>
-                  <a:srgbClr val="5C6670"/>
-                </a:solidFill>
-                <a:latin typeface="Microsoft YaHei"/>
-                <a:ea typeface="Microsoft YaHei"/>
-                <a:cs typeface="Microsoft YaHei"/>
-              </a:defRPr>
-            </a:pPr>
-            <a:r>
-              <a:rPr sz="1275" b="0">
-                <a:solidFill>
-                  <a:srgbClr val="5C6670"/>
-                </a:solidFill>
-                <a:latin typeface="Microsoft YaHei"/>
-                <a:ea typeface="Microsoft YaHei"/>
-                <a:cs typeface="Microsoft YaHei"/>
-              </a:rPr>
-              <a:t>综合分（0–0.09）</a:t>
-            </a:r>
-          </a:p>
-        </p:txBody>
-      </p:sp>
-      <p:graphicFrame>
-        <p:nvGraphicFramePr>
-          <p:cNvPr id="15" name="Chart"/>
-          <p:cNvGraphicFramePr/>
-          <p:nvPr/>
-        </p:nvGraphicFramePr>
-        <p:xfrm>
-          <a:off xmlns:a="http://schemas.openxmlformats.org/drawingml/2006/main" x="552450" y="1695450"/>
-          <a:ext xmlns:a="http://schemas.openxmlformats.org/drawingml/2006/main" cx="7524750" cy="4171950"/>
-        </p:xfrm>
-        <a:graphic xmlns:a="http://schemas.openxmlformats.org/drawingml/2006/main">
-          <a:graphicData uri="http://schemas.openxmlformats.org/drawingml/2006/chart">
-            <c:chart xmlns:r="http://schemas.openxmlformats.org/officeDocument/2006/relationships" xmlns:c="http://schemas.openxmlformats.org/drawingml/2006/chart" r:id="R88d5d8c32dee462f"/>
-          </a:graphicData>
-        </a:graphic>
-      </p:graphicFrame>
-      <p:sp>
-        <p:nvSpPr>
-          <p:cNvPr id="6" name="">
+              <a:defRPr sz="1950" b="1">
+                <a:solidFill>
+                  <a:srgbClr val="008A83"/>
+                </a:solidFill>
+                <a:latin typeface="Microsoft YaHei"/>
+                <a:ea typeface="Microsoft YaHei"/>
+                <a:cs typeface="Microsoft YaHei"/>
+              </a:defRPr>
+            </a:pPr>
+            <a:r>
+              <a:rPr sz="1950" b="1">
+                <a:solidFill>
+                  <a:srgbClr val="008A83"/>
+                </a:solidFill>
+                <a:latin typeface="Microsoft YaHei"/>
+                <a:ea typeface="Microsoft YaHei"/>
+                <a:cs typeface="Microsoft YaHei"/>
+              </a:rPr>
+              <a:t>三个术语，用一句话说清</a:t>
+            </a:r>
+          </a:p>
+        </p:txBody>
+      </p:sp>
+      <p:sp>
+        <p:nvSpPr>
+          <p:cNvPr id="17" name="">
             <a:extLst xmlns:a="http://schemas.openxmlformats.org/drawingml/2006/main">
               <a:ext uri="{FF2B5EF4-FFF2-40B4-BE49-F238E27FC236}">
-                <a16:creationId xmlns:a16="http://schemas.microsoft.com/office/drawing/2014/main" id="{74F347D4-F53B-4CD5-A2DE-34B4AB61DC36}"/>
+                <a16:creationId xmlns:a16="http://schemas.microsoft.com/office/drawing/2014/main" id="{C88B0929-F29F-4E12-94E5-A9F91187577A}"/>
               </a:ext>
             </a:extLst>
           </p:cNvPr>
@@ -3195,8 +3698,8 @@
         </p:nvSpPr>
         <p:spPr>
           <a:xfrm xmlns:a="http://schemas.openxmlformats.org/drawingml/2006/main">
-            <a:off x="8620125" y="1952625"/>
-            <a:ext cx="2714625" cy="666750"/>
+            <a:off x="571500" y="2009775"/>
+            <a:ext cx="4714875" cy="323850"/>
           </a:xfrm>
           <a:prstGeom xmlns:a="http://schemas.openxmlformats.org/drawingml/2006/main" prst="rect">
             <a:avLst/>
@@ -3208,40 +3711,40 @@
         </p:spPr>
         <p:txBody>
           <a:bodyPr xmlns:a="http://schemas.openxmlformats.org/drawingml/2006/main" anchor="ctr">
-            <a:normAutofit fontScale="96795"/>
+            <a:noAutofit/>
           </a:bodyPr>
           <a:lstStyle xmlns:a="http://schemas.openxmlformats.org/drawingml/2006/main"/>
           <a:p xmlns:a="http://schemas.openxmlformats.org/drawingml/2006/main">
             <a:pPr algn="l">
-              <a:defRPr sz="3900" b="1">
-                <a:solidFill>
-                  <a:srgbClr val="008A83"/>
-                </a:solidFill>
-                <a:latin typeface="Microsoft YaHei"/>
-                <a:ea typeface="Microsoft YaHei"/>
-                <a:cs typeface="Microsoft YaHei"/>
-              </a:defRPr>
-            </a:pPr>
-            <a:r>
-              <a:rPr sz="3900" b="1">
-                <a:solidFill>
-                  <a:srgbClr val="008A83"/>
-                </a:solidFill>
-                <a:latin typeface="Microsoft YaHei"/>
-                <a:ea typeface="Microsoft YaHei"/>
-                <a:cs typeface="Microsoft YaHei"/>
-              </a:rPr>
-              <a:t>+4.10%</a:t>
-            </a:r>
-          </a:p>
-        </p:txBody>
-      </p:sp>
-      <p:sp>
-        <p:nvSpPr>
-          <p:cNvPr id="7" name="">
+              <a:defRPr sz="1800" b="1">
+                <a:solidFill>
+                  <a:srgbClr val="17212B"/>
+                </a:solidFill>
+                <a:latin typeface="Microsoft YaHei"/>
+                <a:ea typeface="Microsoft YaHei"/>
+                <a:cs typeface="Microsoft YaHei"/>
+              </a:defRPr>
+            </a:pPr>
+            <a:r>
+              <a:rPr sz="1800" b="1">
+                <a:solidFill>
+                  <a:srgbClr val="17212B"/>
+                </a:solidFill>
+                <a:latin typeface="Microsoft YaHei"/>
+                <a:ea typeface="Microsoft YaHei"/>
+                <a:cs typeface="Microsoft YaHei"/>
+              </a:rPr>
+              <a:t>HSTU｜处理历史记录</a:t>
+            </a:r>
+          </a:p>
+        </p:txBody>
+      </p:sp>
+      <p:sp>
+        <p:nvSpPr>
+          <p:cNvPr id="18" name="">
             <a:extLst xmlns:a="http://schemas.openxmlformats.org/drawingml/2006/main">
               <a:ext uri="{FF2B5EF4-FFF2-40B4-BE49-F238E27FC236}">
-                <a16:creationId xmlns:a16="http://schemas.microsoft.com/office/drawing/2014/main" id="{CD4ADF91-D29C-4BCF-A4F6-BD4AB7A26648}"/>
+                <a16:creationId xmlns:a16="http://schemas.microsoft.com/office/drawing/2014/main" id="{7B7157DD-6169-43F7-88CA-A5E2C7B42E8B}"/>
               </a:ext>
             </a:extLst>
           </p:cNvPr>
@@ -3252,8 +3755,8 @@
         </p:nvSpPr>
         <p:spPr>
           <a:xfrm xmlns:a="http://schemas.openxmlformats.org/drawingml/2006/main">
-            <a:off x="8648700" y="2619375"/>
-            <a:ext cx="2714625" cy="666750"/>
+            <a:off x="571500" y="2409825"/>
+            <a:ext cx="4743450" cy="628650"/>
           </a:xfrm>
           <a:prstGeom xmlns:a="http://schemas.openxmlformats.org/drawingml/2006/main" prst="rect">
             <a:avLst/>
@@ -3265,40 +3768,63 @@
         </p:spPr>
         <p:txBody>
           <a:bodyPr xmlns:a="http://schemas.openxmlformats.org/drawingml/2006/main" anchor="ctr">
-            <a:normAutofit fontScale="100000"/>
+            <a:noAutofit/>
           </a:bodyPr>
           <a:lstStyle xmlns:a="http://schemas.openxmlformats.org/drawingml/2006/main"/>
           <a:p xmlns:a="http://schemas.openxmlformats.org/drawingml/2006/main">
             <a:pPr algn="l">
-              <a:defRPr sz="1650" b="0">
-                <a:solidFill>
-                  <a:srgbClr val="17212B"/>
-                </a:solidFill>
-                <a:latin typeface="Microsoft YaHei"/>
-                <a:ea typeface="Microsoft YaHei"/>
-                <a:cs typeface="Microsoft YaHei"/>
-              </a:defRPr>
-            </a:pPr>
-            <a:r>
-              <a:rPr sz="1650" b="0">
-                <a:solidFill>
-                  <a:srgbClr val="17212B"/>
-                </a:solidFill>
-                <a:latin typeface="Microsoft YaHei"/>
-                <a:ea typeface="Microsoft YaHei"/>
-                <a:cs typeface="Microsoft YaHei"/>
-              </a:rPr>
-              <a:t>HSTU 4×128 相对同预算 Transformer</a:t>
-            </a:r>
-          </a:p>
-        </p:txBody>
-      </p:sp>
-      <p:sp>
-        <p:nvSpPr>
-          <p:cNvPr id="8" name="">
+              <a:defRPr sz="1725" b="0">
+                <a:solidFill>
+                  <a:srgbClr val="17212B"/>
+                </a:solidFill>
+                <a:latin typeface="Microsoft YaHei"/>
+                <a:ea typeface="Microsoft YaHei"/>
+                <a:cs typeface="Microsoft YaHei"/>
+              </a:defRPr>
+            </a:pPr>
+            <a:r>
+              <a:rPr sz="1725" b="0">
+                <a:solidFill>
+                  <a:srgbClr val="17212B"/>
+                </a:solidFill>
+                <a:latin typeface="Microsoft YaHei"/>
+                <a:ea typeface="Microsoft YaHei"/>
+                <a:cs typeface="Microsoft YaHei"/>
+              </a:rPr>
+              <a:t>给历史记录分配权重，</a:t>
+            </a:r>
+          </a:p>
+          <a:p xmlns:a="http://schemas.openxmlformats.org/drawingml/2006/main">
+            <a:pPr algn="l">
+              <a:defRPr sz="1725" b="0">
+                <a:solidFill>
+                  <a:srgbClr val="17212B"/>
+                </a:solidFill>
+                <a:latin typeface="Microsoft YaHei"/>
+                <a:ea typeface="Microsoft YaHei"/>
+                <a:cs typeface="Microsoft YaHei"/>
+              </a:defRPr>
+            </a:pPr>
+            <a:r>
+              <a:rPr sz="1725" b="0">
+                <a:solidFill>
+                  <a:srgbClr val="17212B"/>
+                </a:solidFill>
+                <a:latin typeface="Microsoft YaHei"/>
+                <a:ea typeface="Microsoft YaHei"/>
+                <a:cs typeface="Microsoft YaHei"/>
+              </a:rPr>
+              <a:t>再用门控决定保留多少信息。</a:t>
+            </a:r>
+          </a:p>
+        </p:txBody>
+      </p:sp>
+      <p:sp>
+        <p:nvSpPr>
+          <p:cNvPr id="19" name="">
             <a:extLst xmlns:a="http://schemas.openxmlformats.org/drawingml/2006/main">
               <a:ext uri="{FF2B5EF4-FFF2-40B4-BE49-F238E27FC236}">
-                <a16:creationId xmlns:a16="http://schemas.microsoft.com/office/drawing/2014/main" id="{F1CC751C-682F-4AE3-BBFE-23AD0C80F7AA}"/>
+                <a16:creationId xmlns:a16="http://schemas.microsoft.com/office/drawing/2014/main" id="{6126F38E-C040-45F9-91AB-AC69A42ED630}"/>
               </a:ext>
             </a:extLst>
           </p:cNvPr>
@@ -3309,8 +3835,8 @@
         </p:nvSpPr>
         <p:spPr>
           <a:xfrm xmlns:a="http://schemas.openxmlformats.org/drawingml/2006/main">
-            <a:off x="8620125" y="3733800"/>
-            <a:ext cx="2714625" cy="666750"/>
+            <a:off x="571500" y="3219450"/>
+            <a:ext cx="4714875" cy="323850"/>
           </a:xfrm>
           <a:prstGeom xmlns:a="http://schemas.openxmlformats.org/drawingml/2006/main" prst="rect">
             <a:avLst/>
@@ -3322,40 +3848,40 @@
         </p:spPr>
         <p:txBody>
           <a:bodyPr xmlns:a="http://schemas.openxmlformats.org/drawingml/2006/main" anchor="ctr">
-            <a:normAutofit fontScale="96795"/>
+            <a:noAutofit/>
           </a:bodyPr>
           <a:lstStyle xmlns:a="http://schemas.openxmlformats.org/drawingml/2006/main"/>
           <a:p xmlns:a="http://schemas.openxmlformats.org/drawingml/2006/main">
             <a:pPr algn="l">
-              <a:defRPr sz="3900" b="1">
-                <a:solidFill>
-                  <a:srgbClr val="E7743A"/>
-                </a:solidFill>
-                <a:latin typeface="Microsoft YaHei"/>
-                <a:ea typeface="Microsoft YaHei"/>
-                <a:cs typeface="Microsoft YaHei"/>
-              </a:defRPr>
-            </a:pPr>
-            <a:r>
-              <a:rPr sz="3900" b="1">
-                <a:solidFill>
-                  <a:srgbClr val="E7743A"/>
-                </a:solidFill>
-                <a:latin typeface="Microsoft YaHei"/>
-                <a:ea typeface="Microsoft YaHei"/>
-                <a:cs typeface="Microsoft YaHei"/>
-              </a:rPr>
-              <a:t>+25.63%</a:t>
-            </a:r>
-          </a:p>
-        </p:txBody>
-      </p:sp>
-      <p:sp>
-        <p:nvSpPr>
-          <p:cNvPr id="9" name="">
+              <a:defRPr sz="1800" b="1">
+                <a:solidFill>
+                  <a:srgbClr val="17212B"/>
+                </a:solidFill>
+                <a:latin typeface="Microsoft YaHei"/>
+                <a:ea typeface="Microsoft YaHei"/>
+                <a:cs typeface="Microsoft YaHei"/>
+              </a:defRPr>
+            </a:pPr>
+            <a:r>
+              <a:rPr sz="1800" b="1">
+                <a:solidFill>
+                  <a:srgbClr val="17212B"/>
+                </a:solidFill>
+                <a:latin typeface="Microsoft YaHei"/>
+                <a:ea typeface="Microsoft YaHei"/>
+                <a:cs typeface="Microsoft YaHei"/>
+              </a:rPr>
+              <a:t>InfoNCE｜模型怎样学习</a:t>
+            </a:r>
+          </a:p>
+        </p:txBody>
+      </p:sp>
+      <p:sp>
+        <p:nvSpPr>
+          <p:cNvPr id="20" name="">
             <a:extLst xmlns:a="http://schemas.openxmlformats.org/drawingml/2006/main">
               <a:ext uri="{FF2B5EF4-FFF2-40B4-BE49-F238E27FC236}">
-                <a16:creationId xmlns:a16="http://schemas.microsoft.com/office/drawing/2014/main" id="{14C59EC7-B1D6-4E53-9874-A6E6F7AEFF1A}"/>
+                <a16:creationId xmlns:a16="http://schemas.microsoft.com/office/drawing/2014/main" id="{FCB58750-B181-45BB-AA0A-4027418C806E}"/>
               </a:ext>
             </a:extLst>
           </p:cNvPr>
@@ -3366,8 +3892,8 @@
         </p:nvSpPr>
         <p:spPr>
           <a:xfrm xmlns:a="http://schemas.openxmlformats.org/drawingml/2006/main">
-            <a:off x="8648700" y="4400550"/>
-            <a:ext cx="2714625" cy="838200"/>
+            <a:off x="571500" y="3619500"/>
+            <a:ext cx="4743450" cy="628650"/>
           </a:xfrm>
           <a:prstGeom xmlns:a="http://schemas.openxmlformats.org/drawingml/2006/main" prst="rect">
             <a:avLst/>
@@ -3379,40 +3905,63 @@
         </p:spPr>
         <p:txBody>
           <a:bodyPr xmlns:a="http://schemas.openxmlformats.org/drawingml/2006/main" anchor="ctr">
-            <a:normAutofit fontScale="100000"/>
+            <a:noAutofit/>
           </a:bodyPr>
           <a:lstStyle xmlns:a="http://schemas.openxmlformats.org/drawingml/2006/main"/>
           <a:p xmlns:a="http://schemas.openxmlformats.org/drawingml/2006/main">
             <a:pPr algn="l">
-              <a:defRPr sz="1650" b="0">
-                <a:solidFill>
-                  <a:srgbClr val="17212B"/>
-                </a:solidFill>
-                <a:latin typeface="Microsoft YaHei"/>
-                <a:ea typeface="Microsoft YaHei"/>
-                <a:cs typeface="Microsoft YaHei"/>
-              </a:defRPr>
-            </a:pPr>
-            <a:r>
-              <a:rPr sz="1650" b="0">
-                <a:solidFill>
-                  <a:srgbClr val="17212B"/>
-                </a:solidFill>
-                <a:latin typeface="Microsoft YaHei"/>
-                <a:ea typeface="Microsoft YaHei"/>
-                <a:cs typeface="Microsoft YaHei"/>
-              </a:rPr>
-              <a:t>HSTU 8×512 相对 4×128 的整体容量扩展</a:t>
-            </a:r>
-          </a:p>
-        </p:txBody>
-      </p:sp>
-      <p:sp>
-        <p:nvSpPr>
-          <p:cNvPr id="10" name="">
+              <a:defRPr sz="1725" b="0">
+                <a:solidFill>
+                  <a:srgbClr val="17212B"/>
+                </a:solidFill>
+                <a:latin typeface="Microsoft YaHei"/>
+                <a:ea typeface="Microsoft YaHei"/>
+                <a:cs typeface="Microsoft YaHei"/>
+              </a:defRPr>
+            </a:pPr>
+            <a:r>
+              <a:rPr sz="1725" b="0">
+                <a:solidFill>
+                  <a:srgbClr val="17212B"/>
+                </a:solidFill>
+                <a:latin typeface="Microsoft YaHei"/>
+                <a:ea typeface="Microsoft YaHei"/>
+                <a:cs typeface="Microsoft YaHei"/>
+              </a:rPr>
+              <a:t>让真实下一条的分数，</a:t>
+            </a:r>
+          </a:p>
+          <a:p xmlns:a="http://schemas.openxmlformats.org/drawingml/2006/main">
+            <a:pPr algn="l">
+              <a:defRPr sz="1725" b="0">
+                <a:solidFill>
+                  <a:srgbClr val="17212B"/>
+                </a:solidFill>
+                <a:latin typeface="Microsoft YaHei"/>
+                <a:ea typeface="Microsoft YaHei"/>
+                <a:cs typeface="Microsoft YaHei"/>
+              </a:defRPr>
+            </a:pPr>
+            <a:r>
+              <a:rPr sz="1725" b="0">
+                <a:solidFill>
+                  <a:srgbClr val="17212B"/>
+                </a:solidFill>
+                <a:latin typeface="Microsoft YaHei"/>
+                <a:ea typeface="Microsoft YaHei"/>
+                <a:cs typeface="Microsoft YaHei"/>
+              </a:rPr>
+              <a:t>高于同一批中的其他对象。</a:t>
+            </a:r>
+          </a:p>
+        </p:txBody>
+      </p:sp>
+      <p:sp>
+        <p:nvSpPr>
+          <p:cNvPr id="21" name="">
             <a:extLst xmlns:a="http://schemas.openxmlformats.org/drawingml/2006/main">
               <a:ext uri="{FF2B5EF4-FFF2-40B4-BE49-F238E27FC236}">
-                <a16:creationId xmlns:a16="http://schemas.microsoft.com/office/drawing/2014/main" id="{6D2AF02E-6226-4F8C-B47B-5C9992E08E43}"/>
+                <a16:creationId xmlns:a16="http://schemas.microsoft.com/office/drawing/2014/main" id="{B511EF3B-72A0-48FE-B302-D0FF4A526094}"/>
               </a:ext>
             </a:extLst>
           </p:cNvPr>
@@ -3423,8 +3972,8 @@
         </p:nvSpPr>
         <p:spPr>
           <a:xfrm xmlns:a="http://schemas.openxmlformats.org/drawingml/2006/main">
-            <a:off x="628650" y="6191250"/>
-            <a:ext cx="10572750" cy="304800"/>
+            <a:off x="571500" y="4429125"/>
+            <a:ext cx="4857750" cy="323850"/>
           </a:xfrm>
           <a:prstGeom xmlns:a="http://schemas.openxmlformats.org/drawingml/2006/main" prst="rect">
             <a:avLst/>
@@ -3436,12 +3985,728 @@
         </p:spPr>
         <p:txBody>
           <a:bodyPr xmlns:a="http://schemas.openxmlformats.org/drawingml/2006/main" anchor="ctr">
-            <a:normAutofit fontScale="100000"/>
+            <a:noAutofit/>
           </a:bodyPr>
           <a:lstStyle xmlns:a="http://schemas.openxmlformats.org/drawingml/2006/main"/>
           <a:p xmlns:a="http://schemas.openxmlformats.org/drawingml/2006/main">
             <a:pPr algn="l">
-              <a:defRPr sz="1200" b="0">
+              <a:defRPr sz="1725" b="1">
+                <a:solidFill>
+                  <a:srgbClr val="17212B"/>
+                </a:solidFill>
+                <a:latin typeface="Microsoft YaHei"/>
+                <a:ea typeface="Microsoft YaHei"/>
+                <a:cs typeface="Microsoft YaHei"/>
+              </a:defRPr>
+            </a:pPr>
+            <a:r>
+              <a:rPr sz="1725" b="1">
+                <a:solidFill>
+                  <a:srgbClr val="17212B"/>
+                </a:solidFill>
+                <a:latin typeface="Microsoft YaHei"/>
+                <a:ea typeface="Microsoft YaHei"/>
+                <a:cs typeface="Microsoft YaHei"/>
+              </a:rPr>
+              <a:t>LogQ｜校正热门对象的抽样偏差</a:t>
+            </a:r>
+          </a:p>
+        </p:txBody>
+      </p:sp>
+      <p:sp>
+        <p:nvSpPr>
+          <p:cNvPr id="22" name="">
+            <a:extLst xmlns:a="http://schemas.openxmlformats.org/drawingml/2006/main">
+              <a:ext uri="{FF2B5EF4-FFF2-40B4-BE49-F238E27FC236}">
+                <a16:creationId xmlns:a16="http://schemas.microsoft.com/office/drawing/2014/main" id="{99DE218C-AAE7-467C-937D-FC8291CF53B0}"/>
+              </a:ext>
+            </a:extLst>
+          </p:cNvPr>
+          <p:cNvSpPr>
+            <a:spLocks xmlns:a="http://schemas.openxmlformats.org/drawingml/2006/main" noGrp="1"/>
+          </p:cNvSpPr>
+          <p:nvPr/>
+        </p:nvSpPr>
+        <p:spPr>
+          <a:xfrm xmlns:a="http://schemas.openxmlformats.org/drawingml/2006/main">
+            <a:off x="571500" y="4829175"/>
+            <a:ext cx="4857750" cy="628650"/>
+          </a:xfrm>
+          <a:prstGeom xmlns:a="http://schemas.openxmlformats.org/drawingml/2006/main" prst="rect">
+            <a:avLst/>
+          </a:prstGeom>
+          <a:noFill xmlns:a="http://schemas.openxmlformats.org/drawingml/2006/main"/>
+          <a:ln xmlns:a="http://schemas.openxmlformats.org/drawingml/2006/main" w="0">
+            <a:noFill/>
+          </a:ln>
+        </p:spPr>
+        <p:txBody>
+          <a:bodyPr xmlns:a="http://schemas.openxmlformats.org/drawingml/2006/main" anchor="ctr">
+            <a:noAutofit/>
+          </a:bodyPr>
+          <a:lstStyle xmlns:a="http://schemas.openxmlformats.org/drawingml/2006/main"/>
+          <a:p xmlns:a="http://schemas.openxmlformats.org/drawingml/2006/main">
+            <a:pPr algn="l">
+              <a:defRPr sz="1725" b="0">
+                <a:solidFill>
+                  <a:srgbClr val="17212B"/>
+                </a:solidFill>
+                <a:latin typeface="Microsoft YaHei"/>
+                <a:ea typeface="Microsoft YaHei"/>
+                <a:cs typeface="Microsoft YaHei"/>
+              </a:defRPr>
+            </a:pPr>
+            <a:r>
+              <a:rPr sz="1725" b="0">
+                <a:solidFill>
+                  <a:srgbClr val="17212B"/>
+                </a:solidFill>
+                <a:latin typeface="Microsoft YaHei"/>
+                <a:ea typeface="Microsoft YaHei"/>
+                <a:cs typeface="Microsoft YaHei"/>
+              </a:rPr>
+              <a:t>按训练中的出现频率做校正，</a:t>
+            </a:r>
+          </a:p>
+          <a:p xmlns:a="http://schemas.openxmlformats.org/drawingml/2006/main">
+            <a:pPr algn="l">
+              <a:defRPr sz="1725" b="0">
+                <a:solidFill>
+                  <a:srgbClr val="17212B"/>
+                </a:solidFill>
+                <a:latin typeface="Microsoft YaHei"/>
+                <a:ea typeface="Microsoft YaHei"/>
+                <a:cs typeface="Microsoft YaHei"/>
+              </a:defRPr>
+            </a:pPr>
+            <a:r>
+              <a:rPr sz="1725" b="0">
+                <a:solidFill>
+                  <a:srgbClr val="17212B"/>
+                </a:solidFill>
+                <a:latin typeface="Microsoft YaHei"/>
+                <a:ea typeface="Microsoft YaHei"/>
+                <a:cs typeface="Microsoft YaHei"/>
+              </a:rPr>
+              <a:t>减小热门对象更常被抽到的偏差。</a:t>
+            </a:r>
+          </a:p>
+        </p:txBody>
+      </p:sp>
+      <p:sp>
+        <p:nvSpPr>
+          <p:cNvPr id="23" name="">
+            <a:extLst xmlns:a="http://schemas.openxmlformats.org/drawingml/2006/main">
+              <a:ext uri="{FF2B5EF4-FFF2-40B4-BE49-F238E27FC236}">
+                <a16:creationId xmlns:a16="http://schemas.microsoft.com/office/drawing/2014/main" id="{9C6ED2D3-7803-4858-9AF7-69C8E2CDBD0E}"/>
+              </a:ext>
+            </a:extLst>
+          </p:cNvPr>
+          <p:cNvSpPr>
+            <a:spLocks xmlns:a="http://schemas.openxmlformats.org/drawingml/2006/main" noGrp="1"/>
+          </p:cNvSpPr>
+          <p:nvPr/>
+        </p:nvSpPr>
+        <p:spPr>
+          <a:xfrm xmlns:a="http://schemas.openxmlformats.org/drawingml/2006/main">
+            <a:off x="571500" y="5600700"/>
+            <a:ext cx="4857750" cy="323850"/>
+          </a:xfrm>
+          <a:prstGeom xmlns:a="http://schemas.openxmlformats.org/drawingml/2006/main" prst="rect">
+            <a:avLst/>
+          </a:prstGeom>
+          <a:noFill xmlns:a="http://schemas.openxmlformats.org/drawingml/2006/main"/>
+          <a:ln xmlns:a="http://schemas.openxmlformats.org/drawingml/2006/main" w="0">
+            <a:noFill/>
+          </a:ln>
+        </p:spPr>
+        <p:txBody>
+          <a:bodyPr xmlns:a="http://schemas.openxmlformats.org/drawingml/2006/main" anchor="ctr">
+            <a:noAutofit/>
+          </a:bodyPr>
+          <a:lstStyle xmlns:a="http://schemas.openxmlformats.org/drawingml/2006/main"/>
+          <a:p xmlns:a="http://schemas.openxmlformats.org/drawingml/2006/main">
+            <a:pPr algn="l">
+              <a:defRPr sz="1875" b="1">
+                <a:solidFill>
+                  <a:srgbClr val="008A83"/>
+                </a:solidFill>
+                <a:latin typeface="Microsoft YaHei"/>
+                <a:ea typeface="Microsoft YaHei"/>
+                <a:cs typeface="Microsoft YaHei"/>
+              </a:defRPr>
+            </a:pPr>
+            <a:r>
+              <a:rPr sz="1875" b="1">
+                <a:solidFill>
+                  <a:srgbClr val="008A83"/>
+                </a:solidFill>
+                <a:latin typeface="Microsoft YaHei"/>
+                <a:ea typeface="Microsoft YaHei"/>
+                <a:cs typeface="Microsoft YaHei"/>
+              </a:rPr>
+              <a:t>同规模换结构：+4.10%</a:t>
+            </a:r>
+          </a:p>
+        </p:txBody>
+      </p:sp>
+      <p:sp>
+        <p:nvSpPr>
+          <p:cNvPr id="24" name="">
+            <a:extLst xmlns:a="http://schemas.openxmlformats.org/drawingml/2006/main">
+              <a:ext uri="{FF2B5EF4-FFF2-40B4-BE49-F238E27FC236}">
+                <a16:creationId xmlns:a16="http://schemas.microsoft.com/office/drawing/2014/main" id="{B40DC027-CE32-4E49-882A-B07B94B03096}"/>
+              </a:ext>
+            </a:extLst>
+          </p:cNvPr>
+          <p:cNvSpPr>
+            <a:spLocks xmlns:a="http://schemas.openxmlformats.org/drawingml/2006/main" noGrp="1"/>
+          </p:cNvSpPr>
+          <p:nvPr/>
+        </p:nvSpPr>
+        <p:spPr>
+          <a:xfrm xmlns:a="http://schemas.openxmlformats.org/drawingml/2006/main">
+            <a:off x="571500" y="5981700"/>
+            <a:ext cx="4857750" cy="323850"/>
+          </a:xfrm>
+          <a:prstGeom xmlns:a="http://schemas.openxmlformats.org/drawingml/2006/main" prst="rect">
+            <a:avLst/>
+          </a:prstGeom>
+          <a:noFill xmlns:a="http://schemas.openxmlformats.org/drawingml/2006/main"/>
+          <a:ln xmlns:a="http://schemas.openxmlformats.org/drawingml/2006/main" w="0">
+            <a:noFill/>
+          </a:ln>
+        </p:spPr>
+        <p:txBody>
+          <a:bodyPr xmlns:a="http://schemas.openxmlformats.org/drawingml/2006/main" anchor="ctr">
+            <a:noAutofit/>
+          </a:bodyPr>
+          <a:lstStyle xmlns:a="http://schemas.openxmlformats.org/drawingml/2006/main"/>
+          <a:p xmlns:a="http://schemas.openxmlformats.org/drawingml/2006/main">
+            <a:pPr algn="l">
+              <a:defRPr sz="1875" b="1">
+                <a:solidFill>
+                  <a:srgbClr val="E7743A"/>
+                </a:solidFill>
+                <a:latin typeface="Microsoft YaHei"/>
+                <a:ea typeface="Microsoft YaHei"/>
+                <a:cs typeface="Microsoft YaHei"/>
+              </a:defRPr>
+            </a:pPr>
+            <a:r>
+              <a:rPr sz="1875" b="1">
+                <a:solidFill>
+                  <a:srgbClr val="E7743A"/>
+                </a:solidFill>
+                <a:latin typeface="Microsoft YaHei"/>
+                <a:ea typeface="Microsoft YaHei"/>
+                <a:cs typeface="Microsoft YaHei"/>
+              </a:rPr>
+              <a:t>同时加深、加宽：+25.63%</a:t>
+            </a:r>
+          </a:p>
+        </p:txBody>
+      </p:sp>
+      <p:sp>
+        <p:nvSpPr>
+          <p:cNvPr id="25" name="">
+            <a:extLst xmlns:a="http://schemas.openxmlformats.org/drawingml/2006/main">
+              <a:ext uri="{FF2B5EF4-FFF2-40B4-BE49-F238E27FC236}">
+                <a16:creationId xmlns:a16="http://schemas.microsoft.com/office/drawing/2014/main" id="{CBAA89D1-B9C7-44AF-B85A-6870B83E2187}"/>
+              </a:ext>
+            </a:extLst>
+          </p:cNvPr>
+          <p:cNvSpPr>
+            <a:spLocks xmlns:a="http://schemas.openxmlformats.org/drawingml/2006/main" noGrp="1"/>
+          </p:cNvSpPr>
+          <p:nvPr/>
+        </p:nvSpPr>
+        <p:spPr>
+          <a:xfrm xmlns:a="http://schemas.openxmlformats.org/drawingml/2006/main">
+            <a:off x="5572125" y="1504950"/>
+            <a:ext cx="6143625" cy="342900"/>
+          </a:xfrm>
+          <a:prstGeom xmlns:a="http://schemas.openxmlformats.org/drawingml/2006/main" prst="rect">
+            <a:avLst/>
+          </a:prstGeom>
+          <a:noFill xmlns:a="http://schemas.openxmlformats.org/drawingml/2006/main"/>
+          <a:ln xmlns:a="http://schemas.openxmlformats.org/drawingml/2006/main" w="0">
+            <a:noFill/>
+          </a:ln>
+        </p:spPr>
+        <p:txBody>
+          <a:bodyPr xmlns:a="http://schemas.openxmlformats.org/drawingml/2006/main" anchor="ctr">
+            <a:noAutofit/>
+          </a:bodyPr>
+          <a:lstStyle xmlns:a="http://schemas.openxmlformats.org/drawingml/2006/main"/>
+          <a:p xmlns:a="http://schemas.openxmlformats.org/drawingml/2006/main">
+            <a:pPr algn="l">
+              <a:defRPr sz="1950" b="1">
+                <a:solidFill>
+                  <a:srgbClr val="008A83"/>
+                </a:solidFill>
+                <a:latin typeface="Microsoft YaHei"/>
+                <a:ea typeface="Microsoft YaHei"/>
+                <a:cs typeface="Microsoft YaHei"/>
+              </a:defRPr>
+            </a:pPr>
+            <a:r>
+              <a:rPr sz="1950" b="1">
+                <a:solidFill>
+                  <a:srgbClr val="008A83"/>
+                </a:solidFill>
+                <a:latin typeface="Microsoft YaHei"/>
+                <a:ea typeface="Microsoft YaHei"/>
+                <a:cs typeface="Microsoft YaHei"/>
+              </a:rPr>
+              <a:t>综合分与资源开销</a:t>
+            </a:r>
+          </a:p>
+        </p:txBody>
+      </p:sp>
+      <p:graphicFrame>
+        <p:nvGraphicFramePr>
+          <p:cNvPr id="42" name=""/>
+          <p:cNvGraphicFramePr/>
+          <p:nvPr/>
+        </p:nvGraphicFramePr>
+        <p:xfrm>
+          <a:off xmlns:a="http://schemas.openxmlformats.org/drawingml/2006/main" x="5572125" y="4381500"/>
+          <a:ext xmlns:a="http://schemas.openxmlformats.org/drawingml/2006/main" cx="6143625" cy="1857375"/>
+        </p:xfrm>
+        <a:graphic xmlns:a="http://schemas.openxmlformats.org/drawingml/2006/main">
+          <a:graphicData uri="http://schemas.openxmlformats.org/drawingml/2006/table">
+            <a:tbl>
+              <a:tblPr firstRow="1" bandRow="0"/>
+              <a:tblGrid>
+                <a:gridCol w="2600325"/>
+                <a:gridCol w="1657350"/>
+                <a:gridCol w="1885950"/>
+              </a:tblGrid>
+              <a:tr h="371475">
+                <a:tc>
+                  <a:txBody>
+                    <a:bodyPr/>
+                    <a:lstStyle/>
+                    <a:p>
+                      <a:pPr algn="l"/>
+                      <a:r>
+                        <a:rPr sz="1650" b="1">
+                          <a:solidFill>
+                            <a:srgbClr val="008A83"/>
+                          </a:solidFill>
+                          <a:latin typeface="Microsoft YaHei"/>
+                          <a:ea typeface="Microsoft YaHei"/>
+                          <a:cs typeface="Microsoft YaHei"/>
+                        </a:rPr>
+                        <a:t>模型</a:t>
+                      </a:r>
+                    </a:p>
+                  </a:txBody>
+                  <a:tcPr marL="91440" marR="91440" marT="45720" marB="45720" anchor="ctr">
+                    <a:solidFill>
+                      <a:srgbClr val="E4EBE6"/>
+                    </a:solidFill>
+                  </a:tcPr>
+                </a:tc>
+                <a:tc>
+                  <a:txBody>
+                    <a:bodyPr/>
+                    <a:lstStyle/>
+                    <a:p>
+                      <a:pPr algn="ctr"/>
+                      <a:r>
+                        <a:rPr sz="1650" b="1">
+                          <a:solidFill>
+                            <a:srgbClr val="008A83"/>
+                          </a:solidFill>
+                          <a:latin typeface="Microsoft YaHei"/>
+                          <a:ea typeface="Microsoft YaHei"/>
+                          <a:cs typeface="Microsoft YaHei"/>
+                        </a:rPr>
+                        <a:t>训练 / 分钟</a:t>
+                      </a:r>
+                    </a:p>
+                  </a:txBody>
+                  <a:tcPr marL="91440" marR="91440" marT="45720" marB="45720" anchor="ctr">
+                    <a:solidFill>
+                      <a:srgbClr val="E4EBE6"/>
+                    </a:solidFill>
+                  </a:tcPr>
+                </a:tc>
+                <a:tc>
+                  <a:txBody>
+                    <a:bodyPr/>
+                    <a:lstStyle/>
+                    <a:p>
+                      <a:pPr algn="ctr"/>
+                      <a:r>
+                        <a:rPr sz="1650" b="1">
+                          <a:solidFill>
+                            <a:srgbClr val="008A83"/>
+                          </a:solidFill>
+                          <a:latin typeface="Microsoft YaHei"/>
+                          <a:ea typeface="Microsoft YaHei"/>
+                          <a:cs typeface="Microsoft YaHei"/>
+                        </a:rPr>
+                        <a:t>显存峰值 / GiB</a:t>
+                      </a:r>
+                    </a:p>
+                  </a:txBody>
+                  <a:tcPr marL="91440" marR="91440" marT="45720" marB="45720" anchor="ctr">
+                    <a:solidFill>
+                      <a:srgbClr val="E4EBE6"/>
+                    </a:solidFill>
+                  </a:tcPr>
+                </a:tc>
+              </a:tr>
+              <a:tr h="371475">
+                <a:tc>
+                  <a:txBody>
+                    <a:bodyPr/>
+                    <a:lstStyle/>
+                    <a:p>
+                      <a:pPr algn="l"/>
+                      <a:r>
+                        <a:rPr sz="1650" b="0">
+                          <a:solidFill>
+                            <a:srgbClr val="17212B"/>
+                          </a:solidFill>
+                          <a:latin typeface="Microsoft YaHei"/>
+                          <a:ea typeface="Microsoft YaHei"/>
+                          <a:cs typeface="Microsoft YaHei"/>
+                        </a:rPr>
+                        <a:t>Transformer 4×128</a:t>
+                      </a:r>
+                    </a:p>
+                  </a:txBody>
+                  <a:tcPr marL="91440" marR="91440" marT="45720" marB="45720" anchor="ctr">
+                    <a:solidFill>
+                      <a:srgbClr val="F5F2EA"/>
+                    </a:solidFill>
+                  </a:tcPr>
+                </a:tc>
+                <a:tc>
+                  <a:txBody>
+                    <a:bodyPr/>
+                    <a:lstStyle/>
+                    <a:p>
+                      <a:pPr algn="ctr"/>
+                      <a:r>
+                        <a:rPr sz="1650" b="0">
+                          <a:solidFill>
+                            <a:srgbClr val="17212B"/>
+                          </a:solidFill>
+                          <a:latin typeface="Microsoft YaHei"/>
+                          <a:ea typeface="Microsoft YaHei"/>
+                          <a:cs typeface="Microsoft YaHei"/>
+                        </a:rPr>
+                        <a:t>81.1</a:t>
+                      </a:r>
+                    </a:p>
+                  </a:txBody>
+                  <a:tcPr marL="91440" marR="91440" marT="45720" marB="45720" anchor="ctr">
+                    <a:solidFill>
+                      <a:srgbClr val="F5F2EA"/>
+                    </a:solidFill>
+                  </a:tcPr>
+                </a:tc>
+                <a:tc>
+                  <a:txBody>
+                    <a:bodyPr/>
+                    <a:lstStyle/>
+                    <a:p>
+                      <a:pPr algn="ctr"/>
+                      <a:r>
+                        <a:rPr sz="1650" b="0">
+                          <a:solidFill>
+                            <a:srgbClr val="17212B"/>
+                          </a:solidFill>
+                          <a:latin typeface="Microsoft YaHei"/>
+                          <a:ea typeface="Microsoft YaHei"/>
+                          <a:cs typeface="Microsoft YaHei"/>
+                        </a:rPr>
+                        <a:t>9.23</a:t>
+                      </a:r>
+                    </a:p>
+                  </a:txBody>
+                  <a:tcPr marL="91440" marR="91440" marT="45720" marB="45720" anchor="ctr">
+                    <a:solidFill>
+                      <a:srgbClr val="F5F2EA"/>
+                    </a:solidFill>
+                  </a:tcPr>
+                </a:tc>
+              </a:tr>
+              <a:tr h="371475">
+                <a:tc>
+                  <a:txBody>
+                    <a:bodyPr/>
+                    <a:lstStyle/>
+                    <a:p>
+                      <a:pPr algn="l"/>
+                      <a:r>
+                        <a:rPr sz="1650" b="0">
+                          <a:solidFill>
+                            <a:srgbClr val="17212B"/>
+                          </a:solidFill>
+                          <a:latin typeface="Microsoft YaHei"/>
+                          <a:ea typeface="Microsoft YaHei"/>
+                          <a:cs typeface="Microsoft YaHei"/>
+                        </a:rPr>
+                        <a:t>HSTU 4×128</a:t>
+                      </a:r>
+                    </a:p>
+                  </a:txBody>
+                  <a:tcPr marL="91440" marR="91440" marT="45720" marB="45720" anchor="ctr">
+                    <a:solidFill>
+                      <a:srgbClr val="F5F2EA"/>
+                    </a:solidFill>
+                  </a:tcPr>
+                </a:tc>
+                <a:tc>
+                  <a:txBody>
+                    <a:bodyPr/>
+                    <a:lstStyle/>
+                    <a:p>
+                      <a:pPr algn="ctr"/>
+                      <a:r>
+                        <a:rPr sz="1650" b="0">
+                          <a:solidFill>
+                            <a:srgbClr val="17212B"/>
+                          </a:solidFill>
+                          <a:latin typeface="Microsoft YaHei"/>
+                          <a:ea typeface="Microsoft YaHei"/>
+                          <a:cs typeface="Microsoft YaHei"/>
+                        </a:rPr>
+                        <a:t>78.6</a:t>
+                      </a:r>
+                    </a:p>
+                  </a:txBody>
+                  <a:tcPr marL="91440" marR="91440" marT="45720" marB="45720" anchor="ctr">
+                    <a:solidFill>
+                      <a:srgbClr val="F5F2EA"/>
+                    </a:solidFill>
+                  </a:tcPr>
+                </a:tc>
+                <a:tc>
+                  <a:txBody>
+                    <a:bodyPr/>
+                    <a:lstStyle/>
+                    <a:p>
+                      <a:pPr algn="ctr"/>
+                      <a:r>
+                        <a:rPr sz="1650" b="0">
+                          <a:solidFill>
+                            <a:srgbClr val="17212B"/>
+                          </a:solidFill>
+                          <a:latin typeface="Microsoft YaHei"/>
+                          <a:ea typeface="Microsoft YaHei"/>
+                          <a:cs typeface="Microsoft YaHei"/>
+                        </a:rPr>
+                        <a:t>9.23</a:t>
+                      </a:r>
+                    </a:p>
+                  </a:txBody>
+                  <a:tcPr marL="91440" marR="91440" marT="45720" marB="45720" anchor="ctr">
+                    <a:solidFill>
+                      <a:srgbClr val="F5F2EA"/>
+                    </a:solidFill>
+                  </a:tcPr>
+                </a:tc>
+              </a:tr>
+              <a:tr h="371475">
+                <a:tc>
+                  <a:txBody>
+                    <a:bodyPr/>
+                    <a:lstStyle/>
+                    <a:p>
+                      <a:pPr algn="l"/>
+                      <a:r>
+                        <a:rPr sz="1650" b="0">
+                          <a:solidFill>
+                            <a:srgbClr val="17212B"/>
+                          </a:solidFill>
+                          <a:latin typeface="Microsoft YaHei"/>
+                          <a:ea typeface="Microsoft YaHei"/>
+                          <a:cs typeface="Microsoft YaHei"/>
+                        </a:rPr>
+                        <a:t>HSTU 8×256</a:t>
+                      </a:r>
+                    </a:p>
+                  </a:txBody>
+                  <a:tcPr marL="91440" marR="91440" marT="45720" marB="45720" anchor="ctr">
+                    <a:solidFill>
+                      <a:srgbClr val="F5F2EA"/>
+                    </a:solidFill>
+                  </a:tcPr>
+                </a:tc>
+                <a:tc>
+                  <a:txBody>
+                    <a:bodyPr/>
+                    <a:lstStyle/>
+                    <a:p>
+                      <a:pPr algn="ctr"/>
+                      <a:r>
+                        <a:rPr sz="1650" b="0">
+                          <a:solidFill>
+                            <a:srgbClr val="17212B"/>
+                          </a:solidFill>
+                          <a:latin typeface="Microsoft YaHei"/>
+                          <a:ea typeface="Microsoft YaHei"/>
+                          <a:cs typeface="Microsoft YaHei"/>
+                        </a:rPr>
+                        <a:t>118.6</a:t>
+                      </a:r>
+                    </a:p>
+                  </a:txBody>
+                  <a:tcPr marL="91440" marR="91440" marT="45720" marB="45720" anchor="ctr">
+                    <a:solidFill>
+                      <a:srgbClr val="F5F2EA"/>
+                    </a:solidFill>
+                  </a:tcPr>
+                </a:tc>
+                <a:tc>
+                  <a:txBody>
+                    <a:bodyPr/>
+                    <a:lstStyle/>
+                    <a:p>
+                      <a:pPr algn="ctr"/>
+                      <a:r>
+                        <a:rPr sz="1650" b="0">
+                          <a:solidFill>
+                            <a:srgbClr val="17212B"/>
+                          </a:solidFill>
+                          <a:latin typeface="Microsoft YaHei"/>
+                          <a:ea typeface="Microsoft YaHei"/>
+                          <a:cs typeface="Microsoft YaHei"/>
+                        </a:rPr>
+                        <a:t>14.84</a:t>
+                      </a:r>
+                    </a:p>
+                  </a:txBody>
+                  <a:tcPr marL="91440" marR="91440" marT="45720" marB="45720" anchor="ctr">
+                    <a:solidFill>
+                      <a:srgbClr val="F5F2EA"/>
+                    </a:solidFill>
+                  </a:tcPr>
+                </a:tc>
+              </a:tr>
+              <a:tr h="371475">
+                <a:tc>
+                  <a:txBody>
+                    <a:bodyPr/>
+                    <a:lstStyle/>
+                    <a:p>
+                      <a:pPr algn="l"/>
+                      <a:r>
+                        <a:rPr sz="1650" b="1">
+                          <a:solidFill>
+                            <a:srgbClr val="17212B"/>
+                          </a:solidFill>
+                          <a:latin typeface="Microsoft YaHei"/>
+                          <a:ea typeface="Microsoft YaHei"/>
+                          <a:cs typeface="Microsoft YaHei"/>
+                        </a:rPr>
+                        <a:t>HSTU 8×512</a:t>
+                      </a:r>
+                    </a:p>
+                  </a:txBody>
+                  <a:tcPr marL="91440" marR="91440" marT="45720" marB="45720" anchor="ctr">
+                    <a:solidFill>
+                      <a:srgbClr val="F5F2EA"/>
+                    </a:solidFill>
+                  </a:tcPr>
+                </a:tc>
+                <a:tc>
+                  <a:txBody>
+                    <a:bodyPr/>
+                    <a:lstStyle/>
+                    <a:p>
+                      <a:pPr algn="ctr"/>
+                      <a:r>
+                        <a:rPr sz="1650" b="1">
+                          <a:solidFill>
+                            <a:srgbClr val="17212B"/>
+                          </a:solidFill>
+                          <a:latin typeface="Microsoft YaHei"/>
+                          <a:ea typeface="Microsoft YaHei"/>
+                          <a:cs typeface="Microsoft YaHei"/>
+                        </a:rPr>
+                        <a:t>180.8</a:t>
+                      </a:r>
+                    </a:p>
+                  </a:txBody>
+                  <a:tcPr marL="91440" marR="91440" marT="45720" marB="45720" anchor="ctr">
+                    <a:solidFill>
+                      <a:srgbClr val="F5F2EA"/>
+                    </a:solidFill>
+                  </a:tcPr>
+                </a:tc>
+                <a:tc>
+                  <a:txBody>
+                    <a:bodyPr/>
+                    <a:lstStyle/>
+                    <a:p>
+                      <a:pPr algn="ctr"/>
+                      <a:r>
+                        <a:rPr sz="1650" b="1">
+                          <a:solidFill>
+                            <a:srgbClr val="17212B"/>
+                          </a:solidFill>
+                          <a:latin typeface="Microsoft YaHei"/>
+                          <a:ea typeface="Microsoft YaHei"/>
+                          <a:cs typeface="Microsoft YaHei"/>
+                        </a:rPr>
+                        <a:t>26.16</a:t>
+                      </a:r>
+                    </a:p>
+                  </a:txBody>
+                  <a:tcPr marL="91440" marR="91440" marT="45720" marB="45720" anchor="ctr">
+                    <a:solidFill>
+                      <a:srgbClr val="F5F2EA"/>
+                    </a:solidFill>
+                  </a:tcPr>
+                </a:tc>
+              </a:tr>
+            </a:tbl>
+          </a:graphicData>
+        </a:graphic>
+      </p:graphicFrame>
+      <p:sp>
+        <p:nvSpPr>
+          <p:cNvPr id="27" name="">
+            <a:extLst xmlns:a="http://schemas.openxmlformats.org/drawingml/2006/main">
+              <a:ext uri="{FF2B5EF4-FFF2-40B4-BE49-F238E27FC236}">
+                <a16:creationId xmlns:a16="http://schemas.microsoft.com/office/drawing/2014/main" id="{85C55564-0377-4B2D-B6FF-39329C9247E7}"/>
+              </a:ext>
+            </a:extLst>
+          </p:cNvPr>
+          <p:cNvSpPr>
+            <a:spLocks xmlns:a="http://schemas.openxmlformats.org/drawingml/2006/main" noGrp="1"/>
+          </p:cNvSpPr>
+          <p:nvPr/>
+        </p:nvSpPr>
+        <p:spPr>
+          <a:xfrm xmlns:a="http://schemas.openxmlformats.org/drawingml/2006/main">
+            <a:off x="571500" y="6486525"/>
+            <a:ext cx="11049000" cy="228600"/>
+          </a:xfrm>
+          <a:prstGeom xmlns:a="http://schemas.openxmlformats.org/drawingml/2006/main" prst="rect">
+            <a:avLst/>
+          </a:prstGeom>
+          <a:noFill xmlns:a="http://schemas.openxmlformats.org/drawingml/2006/main"/>
+          <a:ln xmlns:a="http://schemas.openxmlformats.org/drawingml/2006/main" w="0">
+            <a:noFill/>
+          </a:ln>
+        </p:spPr>
+        <p:txBody>
+          <a:bodyPr xmlns:a="http://schemas.openxmlformats.org/drawingml/2006/main" anchor="ctr">
+            <a:noAutofit/>
+          </a:bodyPr>
+          <a:lstStyle xmlns:a="http://schemas.openxmlformats.org/drawingml/2006/main"/>
+          <a:p xmlns:a="http://schemas.openxmlformats.org/drawingml/2006/main">
+            <a:pPr algn="l">
+              <a:defRPr sz="1125" b="0">
                 <a:solidFill>
                   <a:srgbClr val="5C6670"/>
                 </a:solidFill>
@@ -3451,7 +4716,7 @@
               </a:defRPr>
             </a:pPr>
             <a:r>
-              <a:rPr sz="1200" b="0">
+              <a:rPr sz="1125" b="0">
                 <a:solidFill>
                   <a:srgbClr val="5C6670"/>
                 </a:solidFill>
@@ -3459,7 +4724,7 @@
                 <a:ea typeface="Microsoft YaHei"/>
                 <a:cs typeface="Microsoft YaHei"/>
               </a:rPr>
-              <a:t>T 代表 Transformer，H 代表 HSTU。架构对照只切换编码器，容量实验同时改变深度与宽度。</a:t>
+              <a:t>T = Transformer，H = HSTU。每个配置只训练 1 次；深度与宽度同时变化，不能拆分各自贡献。</a:t>
             </a:r>
           </a:p>
         </p:txBody>
@@ -3493,12 +4758,28 @@
       <p:grpSpPr>
         <a:xfrm xmlns:a="http://schemas.openxmlformats.org/drawingml/2006/main"/>
       </p:grpSpPr>
-      <p:sp>
-        <p:nvSpPr>
-          <p:cNvPr id="12" name="">
+      <p:graphicFrame>
+        <p:nvGraphicFramePr>
+          <p:cNvPr id="29" name="Chart"/>
+          <p:cNvGraphicFramePr/>
+          <p:nvPr/>
+        </p:nvGraphicFramePr>
+        <p:xfrm>
+          <a:off xmlns:a="http://schemas.openxmlformats.org/drawingml/2006/main" x="5581650" y="1971675"/>
+          <a:ext xmlns:a="http://schemas.openxmlformats.org/drawingml/2006/main" cx="6191250" cy="2752725"/>
+        </p:xfrm>
+        <a:graphic xmlns:a="http://schemas.openxmlformats.org/drawingml/2006/main">
+          <a:graphicData uri="http://schemas.openxmlformats.org/drawingml/2006/chart">
+            <c:chart xmlns:r="http://schemas.openxmlformats.org/officeDocument/2006/relationships" xmlns:c="http://schemas.openxmlformats.org/drawingml/2006/chart" r:id="R83a2c9825e68409d"/>
+          </a:graphicData>
+        </a:graphic>
+      </p:graphicFrame>
+      <p:sp>
+        <p:nvSpPr>
+          <p:cNvPr id="14" name="">
             <a:extLst xmlns:a="http://schemas.openxmlformats.org/drawingml/2006/main">
               <a:ext uri="{FF2B5EF4-FFF2-40B4-BE49-F238E27FC236}">
-                <a16:creationId xmlns:a16="http://schemas.microsoft.com/office/drawing/2014/main" id="{0186ACCD-D48C-4C1A-B3C5-558B9C46962B}"/>
+                <a16:creationId xmlns:a16="http://schemas.microsoft.com/office/drawing/2014/main" id="{ED551727-B78D-4EED-971A-557BA95BED28}"/>
               </a:ext>
             </a:extLst>
           </p:cNvPr>
@@ -3509,8 +4790,8 @@
         </p:nvSpPr>
         <p:spPr>
           <a:xfrm xmlns:a="http://schemas.openxmlformats.org/drawingml/2006/main">
-            <a:off x="11353800" y="438150"/>
-            <a:ext cx="400050" cy="266700"/>
+            <a:off x="514350" y="304800"/>
+            <a:ext cx="10572750" cy="590550"/>
           </a:xfrm>
           <a:prstGeom xmlns:a="http://schemas.openxmlformats.org/drawingml/2006/main" prst="rect">
             <a:avLst/>
@@ -3522,40 +4803,40 @@
         </p:spPr>
         <p:txBody>
           <a:bodyPr xmlns:a="http://schemas.openxmlformats.org/drawingml/2006/main" anchor="ctr">
-            <a:normAutofit fontScale="95833"/>
+            <a:noAutofit/>
           </a:bodyPr>
           <a:lstStyle xmlns:a="http://schemas.openxmlformats.org/drawingml/2006/main"/>
           <a:p xmlns:a="http://schemas.openxmlformats.org/drawingml/2006/main">
-            <a:pPr algn="r">
-              <a:defRPr sz="1200" b="0">
-                <a:solidFill>
-                  <a:srgbClr val="5C6670"/>
-                </a:solidFill>
-                <a:latin typeface="Microsoft YaHei"/>
-                <a:ea typeface="Microsoft YaHei"/>
-                <a:cs typeface="Microsoft YaHei"/>
-              </a:defRPr>
-            </a:pPr>
-            <a:r>
-              <a:rPr sz="1200" b="0">
-                <a:solidFill>
-                  <a:srgbClr val="5C6670"/>
-                </a:solidFill>
-                <a:latin typeface="Microsoft YaHei"/>
-                <a:ea typeface="Microsoft YaHei"/>
-                <a:cs typeface="Microsoft YaHei"/>
-              </a:rPr>
-              <a:t>03</a:t>
-            </a:r>
-          </a:p>
-        </p:txBody>
-      </p:sp>
-      <p:sp>
-        <p:nvSpPr>
-          <p:cNvPr id="2" name="">
+            <a:pPr algn="l">
+              <a:defRPr sz="3150" b="1">
+                <a:solidFill>
+                  <a:srgbClr val="17212B"/>
+                </a:solidFill>
+                <a:latin typeface="Microsoft YaHei"/>
+                <a:ea typeface="Microsoft YaHei"/>
+                <a:cs typeface="Microsoft YaHei"/>
+              </a:defRPr>
+            </a:pPr>
+            <a:r>
+              <a:rPr sz="3150" b="1">
+                <a:solidFill>
+                  <a:srgbClr val="17212B"/>
+                </a:solidFill>
+                <a:latin typeface="Microsoft YaHei"/>
+                <a:ea typeface="Microsoft YaHei"/>
+                <a:cs typeface="Microsoft YaHei"/>
+              </a:rPr>
+              <a:t>SID 实验：先变差，修复后接近原水平</a:t>
+            </a:r>
+          </a:p>
+        </p:txBody>
+      </p:sp>
+      <p:sp>
+        <p:nvSpPr>
+          <p:cNvPr id="15" name="">
             <a:extLst xmlns:a="http://schemas.openxmlformats.org/drawingml/2006/main">
               <a:ext uri="{FF2B5EF4-FFF2-40B4-BE49-F238E27FC236}">
-                <a16:creationId xmlns:a16="http://schemas.microsoft.com/office/drawing/2014/main" id="{66B5AB12-AB3A-4607-8064-5F66FE6127A1}"/>
+                <a16:creationId xmlns:a16="http://schemas.microsoft.com/office/drawing/2014/main" id="{6DC9FA17-89CD-486B-9A2B-C8697E45DEDB}"/>
               </a:ext>
             </a:extLst>
           </p:cNvPr>
@@ -3566,8 +4847,8 @@
         </p:nvSpPr>
         <p:spPr>
           <a:xfrm xmlns:a="http://schemas.openxmlformats.org/drawingml/2006/main">
-            <a:off x="609600" y="400050"/>
-            <a:ext cx="9906000" cy="590550"/>
+            <a:off x="542925" y="952500"/>
+            <a:ext cx="11106150" cy="381000"/>
           </a:xfrm>
           <a:prstGeom xmlns:a="http://schemas.openxmlformats.org/drawingml/2006/main" prst="rect">
             <a:avLst/>
@@ -3579,40 +4860,40 @@
         </p:spPr>
         <p:txBody>
           <a:bodyPr xmlns:a="http://schemas.openxmlformats.org/drawingml/2006/main" anchor="ctr">
-            <a:normAutofit fontScale="97037"/>
+            <a:noAutofit/>
           </a:bodyPr>
           <a:lstStyle xmlns:a="http://schemas.openxmlformats.org/drawingml/2006/main"/>
           <a:p xmlns:a="http://schemas.openxmlformats.org/drawingml/2006/main">
             <a:pPr algn="l">
-              <a:defRPr sz="3375" b="1">
-                <a:solidFill>
-                  <a:srgbClr val="17212B"/>
-                </a:solidFill>
-                <a:latin typeface="Microsoft YaHei"/>
-                <a:ea typeface="Microsoft YaHei"/>
-                <a:cs typeface="Microsoft YaHei"/>
-              </a:defRPr>
-            </a:pPr>
-            <a:r>
-              <a:rPr sz="3375" b="1">
-                <a:solidFill>
-                  <a:srgbClr val="17212B"/>
-                </a:solidFill>
-                <a:latin typeface="Microsoft YaHei"/>
-                <a:ea typeface="Microsoft YaHei"/>
-                <a:cs typeface="Microsoft YaHei"/>
-              </a:rPr>
-              <a:t>SID 负结果形成了完整诊断闭环</a:t>
-            </a:r>
-          </a:p>
-        </p:txBody>
-      </p:sp>
-      <p:sp>
-        <p:nvSpPr>
-          <p:cNvPr id="3" name="">
+              <a:defRPr sz="1650" b="0">
+                <a:solidFill>
+                  <a:srgbClr val="5C6670"/>
+                </a:solidFill>
+                <a:latin typeface="Microsoft YaHei"/>
+                <a:ea typeface="Microsoft YaHei"/>
+                <a:cs typeface="Microsoft YaHei"/>
+              </a:defRPr>
+            </a:pPr>
+            <a:r>
+              <a:rPr sz="1650" b="0">
+                <a:solidFill>
+                  <a:srgbClr val="5C6670"/>
+                </a:solidFill>
+                <a:latin typeface="Microsoft YaHei"/>
+                <a:ea typeface="Microsoft YaHei"/>
+                <a:cs typeface="Microsoft YaHei"/>
+              </a:rPr>
+              <a:t>SID（语义 ID）：把对象向量压成两个数字的编号，再增加“预测编号”的训练任务。</a:t>
+            </a:r>
+          </a:p>
+        </p:txBody>
+      </p:sp>
+      <p:sp>
+        <p:nvSpPr>
+          <p:cNvPr id="16" name="">
             <a:extLst xmlns:a="http://schemas.openxmlformats.org/drawingml/2006/main">
               <a:ext uri="{FF2B5EF4-FFF2-40B4-BE49-F238E27FC236}">
-                <a16:creationId xmlns:a16="http://schemas.microsoft.com/office/drawing/2014/main" id="{CCDA9823-0A0B-4874-9DF2-D4C3FAE1252B}"/>
+                <a16:creationId xmlns:a16="http://schemas.microsoft.com/office/drawing/2014/main" id="{718849E9-032A-455A-87B9-92375346FEF5}"/>
               </a:ext>
             </a:extLst>
           </p:cNvPr>
@@ -3623,8 +4904,8 @@
         </p:nvSpPr>
         <p:spPr>
           <a:xfrm xmlns:a="http://schemas.openxmlformats.org/drawingml/2006/main">
-            <a:off x="628650" y="1152525"/>
-            <a:ext cx="4000500" cy="285750"/>
+            <a:off x="11334750" y="409575"/>
+            <a:ext cx="361950" cy="266700"/>
           </a:xfrm>
           <a:prstGeom xmlns:a="http://schemas.openxmlformats.org/drawingml/2006/main" prst="rect">
             <a:avLst/>
@@ -3636,12 +4917,12 @@
         </p:spPr>
         <p:txBody>
           <a:bodyPr xmlns:a="http://schemas.openxmlformats.org/drawingml/2006/main" anchor="ctr">
-            <a:normAutofit fontScale="89474"/>
+            <a:noAutofit/>
           </a:bodyPr>
           <a:lstStyle xmlns:a="http://schemas.openxmlformats.org/drawingml/2006/main"/>
           <a:p xmlns:a="http://schemas.openxmlformats.org/drawingml/2006/main">
-            <a:pPr algn="l">
-              <a:defRPr sz="1425" b="0">
+            <a:pPr algn="r">
+              <a:defRPr sz="1200" b="0">
                 <a:solidFill>
                   <a:srgbClr val="5C6670"/>
                 </a:solidFill>
@@ -3651,7 +4932,7 @@
               </a:defRPr>
             </a:pPr>
             <a:r>
-              <a:rPr sz="1425" b="0">
+              <a:rPr sz="1200" b="0">
                 <a:solidFill>
                   <a:srgbClr val="5C6670"/>
                 </a:solidFill>
@@ -3659,33 +4940,17 @@
                 <a:ea typeface="Microsoft YaHei"/>
                 <a:cs typeface="Microsoft YaHei"/>
               </a:rPr>
-              <a:t>历史协议综合分（纵轴从 0.075 起）</a:t>
-            </a:r>
-          </a:p>
-        </p:txBody>
-      </p:sp>
-      <p:graphicFrame>
-        <p:nvGraphicFramePr>
-          <p:cNvPr id="15" name="Chart"/>
-          <p:cNvGraphicFramePr/>
-          <p:nvPr/>
-        </p:nvGraphicFramePr>
-        <p:xfrm>
-          <a:off xmlns:a="http://schemas.openxmlformats.org/drawingml/2006/main" x="457200" y="1495425"/>
-          <a:ext xmlns:a="http://schemas.openxmlformats.org/drawingml/2006/main" cx="6667500" cy="4333875"/>
-        </p:xfrm>
-        <a:graphic xmlns:a="http://schemas.openxmlformats.org/drawingml/2006/main">
-          <a:graphicData uri="http://schemas.openxmlformats.org/drawingml/2006/chart">
-            <c:chart xmlns:r="http://schemas.openxmlformats.org/officeDocument/2006/relationships" xmlns:c="http://schemas.openxmlformats.org/drawingml/2006/chart" r:id="R7bada29b79b54744"/>
-          </a:graphicData>
-        </a:graphic>
-      </p:graphicFrame>
-      <p:sp>
-        <p:nvSpPr>
-          <p:cNvPr id="5" name="">
+              <a:t>03</a:t>
+            </a:r>
+          </a:p>
+        </p:txBody>
+      </p:sp>
+      <p:sp>
+        <p:nvSpPr>
+          <p:cNvPr id="17" name="">
             <a:extLst xmlns:a="http://schemas.openxmlformats.org/drawingml/2006/main">
               <a:ext uri="{FF2B5EF4-FFF2-40B4-BE49-F238E27FC236}">
-                <a16:creationId xmlns:a16="http://schemas.microsoft.com/office/drawing/2014/main" id="{223848B3-55B7-4C6C-A739-CE6B2E4D1FEF}"/>
+                <a16:creationId xmlns:a16="http://schemas.microsoft.com/office/drawing/2014/main" id="{03776FE9-C1D3-4DC4-B64C-2E4FC8088C3D}"/>
               </a:ext>
             </a:extLst>
           </p:cNvPr>
@@ -3696,8 +4961,8 @@
         </p:nvSpPr>
         <p:spPr>
           <a:xfrm xmlns:a="http://schemas.openxmlformats.org/drawingml/2006/main">
-            <a:off x="7753350" y="1447800"/>
-            <a:ext cx="1143000" cy="285750"/>
+            <a:off x="571500" y="1504950"/>
+            <a:ext cx="4857750" cy="342900"/>
           </a:xfrm>
           <a:prstGeom xmlns:a="http://schemas.openxmlformats.org/drawingml/2006/main" prst="rect">
             <a:avLst/>
@@ -3709,40 +4974,40 @@
         </p:spPr>
         <p:txBody>
           <a:bodyPr xmlns:a="http://schemas.openxmlformats.org/drawingml/2006/main" anchor="ctr">
-            <a:normAutofit fontScale="94444"/>
+            <a:noAutofit/>
           </a:bodyPr>
           <a:lstStyle xmlns:a="http://schemas.openxmlformats.org/drawingml/2006/main"/>
           <a:p xmlns:a="http://schemas.openxmlformats.org/drawingml/2006/main">
             <a:pPr algn="l">
-              <a:defRPr sz="1350" b="1">
-                <a:solidFill>
-                  <a:srgbClr val="C84D42"/>
-                </a:solidFill>
-                <a:latin typeface="Microsoft YaHei"/>
-                <a:ea typeface="Microsoft YaHei"/>
-                <a:cs typeface="Microsoft YaHei"/>
-              </a:defRPr>
-            </a:pPr>
-            <a:r>
-              <a:rPr sz="1350" b="1">
-                <a:solidFill>
-                  <a:srgbClr val="C84D42"/>
-                </a:solidFill>
-                <a:latin typeface="Microsoft YaHei"/>
-                <a:ea typeface="Microsoft YaHei"/>
-                <a:cs typeface="Microsoft YaHei"/>
-              </a:rPr>
-              <a:t>诊断</a:t>
-            </a:r>
-          </a:p>
-        </p:txBody>
-      </p:sp>
-      <p:sp>
-        <p:nvSpPr>
-          <p:cNvPr id="6" name="">
+              <a:defRPr sz="1950" b="1">
+                <a:solidFill>
+                  <a:srgbClr val="008A83"/>
+                </a:solidFill>
+                <a:latin typeface="Microsoft YaHei"/>
+                <a:ea typeface="Microsoft YaHei"/>
+                <a:cs typeface="Microsoft YaHei"/>
+              </a:defRPr>
+            </a:pPr>
+            <a:r>
+              <a:rPr sz="1950" b="1">
+                <a:solidFill>
+                  <a:srgbClr val="008A83"/>
+                </a:solidFill>
+                <a:latin typeface="Microsoft YaHei"/>
+                <a:ea typeface="Microsoft YaHei"/>
+                <a:cs typeface="Microsoft YaHei"/>
+              </a:rPr>
+              <a:t>哪里出了问题？</a:t>
+            </a:r>
+          </a:p>
+        </p:txBody>
+      </p:sp>
+      <p:sp>
+        <p:nvSpPr>
+          <p:cNvPr id="18" name="">
             <a:extLst xmlns:a="http://schemas.openxmlformats.org/drawingml/2006/main">
               <a:ext uri="{FF2B5EF4-FFF2-40B4-BE49-F238E27FC236}">
-                <a16:creationId xmlns:a16="http://schemas.microsoft.com/office/drawing/2014/main" id="{A4E5898B-C87D-4D7D-A780-3A726F3D5F6D}"/>
+                <a16:creationId xmlns:a16="http://schemas.microsoft.com/office/drawing/2014/main" id="{C733934B-083E-4F6F-96F1-F31BD36D05B3}"/>
               </a:ext>
             </a:extLst>
           </p:cNvPr>
@@ -3753,8 +5018,8 @@
         </p:nvSpPr>
         <p:spPr>
           <a:xfrm xmlns:a="http://schemas.openxmlformats.org/drawingml/2006/main">
-            <a:off x="7753350" y="1752600"/>
-            <a:ext cx="3476625" cy="742950"/>
+            <a:off x="571500" y="1971675"/>
+            <a:ext cx="4991100" cy="657225"/>
           </a:xfrm>
           <a:prstGeom xmlns:a="http://schemas.openxmlformats.org/drawingml/2006/main" prst="rect">
             <a:avLst/>
@@ -3766,63 +5031,63 @@
         </p:spPr>
         <p:txBody>
           <a:bodyPr xmlns:a="http://schemas.openxmlformats.org/drawingml/2006/main" anchor="ctr">
-            <a:normAutofit fontScale="100000"/>
+            <a:noAutofit/>
           </a:bodyPr>
           <a:lstStyle xmlns:a="http://schemas.openxmlformats.org/drawingml/2006/main"/>
           <a:p xmlns:a="http://schemas.openxmlformats.org/drawingml/2006/main">
             <a:pPr algn="l">
-              <a:defRPr sz="1950" b="1">
-                <a:solidFill>
-                  <a:srgbClr val="17212B"/>
-                </a:solidFill>
-                <a:latin typeface="Microsoft YaHei"/>
-                <a:ea typeface="Microsoft YaHei"/>
-                <a:cs typeface="Microsoft YaHei"/>
-              </a:defRPr>
-            </a:pPr>
-            <a:r>
-              <a:rPr sz="1950" b="1">
-                <a:solidFill>
-                  <a:srgbClr val="17212B"/>
-                </a:solidFill>
-                <a:latin typeface="Microsoft YaHei"/>
-                <a:ea typeface="Microsoft YaHei"/>
-                <a:cs typeface="Microsoft YaHei"/>
-              </a:rPr>
-              <a:t>225 万 pair 碰撞</a:t>
-            </a:r>
-          </a:p>
-          <a:p xmlns:a="http://schemas.openxmlformats.org/drawingml/2006/main">
-            <a:pPr algn="l">
-              <a:defRPr sz="1950" b="1">
-                <a:solidFill>
-                  <a:srgbClr val="17212B"/>
-                </a:solidFill>
-                <a:latin typeface="Microsoft YaHei"/>
-                <a:ea typeface="Microsoft YaHei"/>
-                <a:cs typeface="Microsoft YaHei"/>
-              </a:defRPr>
-            </a:pPr>
-            <a:r>
-              <a:rPr sz="1950" b="1">
-                <a:solidFill>
-                  <a:srgbClr val="17212B"/>
-                </a:solidFill>
-                <a:latin typeface="Microsoft YaHei"/>
-                <a:ea typeface="Microsoft YaHei"/>
-                <a:cs typeface="Microsoft YaHei"/>
-              </a:rPr>
-              <a:t>辅助损失等权加入</a:t>
-            </a:r>
-          </a:p>
-        </p:txBody>
-      </p:sp>
-      <p:sp>
-        <p:nvSpPr>
-          <p:cNvPr id="7" name="">
+              <a:defRPr sz="1725" b="0">
+                <a:solidFill>
+                  <a:srgbClr val="17212B"/>
+                </a:solidFill>
+                <a:latin typeface="Microsoft YaHei"/>
+                <a:ea typeface="Microsoft YaHei"/>
+                <a:cs typeface="Microsoft YaHei"/>
+              </a:defRPr>
+            </a:pPr>
+            <a:r>
+              <a:rPr sz="1725" b="0">
+                <a:solidFill>
+                  <a:srgbClr val="17212B"/>
+                </a:solidFill>
+                <a:latin typeface="Microsoft YaHei"/>
+                <a:ea typeface="Microsoft YaHei"/>
+                <a:cs typeface="Microsoft YaHei"/>
+              </a:rPr>
+              <a:t>同一编号对应多个对象：</a:t>
+            </a:r>
+          </a:p>
+          <a:p xmlns:a="http://schemas.openxmlformats.org/drawingml/2006/main">
+            <a:pPr algn="l">
+              <a:defRPr sz="1725" b="0">
+                <a:solidFill>
+                  <a:srgbClr val="17212B"/>
+                </a:solidFill>
+                <a:latin typeface="Microsoft YaHei"/>
+                <a:ea typeface="Microsoft YaHei"/>
+                <a:cs typeface="Microsoft YaHei"/>
+              </a:defRPr>
+            </a:pPr>
+            <a:r>
+              <a:rPr sz="1725" b="0">
+                <a:solidFill>
+                  <a:srgbClr val="17212B"/>
+                </a:solidFill>
+                <a:latin typeface="Microsoft YaHei"/>
+                <a:ea typeface="Microsoft YaHei"/>
+                <a:cs typeface="Microsoft YaHei"/>
+              </a:rPr>
+              <a:t>重复占用数达 225 万；辅助任务等权加入。</a:t>
+            </a:r>
+          </a:p>
+        </p:txBody>
+      </p:sp>
+      <p:sp>
+        <p:nvSpPr>
+          <p:cNvPr id="19" name="">
             <a:extLst xmlns:a="http://schemas.openxmlformats.org/drawingml/2006/main">
               <a:ext uri="{FF2B5EF4-FFF2-40B4-BE49-F238E27FC236}">
-                <a16:creationId xmlns:a16="http://schemas.microsoft.com/office/drawing/2014/main" id="{3EDB885A-0D4A-48EF-8F3E-C0F9A2F63070}"/>
+                <a16:creationId xmlns:a16="http://schemas.microsoft.com/office/drawing/2014/main" id="{FCCB363B-2700-44CA-8516-4D5570F1771C}"/>
               </a:ext>
             </a:extLst>
           </p:cNvPr>
@@ -3833,8 +5098,8 @@
         </p:nvSpPr>
         <p:spPr>
           <a:xfrm xmlns:a="http://schemas.openxmlformats.org/drawingml/2006/main">
-            <a:off x="7753350" y="2895600"/>
-            <a:ext cx="1143000" cy="285750"/>
+            <a:off x="571500" y="2781300"/>
+            <a:ext cx="4991100" cy="638175"/>
           </a:xfrm>
           <a:prstGeom xmlns:a="http://schemas.openxmlformats.org/drawingml/2006/main" prst="rect">
             <a:avLst/>
@@ -3846,40 +5111,63 @@
         </p:spPr>
         <p:txBody>
           <a:bodyPr xmlns:a="http://schemas.openxmlformats.org/drawingml/2006/main" anchor="ctr">
-            <a:normAutofit fontScale="94444"/>
+            <a:noAutofit/>
           </a:bodyPr>
           <a:lstStyle xmlns:a="http://schemas.openxmlformats.org/drawingml/2006/main"/>
           <a:p xmlns:a="http://schemas.openxmlformats.org/drawingml/2006/main">
             <a:pPr algn="l">
-              <a:defRPr sz="1350" b="1">
-                <a:solidFill>
-                  <a:srgbClr val="008A83"/>
-                </a:solidFill>
-                <a:latin typeface="Microsoft YaHei"/>
-                <a:ea typeface="Microsoft YaHei"/>
-                <a:cs typeface="Microsoft YaHei"/>
-              </a:defRPr>
-            </a:pPr>
-            <a:r>
-              <a:rPr sz="1350" b="1">
-                <a:solidFill>
-                  <a:srgbClr val="008A83"/>
-                </a:solidFill>
-                <a:latin typeface="Microsoft YaHei"/>
-                <a:ea typeface="Microsoft YaHei"/>
-                <a:cs typeface="Microsoft YaHei"/>
-              </a:rPr>
-              <a:t>修复</a:t>
-            </a:r>
-          </a:p>
-        </p:txBody>
-      </p:sp>
-      <p:sp>
-        <p:nvSpPr>
-          <p:cNvPr id="8" name="">
+              <a:defRPr sz="1650" b="0">
+                <a:solidFill>
+                  <a:srgbClr val="5C6670"/>
+                </a:solidFill>
+                <a:latin typeface="Microsoft YaHei"/>
+                <a:ea typeface="Microsoft YaHei"/>
+                <a:cs typeface="Microsoft YaHei"/>
+              </a:defRPr>
+            </a:pPr>
+            <a:r>
+              <a:rPr sz="1650" b="0">
+                <a:solidFill>
+                  <a:srgbClr val="5C6670"/>
+                </a:solidFill>
+                <a:latin typeface="Microsoft YaHei"/>
+                <a:ea typeface="Microsoft YaHei"/>
+                <a:cs typeface="Microsoft YaHei"/>
+              </a:rPr>
+              <a:t>总损失先降后升，怀疑影响了主任务；</a:t>
+            </a:r>
+          </a:p>
+          <a:p xmlns:a="http://schemas.openxmlformats.org/drawingml/2006/main">
+            <a:pPr algn="l">
+              <a:defRPr sz="1650" b="0">
+                <a:solidFill>
+                  <a:srgbClr val="5C6670"/>
+                </a:solidFill>
+                <a:latin typeface="Microsoft YaHei"/>
+                <a:ea typeface="Microsoft YaHei"/>
+                <a:cs typeface="Microsoft YaHei"/>
+              </a:defRPr>
+            </a:pPr>
+            <a:r>
+              <a:rPr sz="1650" b="0">
+                <a:solidFill>
+                  <a:srgbClr val="5C6670"/>
+                </a:solidFill>
+                <a:latin typeface="Microsoft YaHei"/>
+                <a:ea typeface="Microsoft YaHei"/>
+                <a:cs typeface="Microsoft YaHei"/>
+              </a:rPr>
+              <a:t>这些是排查线索，不能单独证明原因。</a:t>
+            </a:r>
+          </a:p>
+        </p:txBody>
+      </p:sp>
+      <p:sp>
+        <p:nvSpPr>
+          <p:cNvPr id="20" name="">
             <a:extLst xmlns:a="http://schemas.openxmlformats.org/drawingml/2006/main">
               <a:ext uri="{FF2B5EF4-FFF2-40B4-BE49-F238E27FC236}">
-                <a16:creationId xmlns:a16="http://schemas.microsoft.com/office/drawing/2014/main" id="{EE786577-F32B-4E94-A637-B333043A20C9}"/>
+                <a16:creationId xmlns:a16="http://schemas.microsoft.com/office/drawing/2014/main" id="{34928A1A-5C48-45F2-A229-DBEBF9C93E9A}"/>
               </a:ext>
             </a:extLst>
           </p:cNvPr>
@@ -3890,8 +5178,8 @@
         </p:nvSpPr>
         <p:spPr>
           <a:xfrm xmlns:a="http://schemas.openxmlformats.org/drawingml/2006/main">
-            <a:off x="7753350" y="3200400"/>
-            <a:ext cx="3476625" cy="1104900"/>
+            <a:off x="571500" y="3600450"/>
+            <a:ext cx="4857750" cy="342900"/>
           </a:xfrm>
           <a:prstGeom xmlns:a="http://schemas.openxmlformats.org/drawingml/2006/main" prst="rect">
             <a:avLst/>
@@ -3903,86 +5191,40 @@
         </p:spPr>
         <p:txBody>
           <a:bodyPr xmlns:a="http://schemas.openxmlformats.org/drawingml/2006/main" anchor="ctr">
-            <a:normAutofit fontScale="100000"/>
+            <a:noAutofit/>
           </a:bodyPr>
           <a:lstStyle xmlns:a="http://schemas.openxmlformats.org/drawingml/2006/main"/>
           <a:p xmlns:a="http://schemas.openxmlformats.org/drawingml/2006/main">
             <a:pPr algn="l">
-              <a:defRPr sz="1800" b="1">
-                <a:solidFill>
-                  <a:srgbClr val="17212B"/>
-                </a:solidFill>
-                <a:latin typeface="Microsoft YaHei"/>
-                <a:ea typeface="Microsoft YaHei"/>
-                <a:cs typeface="Microsoft YaHei"/>
-              </a:defRPr>
-            </a:pPr>
-            <a:r>
-              <a:rPr sz="1800" b="1">
-                <a:solidFill>
-                  <a:srgbClr val="17212B"/>
-                </a:solidFill>
-                <a:latin typeface="Microsoft YaHei"/>
-                <a:ea typeface="Microsoft YaHei"/>
-                <a:cs typeface="Microsoft YaHei"/>
-              </a:rPr>
-              <a:t>零碰撞映射</a:t>
-            </a:r>
-          </a:p>
-          <a:p xmlns:a="http://schemas.openxmlformats.org/drawingml/2006/main">
-            <a:pPr algn="l">
-              <a:defRPr sz="1800" b="1">
-                <a:solidFill>
-                  <a:srgbClr val="17212B"/>
-                </a:solidFill>
-                <a:latin typeface="Microsoft YaHei"/>
-                <a:ea typeface="Microsoft YaHei"/>
-                <a:cs typeface="Microsoft YaHei"/>
-              </a:defRPr>
-            </a:pPr>
-            <a:r>
-              <a:rPr sz="1800" b="1">
-                <a:solidFill>
-                  <a:srgbClr val="17212B"/>
-                </a:solidFill>
-                <a:latin typeface="Microsoft YaHei"/>
-                <a:ea typeface="Microsoft YaHei"/>
-                <a:cs typeface="Microsoft YaHei"/>
-              </a:rPr>
-              <a:t>首个 Epoch warm-up</a:t>
-            </a:r>
-          </a:p>
-          <a:p xmlns:a="http://schemas.openxmlformats.org/drawingml/2006/main">
-            <a:pPr algn="l">
-              <a:defRPr sz="1800" b="1">
-                <a:solidFill>
-                  <a:srgbClr val="17212B"/>
-                </a:solidFill>
-                <a:latin typeface="Microsoft YaHei"/>
-                <a:ea typeface="Microsoft YaHei"/>
-                <a:cs typeface="Microsoft YaHei"/>
-              </a:defRPr>
-            </a:pPr>
-            <a:r>
-              <a:rPr sz="1800" b="1">
-                <a:solidFill>
-                  <a:srgbClr val="17212B"/>
-                </a:solidFill>
-                <a:latin typeface="Microsoft YaHei"/>
-                <a:ea typeface="Microsoft YaHei"/>
-                <a:cs typeface="Microsoft YaHei"/>
-              </a:rPr>
-              <a:t>0.02 / 0.05 权重对照</a:t>
-            </a:r>
-          </a:p>
-        </p:txBody>
-      </p:sp>
-      <p:sp>
-        <p:nvSpPr>
-          <p:cNvPr id="9" name="">
+              <a:defRPr sz="1950" b="1">
+                <a:solidFill>
+                  <a:srgbClr val="008A83"/>
+                </a:solidFill>
+                <a:latin typeface="Microsoft YaHei"/>
+                <a:ea typeface="Microsoft YaHei"/>
+                <a:cs typeface="Microsoft YaHei"/>
+              </a:defRPr>
+            </a:pPr>
+            <a:r>
+              <a:rPr sz="1950" b="1">
+                <a:solidFill>
+                  <a:srgbClr val="008A83"/>
+                </a:solidFill>
+                <a:latin typeface="Microsoft YaHei"/>
+                <a:ea typeface="Microsoft YaHei"/>
+                <a:cs typeface="Microsoft YaHei"/>
+              </a:rPr>
+              <a:t>做了哪些修改？</a:t>
+            </a:r>
+          </a:p>
+        </p:txBody>
+      </p:sp>
+      <p:sp>
+        <p:nvSpPr>
+          <p:cNvPr id="21" name="">
             <a:extLst xmlns:a="http://schemas.openxmlformats.org/drawingml/2006/main">
               <a:ext uri="{FF2B5EF4-FFF2-40B4-BE49-F238E27FC236}">
-                <a16:creationId xmlns:a16="http://schemas.microsoft.com/office/drawing/2014/main" id="{1B18D81F-4475-4C54-BA21-BA52E36430E0}"/>
+                <a16:creationId xmlns:a16="http://schemas.microsoft.com/office/drawing/2014/main" id="{B3559824-C72A-44D3-AF26-C2AAF72F417E}"/>
               </a:ext>
             </a:extLst>
           </p:cNvPr>
@@ -3993,8 +5235,8 @@
         </p:nvSpPr>
         <p:spPr>
           <a:xfrm xmlns:a="http://schemas.openxmlformats.org/drawingml/2006/main">
-            <a:off x="7753350" y="4686300"/>
-            <a:ext cx="1428750" cy="285750"/>
+            <a:off x="571500" y="4038600"/>
+            <a:ext cx="4991100" cy="990600"/>
           </a:xfrm>
           <a:prstGeom xmlns:a="http://schemas.openxmlformats.org/drawingml/2006/main" prst="rect">
             <a:avLst/>
@@ -4006,40 +5248,86 @@
         </p:spPr>
         <p:txBody>
           <a:bodyPr xmlns:a="http://schemas.openxmlformats.org/drawingml/2006/main" anchor="ctr">
-            <a:normAutofit fontScale="94444"/>
+            <a:noAutofit/>
           </a:bodyPr>
           <a:lstStyle xmlns:a="http://schemas.openxmlformats.org/drawingml/2006/main"/>
           <a:p xmlns:a="http://schemas.openxmlformats.org/drawingml/2006/main">
             <a:pPr algn="l">
-              <a:defRPr sz="1350" b="1">
-                <a:solidFill>
-                  <a:srgbClr val="E7743A"/>
-                </a:solidFill>
-                <a:latin typeface="Microsoft YaHei"/>
-                <a:ea typeface="Microsoft YaHei"/>
-                <a:cs typeface="Microsoft YaHei"/>
-              </a:defRPr>
-            </a:pPr>
-            <a:r>
-              <a:rPr sz="1350" b="1">
-                <a:solidFill>
-                  <a:srgbClr val="E7743A"/>
-                </a:solidFill>
-                <a:latin typeface="Microsoft YaHei"/>
-                <a:ea typeface="Microsoft YaHei"/>
-                <a:cs typeface="Microsoft YaHei"/>
-              </a:rPr>
-              <a:t>结论边界</a:t>
-            </a:r>
-          </a:p>
-        </p:txBody>
-      </p:sp>
-      <p:sp>
-        <p:nvSpPr>
-          <p:cNvPr id="10" name="">
+              <a:defRPr sz="1725" b="0">
+                <a:solidFill>
+                  <a:srgbClr val="17212B"/>
+                </a:solidFill>
+                <a:latin typeface="Microsoft YaHei"/>
+                <a:ea typeface="Microsoft YaHei"/>
+                <a:cs typeface="Microsoft YaHei"/>
+              </a:defRPr>
+            </a:pPr>
+            <a:r>
+              <a:rPr sz="1725" b="0">
+                <a:solidFill>
+                  <a:srgbClr val="17212B"/>
+                </a:solidFill>
+                <a:latin typeface="Microsoft YaHei"/>
+                <a:ea typeface="Microsoft YaHei"/>
+                <a:cs typeface="Microsoft YaHei"/>
+              </a:rPr>
+              <a:t>重新分配编号，重复占用数降到 0。</a:t>
+            </a:r>
+          </a:p>
+          <a:p xmlns:a="http://schemas.openxmlformats.org/drawingml/2006/main">
+            <a:pPr algn="l">
+              <a:defRPr sz="1725" b="0">
+                <a:solidFill>
+                  <a:srgbClr val="17212B"/>
+                </a:solidFill>
+                <a:latin typeface="Microsoft YaHei"/>
+                <a:ea typeface="Microsoft YaHei"/>
+                <a:cs typeface="Microsoft YaHei"/>
+              </a:defRPr>
+            </a:pPr>
+            <a:r>
+              <a:rPr sz="1725" b="0">
+                <a:solidFill>
+                  <a:srgbClr val="17212B"/>
+                </a:solidFill>
+                <a:latin typeface="Microsoft YaHei"/>
+                <a:ea typeface="Microsoft YaHei"/>
+                <a:cs typeface="Microsoft YaHei"/>
+              </a:rPr>
+              <a:t>辅助任务权重调为 0.02 / 0.05。</a:t>
+            </a:r>
+          </a:p>
+          <a:p xmlns:a="http://schemas.openxmlformats.org/drawingml/2006/main">
+            <a:pPr algn="l">
+              <a:defRPr sz="1725" b="0">
+                <a:solidFill>
+                  <a:srgbClr val="17212B"/>
+                </a:solidFill>
+                <a:latin typeface="Microsoft YaHei"/>
+                <a:ea typeface="Microsoft YaHei"/>
+                <a:cs typeface="Microsoft YaHei"/>
+              </a:defRPr>
+            </a:pPr>
+            <a:r>
+              <a:rPr sz="1725" b="0">
+                <a:solidFill>
+                  <a:srgbClr val="17212B"/>
+                </a:solidFill>
+                <a:latin typeface="Microsoft YaHei"/>
+                <a:ea typeface="Microsoft YaHei"/>
+                <a:cs typeface="Microsoft YaHei"/>
+              </a:rPr>
+              <a:t>第一轮从 0 逐渐增加到设定权重。</a:t>
+            </a:r>
+          </a:p>
+        </p:txBody>
+      </p:sp>
+      <p:sp>
+        <p:nvSpPr>
+          <p:cNvPr id="22" name="">
             <a:extLst xmlns:a="http://schemas.openxmlformats.org/drawingml/2006/main">
               <a:ext uri="{FF2B5EF4-FFF2-40B4-BE49-F238E27FC236}">
-                <a16:creationId xmlns:a16="http://schemas.microsoft.com/office/drawing/2014/main" id="{D6AA688A-413E-4697-8186-5CFBBA30B8A4}"/>
+                <a16:creationId xmlns:a16="http://schemas.microsoft.com/office/drawing/2014/main" id="{335371FB-F3A0-480B-8C4C-6A8733A5F36C}"/>
               </a:ext>
             </a:extLst>
           </p:cNvPr>
@@ -4050,8 +5338,8 @@
         </p:nvSpPr>
         <p:spPr>
           <a:xfrm xmlns:a="http://schemas.openxmlformats.org/drawingml/2006/main">
-            <a:off x="7753350" y="4991100"/>
-            <a:ext cx="3476625" cy="952500"/>
+            <a:off x="571500" y="5276850"/>
+            <a:ext cx="4857750" cy="342900"/>
           </a:xfrm>
           <a:prstGeom xmlns:a="http://schemas.openxmlformats.org/drawingml/2006/main" prst="rect">
             <a:avLst/>
@@ -4063,86 +5351,40 @@
         </p:spPr>
         <p:txBody>
           <a:bodyPr xmlns:a="http://schemas.openxmlformats.org/drawingml/2006/main" anchor="ctr">
-            <a:normAutofit fontScale="100000"/>
+            <a:noAutofit/>
           </a:bodyPr>
           <a:lstStyle xmlns:a="http://schemas.openxmlformats.org/drawingml/2006/main"/>
           <a:p xmlns:a="http://schemas.openxmlformats.org/drawingml/2006/main">
             <a:pPr algn="l">
-              <a:defRPr sz="1725" b="1">
-                <a:solidFill>
-                  <a:srgbClr val="17212B"/>
-                </a:solidFill>
-                <a:latin typeface="Microsoft YaHei"/>
-                <a:ea typeface="Microsoft YaHei"/>
-                <a:cs typeface="Microsoft YaHei"/>
-              </a:defRPr>
-            </a:pPr>
-            <a:r>
-              <a:rPr sz="1725" b="1">
-                <a:solidFill>
-                  <a:srgbClr val="17212B"/>
-                </a:solidFill>
-                <a:latin typeface="Microsoft YaHei"/>
-                <a:ea typeface="Microsoft YaHei"/>
-                <a:cs typeface="Microsoft YaHei"/>
-              </a:rPr>
-              <a:t>-5.87% 修复到统计持平</a:t>
-            </a:r>
-          </a:p>
-          <a:p xmlns:a="http://schemas.openxmlformats.org/drawingml/2006/main">
-            <a:pPr algn="l">
-              <a:defRPr sz="1725" b="1">
-                <a:solidFill>
-                  <a:srgbClr val="17212B"/>
-                </a:solidFill>
-                <a:latin typeface="Microsoft YaHei"/>
-                <a:ea typeface="Microsoft YaHei"/>
-                <a:cs typeface="Microsoft YaHei"/>
-              </a:defRPr>
-            </a:pPr>
-            <a:r>
-              <a:rPr sz="1725" b="1">
-                <a:solidFill>
-                  <a:srgbClr val="17212B"/>
-                </a:solidFill>
-                <a:latin typeface="Microsoft YaHei"/>
-                <a:ea typeface="Microsoft YaHei"/>
-                <a:cs typeface="Microsoft YaHei"/>
-              </a:rPr>
-              <a:t>0.02 对控制组仅 +0.14%</a:t>
-            </a:r>
-          </a:p>
-          <a:p xmlns:a="http://schemas.openxmlformats.org/drawingml/2006/main">
-            <a:pPr algn="l">
-              <a:defRPr sz="1725" b="1">
-                <a:solidFill>
-                  <a:srgbClr val="17212B"/>
-                </a:solidFill>
-                <a:latin typeface="Microsoft YaHei"/>
-                <a:ea typeface="Microsoft YaHei"/>
-                <a:cs typeface="Microsoft YaHei"/>
-              </a:defRPr>
-            </a:pPr>
-            <a:r>
-              <a:rPr sz="1725" b="1">
-                <a:solidFill>
-                  <a:srgbClr val="17212B"/>
-                </a:solidFill>
-                <a:latin typeface="Microsoft YaHei"/>
-                <a:ea typeface="Microsoft YaHei"/>
-                <a:cs typeface="Microsoft YaHei"/>
-              </a:rPr>
-              <a:t>配对区间跨 0</a:t>
-            </a:r>
-          </a:p>
-        </p:txBody>
-      </p:sp>
-      <p:sp>
-        <p:nvSpPr>
-          <p:cNvPr id="11" name="">
+              <a:defRPr sz="1950" b="1">
+                <a:solidFill>
+                  <a:srgbClr val="008A83"/>
+                </a:solidFill>
+                <a:latin typeface="Microsoft YaHei"/>
+                <a:ea typeface="Microsoft YaHei"/>
+                <a:cs typeface="Microsoft YaHei"/>
+              </a:defRPr>
+            </a:pPr>
+            <a:r>
+              <a:rPr sz="1950" b="1">
+                <a:solidFill>
+                  <a:srgbClr val="008A83"/>
+                </a:solidFill>
+                <a:latin typeface="Microsoft YaHei"/>
+                <a:ea typeface="Microsoft YaHei"/>
+                <a:cs typeface="Microsoft YaHei"/>
+              </a:rPr>
+              <a:t>修复后的结论</a:t>
+            </a:r>
+          </a:p>
+        </p:txBody>
+      </p:sp>
+      <p:sp>
+        <p:nvSpPr>
+          <p:cNvPr id="23" name="">
             <a:extLst xmlns:a="http://schemas.openxmlformats.org/drawingml/2006/main">
               <a:ext uri="{FF2B5EF4-FFF2-40B4-BE49-F238E27FC236}">
-                <a16:creationId xmlns:a16="http://schemas.microsoft.com/office/drawing/2014/main" id="{0C4C7B85-FBD9-42ED-A8D7-867691E4B3D2}"/>
+                <a16:creationId xmlns:a16="http://schemas.microsoft.com/office/drawing/2014/main" id="{90E3204F-2188-4A93-B8C7-19EAA71BD4F4}"/>
               </a:ext>
             </a:extLst>
           </p:cNvPr>
@@ -4153,8 +5395,8 @@
         </p:nvSpPr>
         <p:spPr>
           <a:xfrm xmlns:a="http://schemas.openxmlformats.org/drawingml/2006/main">
-            <a:off x="628650" y="6191250"/>
-            <a:ext cx="10572750" cy="361950"/>
+            <a:off x="571500" y="5695950"/>
+            <a:ext cx="5086350" cy="590550"/>
           </a:xfrm>
           <a:prstGeom xmlns:a="http://schemas.openxmlformats.org/drawingml/2006/main" prst="rect">
             <a:avLst/>
@@ -4166,11 +5408,342 @@
         </p:spPr>
         <p:txBody>
           <a:bodyPr xmlns:a="http://schemas.openxmlformats.org/drawingml/2006/main" anchor="ctr">
-            <a:normAutofit fontScale="100000"/>
+            <a:noAutofit/>
           </a:bodyPr>
           <a:lstStyle xmlns:a="http://schemas.openxmlformats.org/drawingml/2006/main"/>
           <a:p xmlns:a="http://schemas.openxmlformats.org/drawingml/2006/main">
             <a:pPr algn="l">
+              <a:defRPr sz="1650" b="1">
+                <a:solidFill>
+                  <a:srgbClr val="17212B"/>
+                </a:solidFill>
+                <a:latin typeface="Microsoft YaHei"/>
+                <a:ea typeface="Microsoft YaHei"/>
+                <a:cs typeface="Microsoft YaHei"/>
+              </a:defRPr>
+            </a:pPr>
+            <a:r>
+              <a:rPr sz="1650" b="1">
+                <a:solidFill>
+                  <a:srgbClr val="17212B"/>
+                </a:solidFill>
+                <a:latin typeface="Microsoft YaHei"/>
+                <a:ea typeface="Microsoft YaHei"/>
+                <a:cs typeface="Microsoft YaHei"/>
+              </a:rPr>
+              <a:t>得分接近无 SID；0.02 的差异区间含 0，</a:t>
+            </a:r>
+          </a:p>
+          <a:p xmlns:a="http://schemas.openxmlformats.org/drawingml/2006/main">
+            <a:pPr algn="l">
+              <a:defRPr sz="1650" b="1">
+                <a:solidFill>
+                  <a:srgbClr val="17212B"/>
+                </a:solidFill>
+                <a:latin typeface="Microsoft YaHei"/>
+                <a:ea typeface="Microsoft YaHei"/>
+                <a:cs typeface="Microsoft YaHei"/>
+              </a:defRPr>
+            </a:pPr>
+            <a:r>
+              <a:rPr sz="1650" b="1">
+                <a:solidFill>
+                  <a:srgbClr val="17212B"/>
+                </a:solidFill>
+                <a:latin typeface="Microsoft YaHei"/>
+                <a:ea typeface="Microsoft YaHei"/>
+                <a:cs typeface="Microsoft YaHei"/>
+              </a:rPr>
+              <a:t>尚未证明稳定提升。</a:t>
+            </a:r>
+          </a:p>
+        </p:txBody>
+      </p:sp>
+      <p:sp>
+        <p:nvSpPr>
+          <p:cNvPr id="24" name="">
+            <a:extLst xmlns:a="http://schemas.openxmlformats.org/drawingml/2006/main">
+              <a:ext uri="{FF2B5EF4-FFF2-40B4-BE49-F238E27FC236}">
+                <a16:creationId xmlns:a16="http://schemas.microsoft.com/office/drawing/2014/main" id="{A497CAF3-F5E8-40BB-B059-ECE134160E66}"/>
+              </a:ext>
+            </a:extLst>
+          </p:cNvPr>
+          <p:cNvSpPr>
+            <a:spLocks xmlns:a="http://schemas.openxmlformats.org/drawingml/2006/main" noGrp="1"/>
+          </p:cNvSpPr>
+          <p:nvPr/>
+        </p:nvSpPr>
+        <p:spPr>
+          <a:xfrm xmlns:a="http://schemas.openxmlformats.org/drawingml/2006/main">
+            <a:off x="5762625" y="1543050"/>
+            <a:ext cx="5905500" cy="333375"/>
+          </a:xfrm>
+          <a:prstGeom xmlns:a="http://schemas.openxmlformats.org/drawingml/2006/main" prst="rect">
+            <a:avLst/>
+          </a:prstGeom>
+          <a:noFill xmlns:a="http://schemas.openxmlformats.org/drawingml/2006/main"/>
+          <a:ln xmlns:a="http://schemas.openxmlformats.org/drawingml/2006/main" w="0">
+            <a:noFill/>
+          </a:ln>
+        </p:spPr>
+        <p:txBody>
+          <a:bodyPr xmlns:a="http://schemas.openxmlformats.org/drawingml/2006/main" anchor="ctr">
+            <a:noAutofit/>
+          </a:bodyPr>
+          <a:lstStyle xmlns:a="http://schemas.openxmlformats.org/drawingml/2006/main"/>
+          <a:p xmlns:a="http://schemas.openxmlformats.org/drawingml/2006/main">
+            <a:pPr algn="l">
+              <a:defRPr sz="1800" b="1">
+                <a:solidFill>
+                  <a:srgbClr val="008A83"/>
+                </a:solidFill>
+                <a:latin typeface="Microsoft YaHei"/>
+                <a:ea typeface="Microsoft YaHei"/>
+                <a:cs typeface="Microsoft YaHei"/>
+              </a:defRPr>
+            </a:pPr>
+            <a:r>
+              <a:rPr sz="1800" b="1">
+                <a:solidFill>
+                  <a:srgbClr val="008A83"/>
+                </a:solidFill>
+                <a:latin typeface="Microsoft YaHei"/>
+                <a:ea typeface="Microsoft YaHei"/>
+                <a:cs typeface="Microsoft YaHei"/>
+              </a:rPr>
+              <a:t>综合分（纵轴从 0.075 起）</a:t>
+            </a:r>
+          </a:p>
+        </p:txBody>
+      </p:sp>
+      <p:sp>
+        <p:nvSpPr>
+          <p:cNvPr id="25" name="">
+            <a:extLst xmlns:a="http://schemas.openxmlformats.org/drawingml/2006/main">
+              <a:ext uri="{FF2B5EF4-FFF2-40B4-BE49-F238E27FC236}">
+                <a16:creationId xmlns:a16="http://schemas.microsoft.com/office/drawing/2014/main" id="{DA8CD9B8-69A8-4115-9D17-1599B443B998}"/>
+              </a:ext>
+            </a:extLst>
+          </p:cNvPr>
+          <p:cNvSpPr>
+            <a:spLocks xmlns:a="http://schemas.openxmlformats.org/drawingml/2006/main" noGrp="1"/>
+          </p:cNvSpPr>
+          <p:nvPr/>
+        </p:nvSpPr>
+        <p:spPr>
+          <a:xfrm xmlns:a="http://schemas.openxmlformats.org/drawingml/2006/main">
+            <a:off x="5762625" y="4895850"/>
+            <a:ext cx="5905500" cy="314325"/>
+          </a:xfrm>
+          <a:prstGeom xmlns:a="http://schemas.openxmlformats.org/drawingml/2006/main" prst="rect">
+            <a:avLst/>
+          </a:prstGeom>
+          <a:noFill xmlns:a="http://schemas.openxmlformats.org/drawingml/2006/main"/>
+          <a:ln xmlns:a="http://schemas.openxmlformats.org/drawingml/2006/main" w="0">
+            <a:noFill/>
+          </a:ln>
+        </p:spPr>
+        <p:txBody>
+          <a:bodyPr xmlns:a="http://schemas.openxmlformats.org/drawingml/2006/main" anchor="ctr">
+            <a:noAutofit/>
+          </a:bodyPr>
+          <a:lstStyle xmlns:a="http://schemas.openxmlformats.org/drawingml/2006/main"/>
+          <a:p xmlns:a="http://schemas.openxmlformats.org/drawingml/2006/main">
+            <a:pPr algn="l">
+              <a:defRPr sz="1725" b="1">
+                <a:solidFill>
+                  <a:srgbClr val="17212B"/>
+                </a:solidFill>
+                <a:latin typeface="Microsoft YaHei"/>
+                <a:ea typeface="Microsoft YaHei"/>
+                <a:cs typeface="Microsoft YaHei"/>
+              </a:defRPr>
+            </a:pPr>
+            <a:r>
+              <a:rPr sz="1725" b="1">
+                <a:solidFill>
+                  <a:srgbClr val="17212B"/>
+                </a:solidFill>
+                <a:latin typeface="Microsoft YaHei"/>
+                <a:ea typeface="Microsoft YaHei"/>
+                <a:cs typeface="Microsoft YaHei"/>
+              </a:rPr>
+              <a:t>相对无 SID：</a:t>
+            </a:r>
+          </a:p>
+        </p:txBody>
+      </p:sp>
+      <p:sp>
+        <p:nvSpPr>
+          <p:cNvPr id="26" name="">
+            <a:extLst xmlns:a="http://schemas.openxmlformats.org/drawingml/2006/main">
+              <a:ext uri="{FF2B5EF4-FFF2-40B4-BE49-F238E27FC236}">
+                <a16:creationId xmlns:a16="http://schemas.microsoft.com/office/drawing/2014/main" id="{3D38D697-F0AA-4533-A452-458AEFE9FDBF}"/>
+              </a:ext>
+            </a:extLst>
+          </p:cNvPr>
+          <p:cNvSpPr>
+            <a:spLocks xmlns:a="http://schemas.openxmlformats.org/drawingml/2006/main" noGrp="1"/>
+          </p:cNvSpPr>
+          <p:nvPr/>
+        </p:nvSpPr>
+        <p:spPr>
+          <a:xfrm xmlns:a="http://schemas.openxmlformats.org/drawingml/2006/main">
+            <a:off x="5762625" y="5286375"/>
+            <a:ext cx="5905500" cy="333375"/>
+          </a:xfrm>
+          <a:prstGeom xmlns:a="http://schemas.openxmlformats.org/drawingml/2006/main" prst="rect">
+            <a:avLst/>
+          </a:prstGeom>
+          <a:noFill xmlns:a="http://schemas.openxmlformats.org/drawingml/2006/main"/>
+          <a:ln xmlns:a="http://schemas.openxmlformats.org/drawingml/2006/main" w="0">
+            <a:noFill/>
+          </a:ln>
+        </p:spPr>
+        <p:txBody>
+          <a:bodyPr xmlns:a="http://schemas.openxmlformats.org/drawingml/2006/main" anchor="ctr">
+            <a:noAutofit/>
+          </a:bodyPr>
+          <a:lstStyle xmlns:a="http://schemas.openxmlformats.org/drawingml/2006/main"/>
+          <a:p xmlns:a="http://schemas.openxmlformats.org/drawingml/2006/main">
+            <a:pPr algn="l">
+              <a:defRPr sz="1875" b="1">
+                <a:solidFill>
+                  <a:srgbClr val="E7743A"/>
+                </a:solidFill>
+                <a:latin typeface="Microsoft YaHei"/>
+                <a:ea typeface="Microsoft YaHei"/>
+                <a:cs typeface="Microsoft YaHei"/>
+              </a:defRPr>
+            </a:pPr>
+            <a:r>
+              <a:rPr sz="1875" b="1">
+                <a:solidFill>
+                  <a:srgbClr val="E7743A"/>
+                </a:solidFill>
+                <a:latin typeface="Microsoft YaHei"/>
+                <a:ea typeface="Microsoft YaHei"/>
+                <a:cs typeface="Microsoft YaHei"/>
+              </a:rPr>
+              <a:t>旧版 −5.87%  →  0.02 版 +0.14%</a:t>
+            </a:r>
+          </a:p>
+        </p:txBody>
+      </p:sp>
+      <p:sp>
+        <p:nvSpPr>
+          <p:cNvPr id="27" name="">
+            <a:extLst xmlns:a="http://schemas.openxmlformats.org/drawingml/2006/main">
+              <a:ext uri="{FF2B5EF4-FFF2-40B4-BE49-F238E27FC236}">
+                <a16:creationId xmlns:a16="http://schemas.microsoft.com/office/drawing/2014/main" id="{FA755CF6-2675-4071-9A33-A15C41434FB0}"/>
+              </a:ext>
+            </a:extLst>
+          </p:cNvPr>
+          <p:cNvSpPr>
+            <a:spLocks xmlns:a="http://schemas.openxmlformats.org/drawingml/2006/main" noGrp="1"/>
+          </p:cNvSpPr>
+          <p:nvPr/>
+        </p:nvSpPr>
+        <p:spPr>
+          <a:xfrm xmlns:a="http://schemas.openxmlformats.org/drawingml/2006/main">
+            <a:off x="5762625" y="5734050"/>
+            <a:ext cx="5905500" cy="590550"/>
+          </a:xfrm>
+          <a:prstGeom xmlns:a="http://schemas.openxmlformats.org/drawingml/2006/main" prst="rect">
+            <a:avLst/>
+          </a:prstGeom>
+          <a:noFill xmlns:a="http://schemas.openxmlformats.org/drawingml/2006/main"/>
+          <a:ln xmlns:a="http://schemas.openxmlformats.org/drawingml/2006/main" w="0">
+            <a:noFill/>
+          </a:ln>
+        </p:spPr>
+        <p:txBody>
+          <a:bodyPr xmlns:a="http://schemas.openxmlformats.org/drawingml/2006/main" anchor="ctr">
+            <a:noAutofit/>
+          </a:bodyPr>
+          <a:lstStyle xmlns:a="http://schemas.openxmlformats.org/drawingml/2006/main"/>
+          <a:p xmlns:a="http://schemas.openxmlformats.org/drawingml/2006/main">
+            <a:pPr algn="l">
+              <a:defRPr sz="1650" b="0">
+                <a:solidFill>
+                  <a:srgbClr val="5C6670"/>
+                </a:solidFill>
+                <a:latin typeface="Microsoft YaHei"/>
+                <a:ea typeface="Microsoft YaHei"/>
+                <a:cs typeface="Microsoft YaHei"/>
+              </a:defRPr>
+            </a:pPr>
+            <a:r>
+              <a:rPr sz="1650" b="0">
+                <a:solidFill>
+                  <a:srgbClr val="5C6670"/>
+                </a:solidFill>
+                <a:latin typeface="Microsoft YaHei"/>
+                <a:ea typeface="Microsoft YaHei"/>
+                <a:cs typeface="Microsoft YaHei"/>
+              </a:rPr>
+              <a:t>0.05 版为 −0.71%。本轮同时修改多项，</a:t>
+            </a:r>
+          </a:p>
+          <a:p xmlns:a="http://schemas.openxmlformats.org/drawingml/2006/main">
+            <a:pPr algn="l">
+              <a:defRPr sz="1650" b="0">
+                <a:solidFill>
+                  <a:srgbClr val="5C6670"/>
+                </a:solidFill>
+                <a:latin typeface="Microsoft YaHei"/>
+                <a:ea typeface="Microsoft YaHei"/>
+                <a:cs typeface="Microsoft YaHei"/>
+              </a:defRPr>
+            </a:pPr>
+            <a:r>
+              <a:rPr sz="1650" b="0">
+                <a:solidFill>
+                  <a:srgbClr val="5C6670"/>
+                </a:solidFill>
+                <a:latin typeface="Microsoft YaHei"/>
+                <a:ea typeface="Microsoft YaHei"/>
+                <a:cs typeface="Microsoft YaHei"/>
+              </a:rPr>
+              <a:t>无法把变化单独归因于编号、权重或预热。</a:t>
+            </a:r>
+          </a:p>
+        </p:txBody>
+      </p:sp>
+      <p:sp>
+        <p:nvSpPr>
+          <p:cNvPr id="28" name="">
+            <a:extLst xmlns:a="http://schemas.openxmlformats.org/drawingml/2006/main">
+              <a:ext uri="{FF2B5EF4-FFF2-40B4-BE49-F238E27FC236}">
+                <a16:creationId xmlns:a16="http://schemas.microsoft.com/office/drawing/2014/main" id="{9E031F71-DBF7-4F36-8D75-49895BD01A25}"/>
+              </a:ext>
+            </a:extLst>
+          </p:cNvPr>
+          <p:cNvSpPr>
+            <a:spLocks xmlns:a="http://schemas.openxmlformats.org/drawingml/2006/main" noGrp="1"/>
+          </p:cNvSpPr>
+          <p:nvPr/>
+        </p:nvSpPr>
+        <p:spPr>
+          <a:xfrm xmlns:a="http://schemas.openxmlformats.org/drawingml/2006/main">
+            <a:off x="571500" y="6486525"/>
+            <a:ext cx="11049000" cy="228600"/>
+          </a:xfrm>
+          <a:prstGeom xmlns:a="http://schemas.openxmlformats.org/drawingml/2006/main" prst="rect">
+            <a:avLst/>
+          </a:prstGeom>
+          <a:noFill xmlns:a="http://schemas.openxmlformats.org/drawingml/2006/main"/>
+          <a:ln xmlns:a="http://schemas.openxmlformats.org/drawingml/2006/main" w="0">
+            <a:noFill/>
+          </a:ln>
+        </p:spPr>
+        <p:txBody>
+          <a:bodyPr xmlns:a="http://schemas.openxmlformats.org/drawingml/2006/main" anchor="ctr">
+            <a:noAutofit/>
+          </a:bodyPr>
+          <a:lstStyle xmlns:a="http://schemas.openxmlformats.org/drawingml/2006/main"/>
+          <a:p xmlns:a="http://schemas.openxmlformats.org/drawingml/2006/main">
+            <a:pPr algn="l">
               <a:defRPr sz="1125" b="0">
                 <a:solidFill>
                   <a:srgbClr val="5C6670"/>
@@ -4189,7 +5762,7 @@
                 <a:ea typeface="Microsoft YaHei"/>
                 <a:cs typeface="Microsoft YaHei"/>
               </a:rPr>
-              <a:t>对齐协议中，SID 与掩码相对控制组的区间同样跨 0；协议变化不计作模型提升。</a:t>
+              <a:t>评测规则也会改分数：同一模型换候选 / 历史过滤后 +2.61%，这是规则变化，不是模型提升。</a:t>
             </a:r>
           </a:p>
         </p:txBody>

</xml_diff>